<commit_message>
docs: simplify checkpoint presentation
</commit_message>
<xml_diff>
--- a/docs/submission/vapi-trust-network-checkpoint-2.pptx
+++ b/docs/submission/vapi-trust-network-checkpoint-2.pptx
@@ -2,17 +2,17 @@
 <file path=ppt/presentation.xml><?xml version="1.0" encoding="utf-8"?>
 <p:presentation xmlns:p="http://schemas.openxmlformats.org/presentationml/2006/main">
   <p:sldMasterIdLst>
-    <p:sldMasterId xmlns:r="http://schemas.openxmlformats.org/officeDocument/2006/relationships" id="2147483648" r:id="R38246be7265f4087"/>
+    <p:sldMasterId xmlns:r="http://schemas.openxmlformats.org/officeDocument/2006/relationships" id="2147483648" r:id="Ra60a40cfb6b84f62"/>
   </p:sldMasterIdLst>
   <p:notesMasterIdLst>
-    <p:notesMasterId xmlns:r="http://schemas.openxmlformats.org/officeDocument/2006/relationships" r:id="R96eb7d3ab3864e75"/>
+    <p:notesMasterId xmlns:r="http://schemas.openxmlformats.org/officeDocument/2006/relationships" r:id="R68d94e852652406e"/>
   </p:notesMasterIdLst>
   <p:sldIdLst>
-    <p:sldId xmlns:r="http://schemas.openxmlformats.org/officeDocument/2006/relationships" id="256" r:id="R88a56826aa5c4685"/>
-    <p:sldId xmlns:r="http://schemas.openxmlformats.org/officeDocument/2006/relationships" id="257" r:id="Rab117f105ddd44e0"/>
-    <p:sldId xmlns:r="http://schemas.openxmlformats.org/officeDocument/2006/relationships" id="258" r:id="R4d1cc6e715de4ccb"/>
-    <p:sldId xmlns:r="http://schemas.openxmlformats.org/officeDocument/2006/relationships" id="259" r:id="R257f3142eba440f4"/>
-    <p:sldId xmlns:r="http://schemas.openxmlformats.org/officeDocument/2006/relationships" id="260" r:id="R77505131868a442d"/>
+    <p:sldId xmlns:r="http://schemas.openxmlformats.org/officeDocument/2006/relationships" id="256" r:id="R403a21f5558e4806"/>
+    <p:sldId xmlns:r="http://schemas.openxmlformats.org/officeDocument/2006/relationships" id="257" r:id="R23c95ebbe261415b"/>
+    <p:sldId xmlns:r="http://schemas.openxmlformats.org/officeDocument/2006/relationships" id="258" r:id="R83365e0d76a64ecb"/>
+    <p:sldId xmlns:r="http://schemas.openxmlformats.org/officeDocument/2006/relationships" id="259" r:id="R3da86574ea2442f0"/>
+    <p:sldId xmlns:r="http://schemas.openxmlformats.org/officeDocument/2006/relationships" id="260" r:id="R2e417e0f411d44cb"/>
   </p:sldIdLst>
   <p:sldSz cx="12192000" cy="6858000"/>
   <p:notesSz cx="6858000" cy="9144000"/>
@@ -909,7 +909,7 @@
   </p:cSld>
   <p:clrMap bg1="lt1" tx1="dk1" bg2="lt2" tx2="dk2" accent1="accent1" accent2="accent2" accent3="accent3" accent4="accent4" accent5="accent5" accent6="accent6" hlink="hlink" folHlink="folHlink"/>
   <p:sldLayoutIdLst>
-    <p:sldLayoutId xmlns:r="http://schemas.openxmlformats.org/officeDocument/2006/relationships" id="2147483649" r:id="Rb53bfe96becb4df1"/>
+    <p:sldLayoutId xmlns:r="http://schemas.openxmlformats.org/officeDocument/2006/relationships" id="2147483649" r:id="Rc8771f54f5cc4e8d"/>
   </p:sldLayoutIdLst>
   <p:txStyles>
     <p:titleStyle>
@@ -1457,14 +1457,14 @@
       </p:grpSpPr>
       <p:pic>
         <p:nvPicPr>
-          <p:cNvPr id="11" name=""/>
+          <p:cNvPr id="10" name=""/>
           <p:cNvPicPr>
             <a:picLocks xmlns:a="http://schemas.openxmlformats.org/drawingml/2006/main" noChangeAspect="1"/>
           </p:cNvPicPr>
           <p:nvPr/>
         </p:nvPicPr>
         <p:blipFill>
-          <a:blip xmlns:r="http://schemas.openxmlformats.org/officeDocument/2006/relationships" xmlns:a="http://schemas.openxmlformats.org/drawingml/2006/main" r:embed="Rb82c735e74b8434c"/>
+          <a:blip xmlns:r="http://schemas.openxmlformats.org/officeDocument/2006/relationships" xmlns:a="http://schemas.openxmlformats.org/drawingml/2006/main" r:embed="R471a2857b5214dbf"/>
           <a:stretch xmlns:a="http://schemas.openxmlformats.org/drawingml/2006/main"/>
         </p:blipFill>
         <p:spPr>
@@ -1482,7 +1482,7 @@
           <p:cNvPr id="2" name="">
             <a:extLst xmlns:a="http://schemas.openxmlformats.org/drawingml/2006/main">
               <a:ext uri="{FF2B5EF4-FFF2-40B4-BE49-F238E27FC236}">
-                <a16:creationId xmlns:a16="http://schemas.microsoft.com/office/drawing/2014/main" id="{D5B527B5-9FBD-4F01-AC6E-E0899B9C9B1F}"/>
+                <a16:creationId xmlns:a16="http://schemas.microsoft.com/office/drawing/2014/main" id="{5FB23C82-DA13-4BE2-8F29-8F7F51A963CB}"/>
               </a:ext>
             </a:extLst>
           </p:cNvPr>
@@ -1513,7 +1513,7 @@
           <p:cNvPr id="3" name="">
             <a:extLst xmlns:a="http://schemas.openxmlformats.org/drawingml/2006/main">
               <a:ext uri="{FF2B5EF4-FFF2-40B4-BE49-F238E27FC236}">
-                <a16:creationId xmlns:a16="http://schemas.microsoft.com/office/drawing/2014/main" id="{DEC88900-9B08-48ED-AD61-848C14CAE2F1}"/>
+                <a16:creationId xmlns:a16="http://schemas.microsoft.com/office/drawing/2014/main" id="{DE27DE9D-33E5-4131-B8DE-4BE930811B1D}"/>
               </a:ext>
             </a:extLst>
           </p:cNvPr>
@@ -1544,7 +1544,7 @@
           <p:cNvPr id="4" name="deck-title">
             <a:extLst xmlns:a="http://schemas.openxmlformats.org/drawingml/2006/main">
               <a:ext uri="{FF2B5EF4-FFF2-40B4-BE49-F238E27FC236}">
-                <a16:creationId xmlns:a16="http://schemas.microsoft.com/office/drawing/2014/main" id="{035D2C78-1E41-4787-8515-7FC62A2BAFC7}"/>
+                <a16:creationId xmlns:a16="http://schemas.microsoft.com/office/drawing/2014/main" id="{EC44D703-34A8-4230-B5FA-85099DC73FDB}"/>
               </a:ext>
             </a:extLst>
           </p:cNvPr>
@@ -1602,7 +1602,7 @@
           <p:cNvPr id="5" name="deck-subtitle">
             <a:extLst xmlns:a="http://schemas.openxmlformats.org/drawingml/2006/main">
               <a:ext uri="{FF2B5EF4-FFF2-40B4-BE49-F238E27FC236}">
-                <a16:creationId xmlns:a16="http://schemas.microsoft.com/office/drawing/2014/main" id="{D9D29C4C-F4D6-4A7B-A0AF-8CCE85BDE546}"/>
+                <a16:creationId xmlns:a16="http://schemas.microsoft.com/office/drawing/2014/main" id="{D05F882E-E363-4AAA-A454-B12B778836D0}"/>
               </a:ext>
             </a:extLst>
           </p:cNvPr>
@@ -1660,7 +1660,7 @@
           <p:cNvPr id="6" name="">
             <a:extLst xmlns:a="http://schemas.openxmlformats.org/drawingml/2006/main">
               <a:ext uri="{FF2B5EF4-FFF2-40B4-BE49-F238E27FC236}">
-                <a16:creationId xmlns:a16="http://schemas.microsoft.com/office/drawing/2014/main" id="{F6BDABCD-4FD2-4974-B7C0-B1E8609D33E3}"/>
+                <a16:creationId xmlns:a16="http://schemas.microsoft.com/office/drawing/2014/main" id="{0F7F75F5-E9A9-49BE-A1DE-58F390EDC5F3}"/>
               </a:ext>
             </a:extLst>
           </p:cNvPr>
@@ -1691,7 +1691,7 @@
           <p:cNvPr id="7" name="">
             <a:extLst xmlns:a="http://schemas.openxmlformats.org/drawingml/2006/main">
               <a:ext uri="{FF2B5EF4-FFF2-40B4-BE49-F238E27FC236}">
-                <a16:creationId xmlns:a16="http://schemas.microsoft.com/office/drawing/2014/main" id="{F502C95F-6D27-473F-9FC4-8914EB62D85F}"/>
+                <a16:creationId xmlns:a16="http://schemas.microsoft.com/office/drawing/2014/main" id="{9A9DA3DF-65B2-4AF7-BDEF-903F6BD1102A}"/>
               </a:ext>
             </a:extLst>
           </p:cNvPr>
@@ -1722,7 +1722,7 @@
           <p:cNvPr id="8" name="">
             <a:extLst xmlns:a="http://schemas.openxmlformats.org/drawingml/2006/main">
               <a:ext uri="{FF2B5EF4-FFF2-40B4-BE49-F238E27FC236}">
-                <a16:creationId xmlns:a16="http://schemas.microsoft.com/office/drawing/2014/main" id="{E4BA5324-FA0E-475B-866D-D044EAA5BDD9}"/>
+                <a16:creationId xmlns:a16="http://schemas.microsoft.com/office/drawing/2014/main" id="{ECFB5D6C-2EF2-4159-A2B1-81FD1480000A}"/>
               </a:ext>
             </a:extLst>
           </p:cNvPr>
@@ -1753,7 +1753,7 @@
           <p:cNvPr id="9" name="deck-meta">
             <a:extLst xmlns:a="http://schemas.openxmlformats.org/drawingml/2006/main">
               <a:ext uri="{FF2B5EF4-FFF2-40B4-BE49-F238E27FC236}">
-                <a16:creationId xmlns:a16="http://schemas.microsoft.com/office/drawing/2014/main" id="{FB453A9A-194A-4B3E-A970-F19B399DA65A}"/>
+                <a16:creationId xmlns:a16="http://schemas.microsoft.com/office/drawing/2014/main" id="{F2B75122-210A-49AC-92A1-F47995187636}"/>
               </a:ext>
             </a:extLst>
           </p:cNvPr>
@@ -1801,65 +1801,7 @@
                 <a:ea typeface="Space Grotesk"/>
                 <a:cs typeface="Space Grotesk"/>
               </a:rPr>
-              <a:t>Agentic Economy · Mark T · Checkpoint 2</a:t>
-            </a:r>
-          </a:p>
-        </p:txBody>
-      </p:sp>
-      <p:sp>
-        <p:nvSpPr>
-          <p:cNvPr id="10" name="deck-date">
-            <a:extLst xmlns:a="http://schemas.openxmlformats.org/drawingml/2006/main">
-              <a:ext uri="{FF2B5EF4-FFF2-40B4-BE49-F238E27FC236}">
-                <a16:creationId xmlns:a16="http://schemas.microsoft.com/office/drawing/2014/main" id="{AC0236A1-E634-4869-AA4A-2D8C8BD1A537}"/>
-              </a:ext>
-            </a:extLst>
-          </p:cNvPr>
-          <p:cNvSpPr>
-            <a:spLocks xmlns:a="http://schemas.openxmlformats.org/drawingml/2006/main" noGrp="1"/>
-          </p:cNvSpPr>
-          <p:nvPr/>
-        </p:nvSpPr>
-        <p:spPr>
-          <a:xfrm xmlns:a="http://schemas.openxmlformats.org/drawingml/2006/main">
-            <a:off x="685800" y="5810250"/>
-            <a:ext cx="1905000" cy="209550"/>
-          </a:xfrm>
-          <a:prstGeom xmlns:a="http://schemas.openxmlformats.org/drawingml/2006/main" prst="rect">
-            <a:avLst/>
-          </a:prstGeom>
-          <a:noFill xmlns:a="http://schemas.openxmlformats.org/drawingml/2006/main"/>
-          <a:ln xmlns:a="http://schemas.openxmlformats.org/drawingml/2006/main" w="0">
-            <a:noFill/>
-            <a:prstDash val="solid"/>
-          </a:ln>
-        </p:spPr>
-        <p:txBody>
-          <a:bodyPr xmlns:a="http://schemas.openxmlformats.org/drawingml/2006/main" lIns="0" tIns="0" rIns="0" bIns="0" anchor="t">
-            <a:normAutofit fontScale="100000"/>
-          </a:bodyPr>
-          <a:lstStyle xmlns:a="http://schemas.openxmlformats.org/drawingml/2006/main"/>
-          <a:p xmlns:a="http://schemas.openxmlformats.org/drawingml/2006/main">
-            <a:pPr algn="l">
-              <a:defRPr sz="975" b="0">
-                <a:solidFill>
-                  <a:srgbClr val="94948E"/>
-                </a:solidFill>
-                <a:latin typeface="Space Grotesk"/>
-                <a:ea typeface="Space Grotesk"/>
-                <a:cs typeface="Space Grotesk"/>
-              </a:defRPr>
-            </a:pPr>
-            <a:r>
-              <a:rPr sz="975" b="0">
-                <a:solidFill>
-                  <a:srgbClr val="94948E"/>
-                </a:solidFill>
-                <a:latin typeface="Space Grotesk"/>
-                <a:ea typeface="Space Grotesk"/>
-                <a:cs typeface="Space Grotesk"/>
-              </a:rPr>
-              <a:t>August 2026</a:t>
+              <a:t>Arc Testnet · Agentic Economy</a:t>
             </a:r>
           </a:p>
         </p:txBody>
@@ -1867,7 +1809,7 @@
     </p:spTree>
     <p:extLst>
       <p:ext uri="{BB962C8B-B14F-4D97-AF65-F5344CB8AC3E}">
-        <p14:creationId xmlns:p14="http://schemas.microsoft.com/office/powerpoint/2010/main" val="154482977"/>
+        <p14:creationId xmlns:p14="http://schemas.microsoft.com/office/powerpoint/2010/main" val="199284219"/>
       </p:ext>
     </p:extLst>
   </p:cSld>
@@ -1895,22 +1837,22 @@
       </p:grpSpPr>
       <p:sp>
         <p:nvSpPr>
-          <p:cNvPr id="41" name="section-2">
-            <a:extLst xmlns:a="http://schemas.openxmlformats.org/drawingml/2006/main">
-              <a:ext uri="{FF2B5EF4-FFF2-40B4-BE49-F238E27FC236}">
-                <a16:creationId xmlns:a16="http://schemas.microsoft.com/office/drawing/2014/main" id="{BFCB4027-78B2-4B3D-AB56-323207F83A82}"/>
-              </a:ext>
-            </a:extLst>
-          </p:cNvPr>
-          <p:cNvSpPr>
-            <a:spLocks xmlns:a="http://schemas.openxmlformats.org/drawingml/2006/main" noGrp="1"/>
-          </p:cNvSpPr>
-          <p:nvPr/>
-        </p:nvSpPr>
-        <p:spPr>
-          <a:xfrm xmlns:a="http://schemas.openxmlformats.org/drawingml/2006/main">
-            <a:off x="685800" y="304800"/>
-            <a:ext cx="3048000" cy="190500"/>
+          <p:cNvPr id="36" name="page-2">
+            <a:extLst xmlns:a="http://schemas.openxmlformats.org/drawingml/2006/main">
+              <a:ext uri="{FF2B5EF4-FFF2-40B4-BE49-F238E27FC236}">
+                <a16:creationId xmlns:a16="http://schemas.microsoft.com/office/drawing/2014/main" id="{8DE84E78-0695-4ADF-AC79-F66C6EF95584}"/>
+              </a:ext>
+            </a:extLst>
+          </p:cNvPr>
+          <p:cNvSpPr>
+            <a:spLocks xmlns:a="http://schemas.openxmlformats.org/drawingml/2006/main" noGrp="1"/>
+          </p:cNvSpPr>
+          <p:nvPr/>
+        </p:nvSpPr>
+        <p:spPr>
+          <a:xfrm xmlns:a="http://schemas.openxmlformats.org/drawingml/2006/main">
+            <a:off x="10648950" y="304800"/>
+            <a:ext cx="857250" cy="190500"/>
           </a:xfrm>
           <a:prstGeom xmlns:a="http://schemas.openxmlformats.org/drawingml/2006/main" prst="rect">
             <a:avLst/>
@@ -1927,14 +1869,14 @@
           </a:bodyPr>
           <a:lstStyle xmlns:a="http://schemas.openxmlformats.org/drawingml/2006/main"/>
           <a:p xmlns:a="http://schemas.openxmlformats.org/drawingml/2006/main">
-            <a:pPr algn="l">
+            <a:pPr algn="r">
               <a:defRPr sz="975" b="0">
                 <a:solidFill>
                   <a:srgbClr val="94948E"/>
                 </a:solidFill>
-                <a:latin typeface="Space Grotesk"/>
-                <a:ea typeface="Space Grotesk"/>
-                <a:cs typeface="Space Grotesk"/>
+                <a:latin typeface="IBM Plex Mono"/>
+                <a:ea typeface="IBM Plex Mono"/>
+                <a:cs typeface="IBM Plex Mono"/>
               </a:defRPr>
             </a:pPr>
             <a:r>
@@ -1942,83 +1884,21 @@
                 <a:solidFill>
                   <a:srgbClr val="94948E"/>
                 </a:solidFill>
-                <a:latin typeface="Space Grotesk"/>
-                <a:ea typeface="Space Grotesk"/>
-                <a:cs typeface="Space Grotesk"/>
+                <a:latin typeface="IBM Plex Mono"/>
+                <a:ea typeface="IBM Plex Mono"/>
+                <a:cs typeface="IBM Plex Mono"/>
               </a:rPr>
-              <a:t>vAPI Trust Network  ·  02</a:t>
-            </a:r>
-          </a:p>
-        </p:txBody>
-      </p:sp>
-      <p:sp>
-        <p:nvSpPr>
-          <p:cNvPr id="2" name="">
-            <a:extLst xmlns:a="http://schemas.openxmlformats.org/drawingml/2006/main">
-              <a:ext uri="{FF2B5EF4-FFF2-40B4-BE49-F238E27FC236}">
-                <a16:creationId xmlns:a16="http://schemas.microsoft.com/office/drawing/2014/main" id="{0C82A251-D2B9-4270-96BF-DDCA0500E760}"/>
-              </a:ext>
-            </a:extLst>
-          </p:cNvPr>
-          <p:cNvSpPr>
-            <a:spLocks xmlns:a="http://schemas.openxmlformats.org/drawingml/2006/main" noGrp="1"/>
-          </p:cNvSpPr>
-          <p:nvPr/>
-        </p:nvSpPr>
-        <p:spPr>
-          <a:xfrm xmlns:a="http://schemas.openxmlformats.org/drawingml/2006/main">
-            <a:off x="685800" y="581025"/>
-            <a:ext cx="10820400" cy="9525"/>
-          </a:xfrm>
-          <a:prstGeom xmlns:a="http://schemas.openxmlformats.org/drawingml/2006/main" prst="rect">
-            <a:avLst/>
-          </a:prstGeom>
-          <a:solidFill xmlns:a="http://schemas.openxmlformats.org/drawingml/2006/main">
-            <a:srgbClr val="2B2B2B"/>
-          </a:solidFill>
-          <a:ln xmlns:a="http://schemas.openxmlformats.org/drawingml/2006/main" w="0">
-            <a:noFill/>
-            <a:prstDash val="solid"/>
-          </a:ln>
-        </p:spPr>
-      </p:sp>
-      <p:sp>
-        <p:nvSpPr>
-          <p:cNvPr id="3" name="">
-            <a:extLst xmlns:a="http://schemas.openxmlformats.org/drawingml/2006/main">
-              <a:ext uri="{FF2B5EF4-FFF2-40B4-BE49-F238E27FC236}">
-                <a16:creationId xmlns:a16="http://schemas.microsoft.com/office/drawing/2014/main" id="{69F1F9CB-DB08-4F9A-A0B1-429164172596}"/>
-              </a:ext>
-            </a:extLst>
-          </p:cNvPr>
-          <p:cNvSpPr>
-            <a:spLocks xmlns:a="http://schemas.openxmlformats.org/drawingml/2006/main" noGrp="1"/>
-          </p:cNvSpPr>
-          <p:nvPr/>
-        </p:nvSpPr>
-        <p:spPr>
-          <a:xfrm xmlns:a="http://schemas.openxmlformats.org/drawingml/2006/main">
-            <a:off x="11410950" y="304800"/>
-            <a:ext cx="95250" cy="95250"/>
-          </a:xfrm>
-          <a:prstGeom xmlns:a="http://schemas.openxmlformats.org/drawingml/2006/main" prst="rect">
-            <a:avLst/>
-          </a:prstGeom>
-          <a:solidFill xmlns:a="http://schemas.openxmlformats.org/drawingml/2006/main">
-            <a:srgbClr val="FF7300"/>
-          </a:solidFill>
-          <a:ln xmlns:a="http://schemas.openxmlformats.org/drawingml/2006/main" w="0">
-            <a:noFill/>
-            <a:prstDash val="solid"/>
-          </a:ln>
-        </p:spPr>
-      </p:sp>
-      <p:sp>
-        <p:nvSpPr>
-          <p:cNvPr id="4" name="slide-title">
-            <a:extLst xmlns:a="http://schemas.openxmlformats.org/drawingml/2006/main">
-              <a:ext uri="{FF2B5EF4-FFF2-40B4-BE49-F238E27FC236}">
-                <a16:creationId xmlns:a16="http://schemas.microsoft.com/office/drawing/2014/main" id="{B09AFCFA-79F7-4B3A-8D83-D3EDB0BDB594}"/>
+              <a:t>02 / 05</a:t>
+            </a:r>
+          </a:p>
+        </p:txBody>
+      </p:sp>
+      <p:sp>
+        <p:nvSpPr>
+          <p:cNvPr id="2" name="slide-title">
+            <a:extLst xmlns:a="http://schemas.openxmlformats.org/drawingml/2006/main">
+              <a:ext uri="{FF2B5EF4-FFF2-40B4-BE49-F238E27FC236}">
+                <a16:creationId xmlns:a16="http://schemas.microsoft.com/office/drawing/2014/main" id="{3ED08BC2-4753-43D8-9195-55A2AF9340FA}"/>
               </a:ext>
             </a:extLst>
           </p:cNvPr>
@@ -2066,17 +1946,17 @@
                 <a:ea typeface="Space Grotesk"/>
                 <a:cs typeface="Space Grotesk"/>
               </a:rPr>
-              <a:t>Each job uses AI review or waits for a human</a:t>
-            </a:r>
-          </a:p>
-        </p:txBody>
-      </p:sp>
-      <p:sp>
-        <p:nvSpPr>
-          <p:cNvPr id="5" name="">
-            <a:extLst xmlns:a="http://schemas.openxmlformats.org/drawingml/2006/main">
-              <a:ext uri="{FF2B5EF4-FFF2-40B4-BE49-F238E27FC236}">
-                <a16:creationId xmlns:a16="http://schemas.microsoft.com/office/drawing/2014/main" id="{8F90BFBE-A249-4EEF-A772-DBCCD461633D}"/>
+              <a:t>AI reviews routine jobs. Auditors review the rest.</a:t>
+            </a:r>
+          </a:p>
+        </p:txBody>
+      </p:sp>
+      <p:sp>
+        <p:nvSpPr>
+          <p:cNvPr id="3" name="">
+            <a:extLst xmlns:a="http://schemas.openxmlformats.org/drawingml/2006/main">
+              <a:ext uri="{FF2B5EF4-FFF2-40B4-BE49-F238E27FC236}">
+                <a16:creationId xmlns:a16="http://schemas.microsoft.com/office/drawing/2014/main" id="{D150E873-4E33-471F-92F1-11DC335CBF0C}"/>
               </a:ext>
             </a:extLst>
           </p:cNvPr>
@@ -2104,10 +1984,10 @@
       </p:sp>
       <p:sp>
         <p:nvSpPr>
-          <p:cNvPr id="6" name="">
-            <a:extLst xmlns:a="http://schemas.openxmlformats.org/drawingml/2006/main">
-              <a:ext uri="{FF2B5EF4-FFF2-40B4-BE49-F238E27FC236}">
-                <a16:creationId xmlns:a16="http://schemas.microsoft.com/office/drawing/2014/main" id="{3057413A-5879-423A-AB32-559CA79BFB32}"/>
+          <p:cNvPr id="4" name="">
+            <a:extLst xmlns:a="http://schemas.openxmlformats.org/drawingml/2006/main">
+              <a:ext uri="{FF2B5EF4-FFF2-40B4-BE49-F238E27FC236}">
+                <a16:creationId xmlns:a16="http://schemas.microsoft.com/office/drawing/2014/main" id="{15998046-3875-4E98-A84E-886CD705D8CF}"/>
               </a:ext>
             </a:extLst>
           </p:cNvPr>
@@ -2135,10 +2015,10 @@
       </p:sp>
       <p:sp>
         <p:nvSpPr>
-          <p:cNvPr id="7" name="">
-            <a:extLst xmlns:a="http://schemas.openxmlformats.org/drawingml/2006/main">
-              <a:ext uri="{FF2B5EF4-FFF2-40B4-BE49-F238E27FC236}">
-                <a16:creationId xmlns:a16="http://schemas.microsoft.com/office/drawing/2014/main" id="{8B2C59F1-C3BF-4308-9EFA-565FCC800807}"/>
+          <p:cNvPr id="5" name="">
+            <a:extLst xmlns:a="http://schemas.openxmlformats.org/drawingml/2006/main">
+              <a:ext uri="{FF2B5EF4-FFF2-40B4-BE49-F238E27FC236}">
+                <a16:creationId xmlns:a16="http://schemas.microsoft.com/office/drawing/2014/main" id="{F1BB22B9-A941-40BF-8AC8-CDF455B2C3A2}"/>
               </a:ext>
             </a:extLst>
           </p:cNvPr>
@@ -2166,10 +2046,10 @@
       </p:sp>
       <p:sp>
         <p:nvSpPr>
-          <p:cNvPr id="8" name="">
-            <a:extLst xmlns:a="http://schemas.openxmlformats.org/drawingml/2006/main">
-              <a:ext uri="{FF2B5EF4-FFF2-40B4-BE49-F238E27FC236}">
-                <a16:creationId xmlns:a16="http://schemas.microsoft.com/office/drawing/2014/main" id="{C6D36D7B-0C2F-4FD8-A8E5-54921926F5AD}"/>
+          <p:cNvPr id="6" name="">
+            <a:extLst xmlns:a="http://schemas.openxmlformats.org/drawingml/2006/main">
+              <a:ext uri="{FF2B5EF4-FFF2-40B4-BE49-F238E27FC236}">
+                <a16:creationId xmlns:a16="http://schemas.microsoft.com/office/drawing/2014/main" id="{326BE5BD-685D-4D41-8E1B-5EBF9049DD5F}"/>
               </a:ext>
             </a:extLst>
           </p:cNvPr>
@@ -2197,10 +2077,10 @@
       </p:sp>
       <p:sp>
         <p:nvSpPr>
-          <p:cNvPr id="9" name="">
-            <a:extLst xmlns:a="http://schemas.openxmlformats.org/drawingml/2006/main">
-              <a:ext uri="{FF2B5EF4-FFF2-40B4-BE49-F238E27FC236}">
-                <a16:creationId xmlns:a16="http://schemas.microsoft.com/office/drawing/2014/main" id="{A59BF557-CE2F-4594-9CD4-56B7101E4028}"/>
+          <p:cNvPr id="7" name="">
+            <a:extLst xmlns:a="http://schemas.openxmlformats.org/drawingml/2006/main">
+              <a:ext uri="{FF2B5EF4-FFF2-40B4-BE49-F238E27FC236}">
+                <a16:creationId xmlns:a16="http://schemas.microsoft.com/office/drawing/2014/main" id="{96732B00-37BE-4415-9D7A-85169FBC5808}"/>
               </a:ext>
             </a:extLst>
           </p:cNvPr>
@@ -2228,10 +2108,10 @@
       </p:sp>
       <p:sp>
         <p:nvSpPr>
-          <p:cNvPr id="10" name="">
-            <a:extLst xmlns:a="http://schemas.openxmlformats.org/drawingml/2006/main">
-              <a:ext uri="{FF2B5EF4-FFF2-40B4-BE49-F238E27FC236}">
-                <a16:creationId xmlns:a16="http://schemas.microsoft.com/office/drawing/2014/main" id="{341022D3-508F-448E-AC75-D127397EB901}"/>
+          <p:cNvPr id="8" name="">
+            <a:extLst xmlns:a="http://schemas.openxmlformats.org/drawingml/2006/main">
+              <a:ext uri="{FF2B5EF4-FFF2-40B4-BE49-F238E27FC236}">
+                <a16:creationId xmlns:a16="http://schemas.microsoft.com/office/drawing/2014/main" id="{779BEBEB-631C-421E-A492-007F161BEF1D}"/>
               </a:ext>
             </a:extLst>
           </p:cNvPr>
@@ -2259,10 +2139,10 @@
       </p:sp>
       <p:sp>
         <p:nvSpPr>
-          <p:cNvPr id="11" name="">
-            <a:extLst xmlns:a="http://schemas.openxmlformats.org/drawingml/2006/main">
-              <a:ext uri="{FF2B5EF4-FFF2-40B4-BE49-F238E27FC236}">
-                <a16:creationId xmlns:a16="http://schemas.microsoft.com/office/drawing/2014/main" id="{769AC622-BAB6-45AD-9CC3-9A304EA003CF}"/>
+          <p:cNvPr id="9" name="">
+            <a:extLst xmlns:a="http://schemas.openxmlformats.org/drawingml/2006/main">
+              <a:ext uri="{FF2B5EF4-FFF2-40B4-BE49-F238E27FC236}">
+                <a16:creationId xmlns:a16="http://schemas.microsoft.com/office/drawing/2014/main" id="{ADA231BE-E379-43F2-95D2-F61A1B1471C8}"/>
               </a:ext>
             </a:extLst>
           </p:cNvPr>
@@ -2290,10 +2170,10 @@
       </p:sp>
       <p:sp>
         <p:nvSpPr>
-          <p:cNvPr id="12" name="">
-            <a:extLst xmlns:a="http://schemas.openxmlformats.org/drawingml/2006/main">
-              <a:ext uri="{FF2B5EF4-FFF2-40B4-BE49-F238E27FC236}">
-                <a16:creationId xmlns:a16="http://schemas.microsoft.com/office/drawing/2014/main" id="{795DDDA3-05C6-432D-A293-E841CA03D176}"/>
+          <p:cNvPr id="10" name="">
+            <a:extLst xmlns:a="http://schemas.openxmlformats.org/drawingml/2006/main">
+              <a:ext uri="{FF2B5EF4-FFF2-40B4-BE49-F238E27FC236}">
+                <a16:creationId xmlns:a16="http://schemas.microsoft.com/office/drawing/2014/main" id="{F998AAA2-362E-4A2C-86D9-2ED246D1EB82}"/>
               </a:ext>
             </a:extLst>
           </p:cNvPr>
@@ -2321,10 +2201,10 @@
       </p:sp>
       <p:sp>
         <p:nvSpPr>
-          <p:cNvPr id="13" name="">
-            <a:extLst xmlns:a="http://schemas.openxmlformats.org/drawingml/2006/main">
-              <a:ext uri="{FF2B5EF4-FFF2-40B4-BE49-F238E27FC236}">
-                <a16:creationId xmlns:a16="http://schemas.microsoft.com/office/drawing/2014/main" id="{B73F83D7-5C72-4845-812A-01CEC8794C26}"/>
+          <p:cNvPr id="11" name="">
+            <a:extLst xmlns:a="http://schemas.openxmlformats.org/drawingml/2006/main">
+              <a:ext uri="{FF2B5EF4-FFF2-40B4-BE49-F238E27FC236}">
+                <a16:creationId xmlns:a16="http://schemas.microsoft.com/office/drawing/2014/main" id="{563C4E3C-FDA8-49FF-A9E3-F27B2A35F238}"/>
               </a:ext>
             </a:extLst>
           </p:cNvPr>
@@ -2352,10 +2232,10 @@
       </p:sp>
       <p:sp>
         <p:nvSpPr>
-          <p:cNvPr id="14" name="">
-            <a:extLst xmlns:a="http://schemas.openxmlformats.org/drawingml/2006/main">
-              <a:ext uri="{FF2B5EF4-FFF2-40B4-BE49-F238E27FC236}">
-                <a16:creationId xmlns:a16="http://schemas.microsoft.com/office/drawing/2014/main" id="{CFDCE692-B8E3-4B02-BC33-E88F57E2C1D5}"/>
+          <p:cNvPr id="12" name="">
+            <a:extLst xmlns:a="http://schemas.openxmlformats.org/drawingml/2006/main">
+              <a:ext uri="{FF2B5EF4-FFF2-40B4-BE49-F238E27FC236}">
+                <a16:creationId xmlns:a16="http://schemas.microsoft.com/office/drawing/2014/main" id="{81A16F0A-FEA7-403E-A5A1-331C05C88999}"/>
               </a:ext>
             </a:extLst>
           </p:cNvPr>
@@ -2383,10 +2263,10 @@
       </p:sp>
       <p:sp>
         <p:nvSpPr>
-          <p:cNvPr id="15" name="flow-node-0">
-            <a:extLst xmlns:a="http://schemas.openxmlformats.org/drawingml/2006/main">
-              <a:ext uri="{FF2B5EF4-FFF2-40B4-BE49-F238E27FC236}">
-                <a16:creationId xmlns:a16="http://schemas.microsoft.com/office/drawing/2014/main" id="{97BF275E-C6E4-4BC5-B69F-5920D3EC492C}"/>
+          <p:cNvPr id="13" name="flow-node-0">
+            <a:extLst xmlns:a="http://schemas.openxmlformats.org/drawingml/2006/main">
+              <a:ext uri="{FF2B5EF4-FFF2-40B4-BE49-F238E27FC236}">
+                <a16:creationId xmlns:a16="http://schemas.microsoft.com/office/drawing/2014/main" id="{833B89B2-D7BC-444D-BE2D-1841DC33E76E}"/>
               </a:ext>
             </a:extLst>
           </p:cNvPr>
@@ -2416,10 +2296,10 @@
       </p:sp>
       <p:sp>
         <p:nvSpPr>
-          <p:cNvPr id="16" name="">
-            <a:extLst xmlns:a="http://schemas.openxmlformats.org/drawingml/2006/main">
-              <a:ext uri="{FF2B5EF4-FFF2-40B4-BE49-F238E27FC236}">
-                <a16:creationId xmlns:a16="http://schemas.microsoft.com/office/drawing/2014/main" id="{E5D60281-C3FE-434B-99EA-350B4CB1AC88}"/>
+          <p:cNvPr id="14" name="">
+            <a:extLst xmlns:a="http://schemas.openxmlformats.org/drawingml/2006/main">
+              <a:ext uri="{FF2B5EF4-FFF2-40B4-BE49-F238E27FC236}">
+                <a16:creationId xmlns:a16="http://schemas.microsoft.com/office/drawing/2014/main" id="{A8702053-A404-46D5-8B85-04FC43084BF3}"/>
               </a:ext>
             </a:extLst>
           </p:cNvPr>
@@ -2447,10 +2327,10 @@
       </p:sp>
       <p:sp>
         <p:nvSpPr>
-          <p:cNvPr id="17" name="flow-node-0-label">
-            <a:extLst xmlns:a="http://schemas.openxmlformats.org/drawingml/2006/main">
-              <a:ext uri="{FF2B5EF4-FFF2-40B4-BE49-F238E27FC236}">
-                <a16:creationId xmlns:a16="http://schemas.microsoft.com/office/drawing/2014/main" id="{357634EC-832F-44BA-8167-FA9C4946CAC5}"/>
+          <p:cNvPr id="15" name="flow-node-0-label">
+            <a:extLst xmlns:a="http://schemas.openxmlformats.org/drawingml/2006/main">
+              <a:ext uri="{FF2B5EF4-FFF2-40B4-BE49-F238E27FC236}">
+                <a16:creationId xmlns:a16="http://schemas.microsoft.com/office/drawing/2014/main" id="{246DBD79-B146-4235-AE0C-BBBEBD0C5D0A}"/>
               </a:ext>
             </a:extLst>
           </p:cNvPr>
@@ -2505,10 +2385,10 @@
       </p:sp>
       <p:sp>
         <p:nvSpPr>
-          <p:cNvPr id="18" name="flow-node-0-detail">
-            <a:extLst xmlns:a="http://schemas.openxmlformats.org/drawingml/2006/main">
-              <a:ext uri="{FF2B5EF4-FFF2-40B4-BE49-F238E27FC236}">
-                <a16:creationId xmlns:a16="http://schemas.microsoft.com/office/drawing/2014/main" id="{E705C78F-EF46-47C2-BA47-4E0272B19415}"/>
+          <p:cNvPr id="16" name="flow-node-0-detail">
+            <a:extLst xmlns:a="http://schemas.openxmlformats.org/drawingml/2006/main">
+              <a:ext uri="{FF2B5EF4-FFF2-40B4-BE49-F238E27FC236}">
+                <a16:creationId xmlns:a16="http://schemas.microsoft.com/office/drawing/2014/main" id="{0AED6003-C0E3-48B6-8250-BF35A349D4FD}"/>
               </a:ext>
             </a:extLst>
           </p:cNvPr>
@@ -2563,10 +2443,10 @@
       </p:sp>
       <p:sp>
         <p:nvSpPr>
-          <p:cNvPr id="19" name="flow-node-1">
-            <a:extLst xmlns:a="http://schemas.openxmlformats.org/drawingml/2006/main">
-              <a:ext uri="{FF2B5EF4-FFF2-40B4-BE49-F238E27FC236}">
-                <a16:creationId xmlns:a16="http://schemas.microsoft.com/office/drawing/2014/main" id="{1CD29A86-CACC-4C19-ADA2-E2E3E605C436}"/>
+          <p:cNvPr id="17" name="flow-node-1">
+            <a:extLst xmlns:a="http://schemas.openxmlformats.org/drawingml/2006/main">
+              <a:ext uri="{FF2B5EF4-FFF2-40B4-BE49-F238E27FC236}">
+                <a16:creationId xmlns:a16="http://schemas.microsoft.com/office/drawing/2014/main" id="{ACC38203-5065-4C61-B57F-A5132875BC19}"/>
               </a:ext>
             </a:extLst>
           </p:cNvPr>
@@ -2596,10 +2476,10 @@
       </p:sp>
       <p:sp>
         <p:nvSpPr>
-          <p:cNvPr id="20" name="">
-            <a:extLst xmlns:a="http://schemas.openxmlformats.org/drawingml/2006/main">
-              <a:ext uri="{FF2B5EF4-FFF2-40B4-BE49-F238E27FC236}">
-                <a16:creationId xmlns:a16="http://schemas.microsoft.com/office/drawing/2014/main" id="{FC4AE274-870D-45F3-9D29-AD61D08E4955}"/>
+          <p:cNvPr id="18" name="">
+            <a:extLst xmlns:a="http://schemas.openxmlformats.org/drawingml/2006/main">
+              <a:ext uri="{FF2B5EF4-FFF2-40B4-BE49-F238E27FC236}">
+                <a16:creationId xmlns:a16="http://schemas.microsoft.com/office/drawing/2014/main" id="{221114FB-C6E1-4267-A07E-424FA713F699}"/>
               </a:ext>
             </a:extLst>
           </p:cNvPr>
@@ -2627,10 +2507,10 @@
       </p:sp>
       <p:sp>
         <p:nvSpPr>
-          <p:cNvPr id="21" name="flow-node-1-label">
-            <a:extLst xmlns:a="http://schemas.openxmlformats.org/drawingml/2006/main">
-              <a:ext uri="{FF2B5EF4-FFF2-40B4-BE49-F238E27FC236}">
-                <a16:creationId xmlns:a16="http://schemas.microsoft.com/office/drawing/2014/main" id="{DA79C6CF-CFF2-4B74-A776-ACB74A4848BE}"/>
+          <p:cNvPr id="19" name="flow-node-1-label">
+            <a:extLst xmlns:a="http://schemas.openxmlformats.org/drawingml/2006/main">
+              <a:ext uri="{FF2B5EF4-FFF2-40B4-BE49-F238E27FC236}">
+                <a16:creationId xmlns:a16="http://schemas.microsoft.com/office/drawing/2014/main" id="{049A4953-53D0-4233-809F-BB3B7A37D778}"/>
               </a:ext>
             </a:extLst>
           </p:cNvPr>
@@ -2643,6 +2523,64 @@
           <a:xfrm xmlns:a="http://schemas.openxmlformats.org/drawingml/2006/main">
             <a:off x="3486150" y="2857500"/>
             <a:ext cx="1695450" cy="285750"/>
+          </a:xfrm>
+          <a:prstGeom xmlns:a="http://schemas.openxmlformats.org/drawingml/2006/main" prst="rect">
+            <a:avLst/>
+          </a:prstGeom>
+          <a:noFill xmlns:a="http://schemas.openxmlformats.org/drawingml/2006/main"/>
+          <a:ln xmlns:a="http://schemas.openxmlformats.org/drawingml/2006/main" w="0">
+            <a:noFill/>
+            <a:prstDash val="solid"/>
+          </a:ln>
+        </p:spPr>
+        <p:txBody>
+          <a:bodyPr xmlns:a="http://schemas.openxmlformats.org/drawingml/2006/main" lIns="0" tIns="0" rIns="0" bIns="0" anchor="t">
+            <a:normAutofit fontScale="85334"/>
+          </a:bodyPr>
+          <a:lstStyle xmlns:a="http://schemas.openxmlformats.org/drawingml/2006/main"/>
+          <a:p xmlns:a="http://schemas.openxmlformats.org/drawingml/2006/main">
+            <a:pPr algn="l">
+              <a:defRPr sz="1425" b="0">
+                <a:solidFill>
+                  <a:srgbClr val="FAFAFA"/>
+                </a:solidFill>
+                <a:latin typeface="Space Grotesk"/>
+                <a:ea typeface="Space Grotesk"/>
+                <a:cs typeface="Space Grotesk"/>
+              </a:defRPr>
+            </a:pPr>
+            <a:r>
+              <a:rPr sz="1425" b="0">
+                <a:solidFill>
+                  <a:srgbClr val="FAFAFA"/>
+                </a:solidFill>
+                <a:latin typeface="Space Grotesk"/>
+                <a:ea typeface="Space Grotesk"/>
+                <a:cs typeface="Space Grotesk"/>
+              </a:rPr>
+              <a:t>Freelancer submits work</a:t>
+            </a:r>
+          </a:p>
+        </p:txBody>
+      </p:sp>
+      <p:sp>
+        <p:nvSpPr>
+          <p:cNvPr id="20" name="flow-node-1-detail">
+            <a:extLst xmlns:a="http://schemas.openxmlformats.org/drawingml/2006/main">
+              <a:ext uri="{FF2B5EF4-FFF2-40B4-BE49-F238E27FC236}">
+                <a16:creationId xmlns:a16="http://schemas.microsoft.com/office/drawing/2014/main" id="{9A75AB1D-F102-4F23-8489-4880C9B11F45}"/>
+              </a:ext>
+            </a:extLst>
+          </p:cNvPr>
+          <p:cNvSpPr>
+            <a:spLocks xmlns:a="http://schemas.openxmlformats.org/drawingml/2006/main" noGrp="1"/>
+          </p:cNvSpPr>
+          <p:nvPr/>
+        </p:nvSpPr>
+        <p:spPr>
+          <a:xfrm xmlns:a="http://schemas.openxmlformats.org/drawingml/2006/main">
+            <a:off x="3486150" y="3200400"/>
+            <a:ext cx="1695450" cy="400050"/>
           </a:xfrm>
           <a:prstGeom xmlns:a="http://schemas.openxmlformats.org/drawingml/2006/main" prst="rect">
             <a:avLst/>
@@ -2660,9 +2598,9 @@
           <a:lstStyle xmlns:a="http://schemas.openxmlformats.org/drawingml/2006/main"/>
           <a:p xmlns:a="http://schemas.openxmlformats.org/drawingml/2006/main">
             <a:pPr algn="l">
-              <a:defRPr sz="1425" b="0">
-                <a:solidFill>
-                  <a:srgbClr val="FAFAFA"/>
+              <a:defRPr sz="1050" b="0">
+                <a:solidFill>
+                  <a:srgbClr val="B0B0AB"/>
                 </a:solidFill>
                 <a:latin typeface="Space Grotesk"/>
                 <a:ea typeface="Space Grotesk"/>
@@ -2670,83 +2608,25 @@
               </a:defRPr>
             </a:pPr>
             <a:r>
-              <a:rPr sz="1425" b="0">
-                <a:solidFill>
-                  <a:srgbClr val="FAFAFA"/>
+              <a:rPr sz="1050" b="0">
+                <a:solidFill>
+                  <a:srgbClr val="B0B0AB"/>
                 </a:solidFill>
                 <a:latin typeface="Space Grotesk"/>
                 <a:ea typeface="Space Grotesk"/>
                 <a:cs typeface="Space Grotesk"/>
               </a:rPr>
-              <a:t>Provider submits</a:t>
-            </a:r>
-          </a:p>
-        </p:txBody>
-      </p:sp>
-      <p:sp>
-        <p:nvSpPr>
-          <p:cNvPr id="22" name="flow-node-1-detail">
-            <a:extLst xmlns:a="http://schemas.openxmlformats.org/drawingml/2006/main">
-              <a:ext uri="{FF2B5EF4-FFF2-40B4-BE49-F238E27FC236}">
-                <a16:creationId xmlns:a16="http://schemas.microsoft.com/office/drawing/2014/main" id="{5D283EFA-ADAC-4AED-A32C-9C2C4CF85C5B}"/>
-              </a:ext>
-            </a:extLst>
-          </p:cNvPr>
-          <p:cNvSpPr>
-            <a:spLocks xmlns:a="http://schemas.openxmlformats.org/drawingml/2006/main" noGrp="1"/>
-          </p:cNvSpPr>
-          <p:nvPr/>
-        </p:nvSpPr>
-        <p:spPr>
-          <a:xfrm xmlns:a="http://schemas.openxmlformats.org/drawingml/2006/main">
-            <a:off x="3486150" y="3200400"/>
-            <a:ext cx="1695450" cy="400050"/>
-          </a:xfrm>
-          <a:prstGeom xmlns:a="http://schemas.openxmlformats.org/drawingml/2006/main" prst="rect">
-            <a:avLst/>
-          </a:prstGeom>
-          <a:noFill xmlns:a="http://schemas.openxmlformats.org/drawingml/2006/main"/>
-          <a:ln xmlns:a="http://schemas.openxmlformats.org/drawingml/2006/main" w="0">
-            <a:noFill/>
-            <a:prstDash val="solid"/>
-          </a:ln>
-        </p:spPr>
-        <p:txBody>
-          <a:bodyPr xmlns:a="http://schemas.openxmlformats.org/drawingml/2006/main" lIns="0" tIns="0" rIns="0" bIns="0" anchor="t">
-            <a:normAutofit fontScale="100000"/>
-          </a:bodyPr>
-          <a:lstStyle xmlns:a="http://schemas.openxmlformats.org/drawingml/2006/main"/>
-          <a:p xmlns:a="http://schemas.openxmlformats.org/drawingml/2006/main">
-            <a:pPr algn="l">
-              <a:defRPr sz="1050" b="0">
-                <a:solidFill>
-                  <a:srgbClr val="B0B0AB"/>
-                </a:solidFill>
-                <a:latin typeface="Space Grotesk"/>
-                <a:ea typeface="Space Grotesk"/>
-                <a:cs typeface="Space Grotesk"/>
-              </a:defRPr>
-            </a:pPr>
-            <a:r>
-              <a:rPr sz="1050" b="0">
-                <a:solidFill>
-                  <a:srgbClr val="B0B0AB"/>
-                </a:solidFill>
-                <a:latin typeface="Space Grotesk"/>
-                <a:ea typeface="Space Grotesk"/>
-                <a:cs typeface="Space Grotesk"/>
-              </a:rPr>
-              <a:t>Arc stores the deliverable commitment.</a:t>
-            </a:r>
-          </a:p>
-        </p:txBody>
-      </p:sp>
-      <p:sp>
-        <p:nvSpPr>
-          <p:cNvPr id="23" name="flow-node-2">
-            <a:extLst xmlns:a="http://schemas.openxmlformats.org/drawingml/2006/main">
-              <a:ext uri="{FF2B5EF4-FFF2-40B4-BE49-F238E27FC236}">
-                <a16:creationId xmlns:a16="http://schemas.microsoft.com/office/drawing/2014/main" id="{4E34DDE6-8DDD-40D6-9E0E-A939A9EBF160}"/>
+              <a:t>Arc stores a hash of the work.</a:t>
+            </a:r>
+          </a:p>
+        </p:txBody>
+      </p:sp>
+      <p:sp>
+        <p:nvSpPr>
+          <p:cNvPr id="21" name="flow-node-2">
+            <a:extLst xmlns:a="http://schemas.openxmlformats.org/drawingml/2006/main">
+              <a:ext uri="{FF2B5EF4-FFF2-40B4-BE49-F238E27FC236}">
+                <a16:creationId xmlns:a16="http://schemas.microsoft.com/office/drawing/2014/main" id="{9D9C39BD-49BC-4C6A-B7FE-856CA2DC7BB9}"/>
               </a:ext>
             </a:extLst>
           </p:cNvPr>
@@ -2776,10 +2656,10 @@
       </p:sp>
       <p:sp>
         <p:nvSpPr>
-          <p:cNvPr id="24" name="">
-            <a:extLst xmlns:a="http://schemas.openxmlformats.org/drawingml/2006/main">
-              <a:ext uri="{FF2B5EF4-FFF2-40B4-BE49-F238E27FC236}">
-                <a16:creationId xmlns:a16="http://schemas.microsoft.com/office/drawing/2014/main" id="{1C3BEA3D-FF8D-4FAD-8A7B-2F4AF68AF135}"/>
+          <p:cNvPr id="22" name="">
+            <a:extLst xmlns:a="http://schemas.openxmlformats.org/drawingml/2006/main">
+              <a:ext uri="{FF2B5EF4-FFF2-40B4-BE49-F238E27FC236}">
+                <a16:creationId xmlns:a16="http://schemas.microsoft.com/office/drawing/2014/main" id="{CAA6F112-D264-4F5D-A98D-333C9F6DB144}"/>
               </a:ext>
             </a:extLst>
           </p:cNvPr>
@@ -2807,10 +2687,10 @@
       </p:sp>
       <p:sp>
         <p:nvSpPr>
-          <p:cNvPr id="25" name="flow-node-2-label">
-            <a:extLst xmlns:a="http://schemas.openxmlformats.org/drawingml/2006/main">
-              <a:ext uri="{FF2B5EF4-FFF2-40B4-BE49-F238E27FC236}">
-                <a16:creationId xmlns:a16="http://schemas.microsoft.com/office/drawing/2014/main" id="{91396DC4-DD55-4F7C-A62F-7C66C8004A01}"/>
+          <p:cNvPr id="23" name="flow-node-2-label">
+            <a:extLst xmlns:a="http://schemas.openxmlformats.org/drawingml/2006/main">
+              <a:ext uri="{FF2B5EF4-FFF2-40B4-BE49-F238E27FC236}">
+                <a16:creationId xmlns:a16="http://schemas.microsoft.com/office/drawing/2014/main" id="{968DAD65-DA3A-4DC5-B076-907162D0CBC6}"/>
               </a:ext>
             </a:extLst>
           </p:cNvPr>
@@ -2865,10 +2745,10 @@
       </p:sp>
       <p:sp>
         <p:nvSpPr>
-          <p:cNvPr id="26" name="flow-node-2-detail">
-            <a:extLst xmlns:a="http://schemas.openxmlformats.org/drawingml/2006/main">
-              <a:ext uri="{FF2B5EF4-FFF2-40B4-BE49-F238E27FC236}">
-                <a16:creationId xmlns:a16="http://schemas.microsoft.com/office/drawing/2014/main" id="{C417D9C2-1E4B-4571-BACD-361498511C3E}"/>
+          <p:cNvPr id="24" name="flow-node-2-detail">
+            <a:extLst xmlns:a="http://schemas.openxmlformats.org/drawingml/2006/main">
+              <a:ext uri="{FF2B5EF4-FFF2-40B4-BE49-F238E27FC236}">
+                <a16:creationId xmlns:a16="http://schemas.microsoft.com/office/drawing/2014/main" id="{60E28438-F2A4-44E1-9E37-F65CE43C64D4}"/>
               </a:ext>
             </a:extLst>
           </p:cNvPr>
@@ -2893,7 +2773,7 @@
         </p:spPr>
         <p:txBody>
           <a:bodyPr xmlns:a="http://schemas.openxmlformats.org/drawingml/2006/main" lIns="0" tIns="0" rIns="0" bIns="0" anchor="t">
-            <a:normAutofit fontScale="100000"/>
+            <a:normAutofit fontScale="97468"/>
           </a:bodyPr>
           <a:lstStyle xmlns:a="http://schemas.openxmlformats.org/drawingml/2006/main"/>
           <a:p xmlns:a="http://schemas.openxmlformats.org/drawingml/2006/main">
@@ -2916,17 +2796,17 @@
                 <a:ea typeface="Space Grotesk"/>
                 <a:cs typeface="Space Grotesk"/>
               </a:rPr>
-              <a:t>Deterministic checks validate the model verdict.</a:t>
-            </a:r>
-          </a:p>
-        </p:txBody>
-      </p:sp>
-      <p:sp>
-        <p:nvSpPr>
-          <p:cNvPr id="27" name="flow-node-3">
-            <a:extLst xmlns:a="http://schemas.openxmlformats.org/drawingml/2006/main">
-              <a:ext uri="{FF2B5EF4-FFF2-40B4-BE49-F238E27FC236}">
-                <a16:creationId xmlns:a16="http://schemas.microsoft.com/office/drawing/2014/main" id="{FCE91AC4-5270-49FB-9BDA-B3783427CB7F}"/>
+              <a:t>The router checks the verdict against the job and policy.</a:t>
+            </a:r>
+          </a:p>
+        </p:txBody>
+      </p:sp>
+      <p:sp>
+        <p:nvSpPr>
+          <p:cNvPr id="25" name="flow-node-3">
+            <a:extLst xmlns:a="http://schemas.openxmlformats.org/drawingml/2006/main">
+              <a:ext uri="{FF2B5EF4-FFF2-40B4-BE49-F238E27FC236}">
+                <a16:creationId xmlns:a16="http://schemas.microsoft.com/office/drawing/2014/main" id="{0B3BAD94-27B5-46F6-9B61-BD254D4A1075}"/>
               </a:ext>
             </a:extLst>
           </p:cNvPr>
@@ -2956,10 +2836,10 @@
       </p:sp>
       <p:sp>
         <p:nvSpPr>
-          <p:cNvPr id="28" name="">
-            <a:extLst xmlns:a="http://schemas.openxmlformats.org/drawingml/2006/main">
-              <a:ext uri="{FF2B5EF4-FFF2-40B4-BE49-F238E27FC236}">
-                <a16:creationId xmlns:a16="http://schemas.microsoft.com/office/drawing/2014/main" id="{9F676848-2687-471E-808A-696BE6ED2D93}"/>
+          <p:cNvPr id="26" name="">
+            <a:extLst xmlns:a="http://schemas.openxmlformats.org/drawingml/2006/main">
+              <a:ext uri="{FF2B5EF4-FFF2-40B4-BE49-F238E27FC236}">
+                <a16:creationId xmlns:a16="http://schemas.microsoft.com/office/drawing/2014/main" id="{582296BF-F2B1-426F-9A8E-4F8C558744B8}"/>
               </a:ext>
             </a:extLst>
           </p:cNvPr>
@@ -2987,10 +2867,10 @@
       </p:sp>
       <p:sp>
         <p:nvSpPr>
-          <p:cNvPr id="29" name="flow-node-3-label">
-            <a:extLst xmlns:a="http://schemas.openxmlformats.org/drawingml/2006/main">
-              <a:ext uri="{FF2B5EF4-FFF2-40B4-BE49-F238E27FC236}">
-                <a16:creationId xmlns:a16="http://schemas.microsoft.com/office/drawing/2014/main" id="{C0BA09AF-86FE-4BCD-A91F-2720D2F2E689}"/>
+          <p:cNvPr id="27" name="flow-node-3-label">
+            <a:extLst xmlns:a="http://schemas.openxmlformats.org/drawingml/2006/main">
+              <a:ext uri="{FF2B5EF4-FFF2-40B4-BE49-F238E27FC236}">
+                <a16:creationId xmlns:a16="http://schemas.microsoft.com/office/drawing/2014/main" id="{94DE29F0-DFCF-472E-9B86-48FCB799BA32}"/>
               </a:ext>
             </a:extLst>
           </p:cNvPr>
@@ -3045,10 +2925,10 @@
       </p:sp>
       <p:sp>
         <p:nvSpPr>
-          <p:cNvPr id="30" name="flow-node-3-detail">
-            <a:extLst xmlns:a="http://schemas.openxmlformats.org/drawingml/2006/main">
-              <a:ext uri="{FF2B5EF4-FFF2-40B4-BE49-F238E27FC236}">
-                <a16:creationId xmlns:a16="http://schemas.microsoft.com/office/drawing/2014/main" id="{429423F0-3ADE-4178-91A8-0895527B2E95}"/>
+          <p:cNvPr id="28" name="flow-node-3-detail">
+            <a:extLst xmlns:a="http://schemas.openxmlformats.org/drawingml/2006/main">
+              <a:ext uri="{FF2B5EF4-FFF2-40B4-BE49-F238E27FC236}">
+                <a16:creationId xmlns:a16="http://schemas.microsoft.com/office/drawing/2014/main" id="{8307095F-D712-4186-AB93-893446193270}"/>
               </a:ext>
             </a:extLst>
           </p:cNvPr>
@@ -3103,10 +2983,10 @@
       </p:sp>
       <p:sp>
         <p:nvSpPr>
-          <p:cNvPr id="31" name="flow-node-4">
-            <a:extLst xmlns:a="http://schemas.openxmlformats.org/drawingml/2006/main">
-              <a:ext uri="{FF2B5EF4-FFF2-40B4-BE49-F238E27FC236}">
-                <a16:creationId xmlns:a16="http://schemas.microsoft.com/office/drawing/2014/main" id="{DF10C7DB-1DB8-472C-89D1-EE5B07EDE70B}"/>
+          <p:cNvPr id="29" name="flow-node-4">
+            <a:extLst xmlns:a="http://schemas.openxmlformats.org/drawingml/2006/main">
+              <a:ext uri="{FF2B5EF4-FFF2-40B4-BE49-F238E27FC236}">
+                <a16:creationId xmlns:a16="http://schemas.microsoft.com/office/drawing/2014/main" id="{D065F809-4254-4E9C-8156-09EBB1F32A31}"/>
               </a:ext>
             </a:extLst>
           </p:cNvPr>
@@ -3136,10 +3016,10 @@
       </p:sp>
       <p:sp>
         <p:nvSpPr>
-          <p:cNvPr id="32" name="">
-            <a:extLst xmlns:a="http://schemas.openxmlformats.org/drawingml/2006/main">
-              <a:ext uri="{FF2B5EF4-FFF2-40B4-BE49-F238E27FC236}">
-                <a16:creationId xmlns:a16="http://schemas.microsoft.com/office/drawing/2014/main" id="{4761A4C8-AAF5-4DAE-928A-2C7FF8FC24F0}"/>
+          <p:cNvPr id="30" name="">
+            <a:extLst xmlns:a="http://schemas.openxmlformats.org/drawingml/2006/main">
+              <a:ext uri="{FF2B5EF4-FFF2-40B4-BE49-F238E27FC236}">
+                <a16:creationId xmlns:a16="http://schemas.microsoft.com/office/drawing/2014/main" id="{BDC29195-799B-40CA-BD06-5074DE5ED449}"/>
               </a:ext>
             </a:extLst>
           </p:cNvPr>
@@ -3167,10 +3047,10 @@
       </p:sp>
       <p:sp>
         <p:nvSpPr>
-          <p:cNvPr id="33" name="flow-node-4-label">
-            <a:extLst xmlns:a="http://schemas.openxmlformats.org/drawingml/2006/main">
-              <a:ext uri="{FF2B5EF4-FFF2-40B4-BE49-F238E27FC236}">
-                <a16:creationId xmlns:a16="http://schemas.microsoft.com/office/drawing/2014/main" id="{79ED33A6-6FFC-4891-A2C1-51056015D141}"/>
+          <p:cNvPr id="31" name="flow-node-4-label">
+            <a:extLst xmlns:a="http://schemas.openxmlformats.org/drawingml/2006/main">
+              <a:ext uri="{FF2B5EF4-FFF2-40B4-BE49-F238E27FC236}">
+                <a16:creationId xmlns:a16="http://schemas.microsoft.com/office/drawing/2014/main" id="{F3F58560-7671-4E13-8882-9D60D9503627}"/>
               </a:ext>
             </a:extLst>
           </p:cNvPr>
@@ -3183,64 +3063,6 @@
           <a:xfrm xmlns:a="http://schemas.openxmlformats.org/drawingml/2006/main">
             <a:off x="9563100" y="2857500"/>
             <a:ext cx="1695450" cy="285750"/>
-          </a:xfrm>
-          <a:prstGeom xmlns:a="http://schemas.openxmlformats.org/drawingml/2006/main" prst="rect">
-            <a:avLst/>
-          </a:prstGeom>
-          <a:noFill xmlns:a="http://schemas.openxmlformats.org/drawingml/2006/main"/>
-          <a:ln xmlns:a="http://schemas.openxmlformats.org/drawingml/2006/main" w="0">
-            <a:noFill/>
-            <a:prstDash val="solid"/>
-          </a:ln>
-        </p:spPr>
-        <p:txBody>
-          <a:bodyPr xmlns:a="http://schemas.openxmlformats.org/drawingml/2006/main" lIns="0" tIns="0" rIns="0" bIns="0" anchor="t">
-            <a:normAutofit fontScale="92471"/>
-          </a:bodyPr>
-          <a:lstStyle xmlns:a="http://schemas.openxmlformats.org/drawingml/2006/main"/>
-          <a:p xmlns:a="http://schemas.openxmlformats.org/drawingml/2006/main">
-            <a:pPr algn="l">
-              <a:defRPr sz="1425" b="0">
-                <a:solidFill>
-                  <a:srgbClr val="FAFAFA"/>
-                </a:solidFill>
-                <a:latin typeface="Space Grotesk"/>
-                <a:ea typeface="Space Grotesk"/>
-                <a:cs typeface="Space Grotesk"/>
-              </a:defRPr>
-            </a:pPr>
-            <a:r>
-              <a:rPr sz="1425" b="0">
-                <a:solidFill>
-                  <a:srgbClr val="FAFAFA"/>
-                </a:solidFill>
-                <a:latin typeface="Space Grotesk"/>
-                <a:ea typeface="Space Grotesk"/>
-                <a:cs typeface="Space Grotesk"/>
-              </a:rPr>
-              <a:t>Original escrow settles</a:t>
-            </a:r>
-          </a:p>
-        </p:txBody>
-      </p:sp>
-      <p:sp>
-        <p:nvSpPr>
-          <p:cNvPr id="34" name="flow-node-4-detail">
-            <a:extLst xmlns:a="http://schemas.openxmlformats.org/drawingml/2006/main">
-              <a:ext uri="{FF2B5EF4-FFF2-40B4-BE49-F238E27FC236}">
-                <a16:creationId xmlns:a16="http://schemas.microsoft.com/office/drawing/2014/main" id="{B8C229AC-40EC-498F-88EA-271961897B32}"/>
-              </a:ext>
-            </a:extLst>
-          </p:cNvPr>
-          <p:cNvSpPr>
-            <a:spLocks xmlns:a="http://schemas.openxmlformats.org/drawingml/2006/main" noGrp="1"/>
-          </p:cNvSpPr>
-          <p:nvPr/>
-        </p:nvSpPr>
-        <p:spPr>
-          <a:xfrm xmlns:a="http://schemas.openxmlformats.org/drawingml/2006/main">
-            <a:off x="9563100" y="3200400"/>
-            <a:ext cx="1695450" cy="400050"/>
           </a:xfrm>
           <a:prstGeom xmlns:a="http://schemas.openxmlformats.org/drawingml/2006/main" prst="rect">
             <a:avLst/>
@@ -3258,9 +3080,9 @@
           <a:lstStyle xmlns:a="http://schemas.openxmlformats.org/drawingml/2006/main"/>
           <a:p xmlns:a="http://schemas.openxmlformats.org/drawingml/2006/main">
             <a:pPr algn="l">
-              <a:defRPr sz="1050" b="0">
-                <a:solidFill>
-                  <a:srgbClr val="B0B0AB"/>
+              <a:defRPr sz="1425" b="0">
+                <a:solidFill>
+                  <a:srgbClr val="FAFAFA"/>
                 </a:solidFill>
                 <a:latin typeface="Space Grotesk"/>
                 <a:ea typeface="Space Grotesk"/>
@@ -3268,6 +3090,64 @@
               </a:defRPr>
             </a:pPr>
             <a:r>
+              <a:rPr sz="1425" b="0">
+                <a:solidFill>
+                  <a:srgbClr val="FAFAFA"/>
+                </a:solidFill>
+                <a:latin typeface="Space Grotesk"/>
+                <a:ea typeface="Space Grotesk"/>
+                <a:cs typeface="Space Grotesk"/>
+              </a:rPr>
+              <a:t>Escrow settles</a:t>
+            </a:r>
+          </a:p>
+        </p:txBody>
+      </p:sp>
+      <p:sp>
+        <p:nvSpPr>
+          <p:cNvPr id="32" name="flow-node-4-detail">
+            <a:extLst xmlns:a="http://schemas.openxmlformats.org/drawingml/2006/main">
+              <a:ext uri="{FF2B5EF4-FFF2-40B4-BE49-F238E27FC236}">
+                <a16:creationId xmlns:a16="http://schemas.microsoft.com/office/drawing/2014/main" id="{D299FC6C-3687-4E08-90C1-CF85E7C4C481}"/>
+              </a:ext>
+            </a:extLst>
+          </p:cNvPr>
+          <p:cNvSpPr>
+            <a:spLocks xmlns:a="http://schemas.openxmlformats.org/drawingml/2006/main" noGrp="1"/>
+          </p:cNvSpPr>
+          <p:nvPr/>
+        </p:nvSpPr>
+        <p:spPr>
+          <a:xfrm xmlns:a="http://schemas.openxmlformats.org/drawingml/2006/main">
+            <a:off x="9563100" y="3200400"/>
+            <a:ext cx="1695450" cy="400050"/>
+          </a:xfrm>
+          <a:prstGeom xmlns:a="http://schemas.openxmlformats.org/drawingml/2006/main" prst="rect">
+            <a:avLst/>
+          </a:prstGeom>
+          <a:noFill xmlns:a="http://schemas.openxmlformats.org/drawingml/2006/main"/>
+          <a:ln xmlns:a="http://schemas.openxmlformats.org/drawingml/2006/main" w="0">
+            <a:noFill/>
+            <a:prstDash val="solid"/>
+          </a:ln>
+        </p:spPr>
+        <p:txBody>
+          <a:bodyPr xmlns:a="http://schemas.openxmlformats.org/drawingml/2006/main" lIns="0" tIns="0" rIns="0" bIns="0" anchor="t">
+            <a:normAutofit fontScale="100000"/>
+          </a:bodyPr>
+          <a:lstStyle xmlns:a="http://schemas.openxmlformats.org/drawingml/2006/main"/>
+          <a:p xmlns:a="http://schemas.openxmlformats.org/drawingml/2006/main">
+            <a:pPr algn="l">
+              <a:defRPr sz="1050" b="0">
+                <a:solidFill>
+                  <a:srgbClr val="B0B0AB"/>
+                </a:solidFill>
+                <a:latin typeface="Space Grotesk"/>
+                <a:ea typeface="Space Grotesk"/>
+                <a:cs typeface="Space Grotesk"/>
+              </a:defRPr>
+            </a:pPr>
+            <a:r>
               <a:rPr sz="1050" b="0">
                 <a:solidFill>
                   <a:srgbClr val="B0B0AB"/>
@@ -3276,17 +3156,17 @@
                 <a:ea typeface="Space Grotesk"/>
                 <a:cs typeface="Space Grotesk"/>
               </a:rPr>
-              <a:t>The job completes or rejects on Arc.</a:t>
-            </a:r>
-          </a:p>
-        </p:txBody>
-      </p:sp>
-      <p:sp>
-        <p:nvSpPr>
-          <p:cNvPr id="35" name="key-note">
-            <a:extLst xmlns:a="http://schemas.openxmlformats.org/drawingml/2006/main">
-              <a:ext uri="{FF2B5EF4-FFF2-40B4-BE49-F238E27FC236}">
-                <a16:creationId xmlns:a16="http://schemas.microsoft.com/office/drawing/2014/main" id="{0F3C3020-1557-4A9C-BC20-3D8E1A64C801}"/>
+              <a:t>Funds go to the freelancer or back to the client.</a:t>
+            </a:r>
+          </a:p>
+        </p:txBody>
+      </p:sp>
+      <p:sp>
+        <p:nvSpPr>
+          <p:cNvPr id="33" name="key-note">
+            <a:extLst xmlns:a="http://schemas.openxmlformats.org/drawingml/2006/main">
+              <a:ext uri="{FF2B5EF4-FFF2-40B4-BE49-F238E27FC236}">
+                <a16:creationId xmlns:a16="http://schemas.microsoft.com/office/drawing/2014/main" id="{E9616B5C-B7D7-4686-AA4D-0269FA689DF4}"/>
               </a:ext>
             </a:extLst>
           </p:cNvPr>
@@ -3316,10 +3196,10 @@
       </p:sp>
       <p:sp>
         <p:nvSpPr>
-          <p:cNvPr id="36" name="">
-            <a:extLst xmlns:a="http://schemas.openxmlformats.org/drawingml/2006/main">
-              <a:ext uri="{FF2B5EF4-FFF2-40B4-BE49-F238E27FC236}">
-                <a16:creationId xmlns:a16="http://schemas.microsoft.com/office/drawing/2014/main" id="{2DF921CB-675F-44CF-A069-AC08D6D81E67}"/>
+          <p:cNvPr id="34" name="">
+            <a:extLst xmlns:a="http://schemas.openxmlformats.org/drawingml/2006/main">
+              <a:ext uri="{FF2B5EF4-FFF2-40B4-BE49-F238E27FC236}">
+                <a16:creationId xmlns:a16="http://schemas.microsoft.com/office/drawing/2014/main" id="{8907CED1-1141-4B58-8916-B790CFAE1820}"/>
               </a:ext>
             </a:extLst>
           </p:cNvPr>
@@ -3347,10 +3227,10 @@
       </p:sp>
       <p:sp>
         <p:nvSpPr>
-          <p:cNvPr id="37" name="key-note-text">
-            <a:extLst xmlns:a="http://schemas.openxmlformats.org/drawingml/2006/main">
-              <a:ext uri="{FF2B5EF4-FFF2-40B4-BE49-F238E27FC236}">
-                <a16:creationId xmlns:a16="http://schemas.microsoft.com/office/drawing/2014/main" id="{76E4ABA6-1C79-4633-A5D6-595B8F9E94F9}"/>
+          <p:cNvPr id="35" name="key-note-text">
+            <a:extLst xmlns:a="http://schemas.openxmlformats.org/drawingml/2006/main">
+              <a:ext uri="{FF2B5EF4-FFF2-40B4-BE49-F238E27FC236}">
+                <a16:creationId xmlns:a16="http://schemas.microsoft.com/office/drawing/2014/main" id="{D635479E-56F0-4D87-9667-372170FE8F7B}"/>
               </a:ext>
             </a:extLst>
           </p:cNvPr>
@@ -3398,154 +3278,7 @@
                 <a:ea typeface="Space Grotesk"/>
                 <a:cs typeface="Space Grotesk"/>
               </a:rPr>
-              <a:t>The model never holds a signing key. Code checks its response before the restricted oracle submits a transaction.</a:t>
-            </a:r>
-          </a:p>
-        </p:txBody>
-      </p:sp>
-      <p:sp>
-        <p:nvSpPr>
-          <p:cNvPr id="38" name="">
-            <a:extLst xmlns:a="http://schemas.openxmlformats.org/drawingml/2006/main">
-              <a:ext uri="{FF2B5EF4-FFF2-40B4-BE49-F238E27FC236}">
-                <a16:creationId xmlns:a16="http://schemas.microsoft.com/office/drawing/2014/main" id="{679AE5D9-3D9E-446E-8C6A-B1572D60E844}"/>
-              </a:ext>
-            </a:extLst>
-          </p:cNvPr>
-          <p:cNvSpPr>
-            <a:spLocks xmlns:a="http://schemas.openxmlformats.org/drawingml/2006/main" noGrp="1"/>
-          </p:cNvSpPr>
-          <p:nvPr/>
-        </p:nvSpPr>
-        <p:spPr>
-          <a:xfrm xmlns:a="http://schemas.openxmlformats.org/drawingml/2006/main">
-            <a:off x="685800" y="6334125"/>
-            <a:ext cx="10820400" cy="9525"/>
-          </a:xfrm>
-          <a:prstGeom xmlns:a="http://schemas.openxmlformats.org/drawingml/2006/main" prst="rect">
-            <a:avLst/>
-          </a:prstGeom>
-          <a:solidFill xmlns:a="http://schemas.openxmlformats.org/drawingml/2006/main">
-            <a:srgbClr val="2B2B2B"/>
-          </a:solidFill>
-          <a:ln xmlns:a="http://schemas.openxmlformats.org/drawingml/2006/main" w="0">
-            <a:noFill/>
-            <a:prstDash val="solid"/>
-          </a:ln>
-        </p:spPr>
-      </p:sp>
-      <p:sp>
-        <p:nvSpPr>
-          <p:cNvPr id="39" name="footer-left">
-            <a:extLst xmlns:a="http://schemas.openxmlformats.org/drawingml/2006/main">
-              <a:ext uri="{FF2B5EF4-FFF2-40B4-BE49-F238E27FC236}">
-                <a16:creationId xmlns:a16="http://schemas.microsoft.com/office/drawing/2014/main" id="{EFD3DBAD-C492-4591-B405-3466F3D1F97A}"/>
-              </a:ext>
-            </a:extLst>
-          </p:cNvPr>
-          <p:cNvSpPr>
-            <a:spLocks xmlns:a="http://schemas.openxmlformats.org/drawingml/2006/main" noGrp="1"/>
-          </p:cNvSpPr>
-          <p:nvPr/>
-        </p:nvSpPr>
-        <p:spPr>
-          <a:xfrm xmlns:a="http://schemas.openxmlformats.org/drawingml/2006/main">
-            <a:off x="685800" y="6467475"/>
-            <a:ext cx="4381500" cy="190500"/>
-          </a:xfrm>
-          <a:prstGeom xmlns:a="http://schemas.openxmlformats.org/drawingml/2006/main" prst="rect">
-            <a:avLst/>
-          </a:prstGeom>
-          <a:noFill xmlns:a="http://schemas.openxmlformats.org/drawingml/2006/main"/>
-          <a:ln xmlns:a="http://schemas.openxmlformats.org/drawingml/2006/main" w="0">
-            <a:noFill/>
-            <a:prstDash val="solid"/>
-          </a:ln>
-        </p:spPr>
-        <p:txBody>
-          <a:bodyPr xmlns:a="http://schemas.openxmlformats.org/drawingml/2006/main" lIns="0" tIns="0" rIns="0" bIns="0" anchor="t">
-            <a:normAutofit fontScale="100000"/>
-          </a:bodyPr>
-          <a:lstStyle xmlns:a="http://schemas.openxmlformats.org/drawingml/2006/main"/>
-          <a:p xmlns:a="http://schemas.openxmlformats.org/drawingml/2006/main">
-            <a:pPr algn="l">
-              <a:defRPr sz="900" b="0">
-                <a:solidFill>
-                  <a:srgbClr val="94948E"/>
-                </a:solidFill>
-                <a:latin typeface="Space Grotesk"/>
-                <a:ea typeface="Space Grotesk"/>
-                <a:cs typeface="Space Grotesk"/>
-              </a:defRPr>
-            </a:pPr>
-            <a:r>
-              <a:rPr sz="900" b="0">
-                <a:solidFill>
-                  <a:srgbClr val="94948E"/>
-                </a:solidFill>
-                <a:latin typeface="Space Grotesk"/>
-                <a:ea typeface="Space Grotesk"/>
-                <a:cs typeface="Space Grotesk"/>
-              </a:rPr>
-              <a:t>Circle Arc Hackathon · Checkpoint 2</a:t>
-            </a:r>
-          </a:p>
-        </p:txBody>
-      </p:sp>
-      <p:sp>
-        <p:nvSpPr>
-          <p:cNvPr id="40" name="footer-right">
-            <a:extLst xmlns:a="http://schemas.openxmlformats.org/drawingml/2006/main">
-              <a:ext uri="{FF2B5EF4-FFF2-40B4-BE49-F238E27FC236}">
-                <a16:creationId xmlns:a16="http://schemas.microsoft.com/office/drawing/2014/main" id="{A0417778-3357-4424-9AC8-AADD3E9C38A1}"/>
-              </a:ext>
-            </a:extLst>
-          </p:cNvPr>
-          <p:cNvSpPr>
-            <a:spLocks xmlns:a="http://schemas.openxmlformats.org/drawingml/2006/main" noGrp="1"/>
-          </p:cNvSpPr>
-          <p:nvPr/>
-        </p:nvSpPr>
-        <p:spPr>
-          <a:xfrm xmlns:a="http://schemas.openxmlformats.org/drawingml/2006/main">
-            <a:off x="9220200" y="6467475"/>
-            <a:ext cx="2286000" cy="190500"/>
-          </a:xfrm>
-          <a:prstGeom xmlns:a="http://schemas.openxmlformats.org/drawingml/2006/main" prst="rect">
-            <a:avLst/>
-          </a:prstGeom>
-          <a:noFill xmlns:a="http://schemas.openxmlformats.org/drawingml/2006/main"/>
-          <a:ln xmlns:a="http://schemas.openxmlformats.org/drawingml/2006/main" w="0">
-            <a:noFill/>
-            <a:prstDash val="solid"/>
-          </a:ln>
-        </p:spPr>
-        <p:txBody>
-          <a:bodyPr xmlns:a="http://schemas.openxmlformats.org/drawingml/2006/main" lIns="0" tIns="0" rIns="0" bIns="0" anchor="t">
-            <a:normAutofit fontScale="100000"/>
-          </a:bodyPr>
-          <a:lstStyle xmlns:a="http://schemas.openxmlformats.org/drawingml/2006/main"/>
-          <a:p xmlns:a="http://schemas.openxmlformats.org/drawingml/2006/main">
-            <a:pPr algn="r">
-              <a:defRPr sz="900" b="0">
-                <a:solidFill>
-                  <a:srgbClr val="94948E"/>
-                </a:solidFill>
-                <a:latin typeface="Space Grotesk"/>
-                <a:ea typeface="Space Grotesk"/>
-                <a:cs typeface="Space Grotesk"/>
-              </a:defRPr>
-            </a:pPr>
-            <a:r>
-              <a:rPr sz="900" b="0">
-                <a:solidFill>
-                  <a:srgbClr val="94948E"/>
-                </a:solidFill>
-                <a:latin typeface="Space Grotesk"/>
-                <a:ea typeface="Space Grotesk"/>
-                <a:cs typeface="Space Grotesk"/>
-              </a:rPr>
-              <a:t>Agentic Economy</a:t>
+              <a:t>AI never signs transactions. The router checks its verdict before the oracle submits it.</a:t>
             </a:r>
           </a:p>
         </p:txBody>
@@ -3553,7 +3286,7 @@
     </p:spTree>
     <p:extLst>
       <p:ext uri="{BB962C8B-B14F-4D97-AF65-F5344CB8AC3E}">
-        <p14:creationId xmlns:p14="http://schemas.microsoft.com/office/powerpoint/2010/main" val="1039403826"/>
+        <p14:creationId xmlns:p14="http://schemas.microsoft.com/office/powerpoint/2010/main" val="987721780"/>
       </p:ext>
     </p:extLst>
   </p:cSld>
@@ -3581,22 +3314,22 @@
       </p:grpSpPr>
       <p:sp>
         <p:nvSpPr>
-          <p:cNvPr id="27" name="section-3">
-            <a:extLst xmlns:a="http://schemas.openxmlformats.org/drawingml/2006/main">
-              <a:ext uri="{FF2B5EF4-FFF2-40B4-BE49-F238E27FC236}">
-                <a16:creationId xmlns:a16="http://schemas.microsoft.com/office/drawing/2014/main" id="{0EBC983A-4B75-4EC4-B17C-8956FDA7D0BB}"/>
-              </a:ext>
-            </a:extLst>
-          </p:cNvPr>
-          <p:cNvSpPr>
-            <a:spLocks xmlns:a="http://schemas.openxmlformats.org/drawingml/2006/main" noGrp="1"/>
-          </p:cNvSpPr>
-          <p:nvPr/>
-        </p:nvSpPr>
-        <p:spPr>
-          <a:xfrm xmlns:a="http://schemas.openxmlformats.org/drawingml/2006/main">
-            <a:off x="685800" y="304800"/>
-            <a:ext cx="3048000" cy="190500"/>
+          <p:cNvPr id="22" name="page-3">
+            <a:extLst xmlns:a="http://schemas.openxmlformats.org/drawingml/2006/main">
+              <a:ext uri="{FF2B5EF4-FFF2-40B4-BE49-F238E27FC236}">
+                <a16:creationId xmlns:a16="http://schemas.microsoft.com/office/drawing/2014/main" id="{68A44C92-FC81-4141-8FF0-3C953E950637}"/>
+              </a:ext>
+            </a:extLst>
+          </p:cNvPr>
+          <p:cNvSpPr>
+            <a:spLocks xmlns:a="http://schemas.openxmlformats.org/drawingml/2006/main" noGrp="1"/>
+          </p:cNvSpPr>
+          <p:nvPr/>
+        </p:nvSpPr>
+        <p:spPr>
+          <a:xfrm xmlns:a="http://schemas.openxmlformats.org/drawingml/2006/main">
+            <a:off x="10648950" y="304800"/>
+            <a:ext cx="857250" cy="190500"/>
           </a:xfrm>
           <a:prstGeom xmlns:a="http://schemas.openxmlformats.org/drawingml/2006/main" prst="rect">
             <a:avLst/>
@@ -3613,14 +3346,14 @@
           </a:bodyPr>
           <a:lstStyle xmlns:a="http://schemas.openxmlformats.org/drawingml/2006/main"/>
           <a:p xmlns:a="http://schemas.openxmlformats.org/drawingml/2006/main">
-            <a:pPr algn="l">
+            <a:pPr algn="r">
               <a:defRPr sz="975" b="0">
                 <a:solidFill>
                   <a:srgbClr val="94948E"/>
                 </a:solidFill>
-                <a:latin typeface="Space Grotesk"/>
-                <a:ea typeface="Space Grotesk"/>
-                <a:cs typeface="Space Grotesk"/>
+                <a:latin typeface="IBM Plex Mono"/>
+                <a:ea typeface="IBM Plex Mono"/>
+                <a:cs typeface="IBM Plex Mono"/>
               </a:defRPr>
             </a:pPr>
             <a:r>
@@ -3628,83 +3361,21 @@
                 <a:solidFill>
                   <a:srgbClr val="94948E"/>
                 </a:solidFill>
-                <a:latin typeface="Space Grotesk"/>
-                <a:ea typeface="Space Grotesk"/>
-                <a:cs typeface="Space Grotesk"/>
+                <a:latin typeface="IBM Plex Mono"/>
+                <a:ea typeface="IBM Plex Mono"/>
+                <a:cs typeface="IBM Plex Mono"/>
               </a:rPr>
-              <a:t>vAPI Trust Network  ·  03</a:t>
-            </a:r>
-          </a:p>
-        </p:txBody>
-      </p:sp>
-      <p:sp>
-        <p:nvSpPr>
-          <p:cNvPr id="2" name="">
-            <a:extLst xmlns:a="http://schemas.openxmlformats.org/drawingml/2006/main">
-              <a:ext uri="{FF2B5EF4-FFF2-40B4-BE49-F238E27FC236}">
-                <a16:creationId xmlns:a16="http://schemas.microsoft.com/office/drawing/2014/main" id="{EAC7B5F1-C62C-4A98-A6AD-BC56085C5585}"/>
-              </a:ext>
-            </a:extLst>
-          </p:cNvPr>
-          <p:cNvSpPr>
-            <a:spLocks xmlns:a="http://schemas.openxmlformats.org/drawingml/2006/main" noGrp="1"/>
-          </p:cNvSpPr>
-          <p:nvPr/>
-        </p:nvSpPr>
-        <p:spPr>
-          <a:xfrm xmlns:a="http://schemas.openxmlformats.org/drawingml/2006/main">
-            <a:off x="685800" y="581025"/>
-            <a:ext cx="10820400" cy="9525"/>
-          </a:xfrm>
-          <a:prstGeom xmlns:a="http://schemas.openxmlformats.org/drawingml/2006/main" prst="rect">
-            <a:avLst/>
-          </a:prstGeom>
-          <a:solidFill xmlns:a="http://schemas.openxmlformats.org/drawingml/2006/main">
-            <a:srgbClr val="2B2B2B"/>
-          </a:solidFill>
-          <a:ln xmlns:a="http://schemas.openxmlformats.org/drawingml/2006/main" w="0">
-            <a:noFill/>
-            <a:prstDash val="solid"/>
-          </a:ln>
-        </p:spPr>
-      </p:sp>
-      <p:sp>
-        <p:nvSpPr>
-          <p:cNvPr id="3" name="">
-            <a:extLst xmlns:a="http://schemas.openxmlformats.org/drawingml/2006/main">
-              <a:ext uri="{FF2B5EF4-FFF2-40B4-BE49-F238E27FC236}">
-                <a16:creationId xmlns:a16="http://schemas.microsoft.com/office/drawing/2014/main" id="{2233FD1C-34E0-430F-9211-BE5285D03E02}"/>
-              </a:ext>
-            </a:extLst>
-          </p:cNvPr>
-          <p:cNvSpPr>
-            <a:spLocks xmlns:a="http://schemas.openxmlformats.org/drawingml/2006/main" noGrp="1"/>
-          </p:cNvSpPr>
-          <p:nvPr/>
-        </p:nvSpPr>
-        <p:spPr>
-          <a:xfrm xmlns:a="http://schemas.openxmlformats.org/drawingml/2006/main">
-            <a:off x="11410950" y="304800"/>
-            <a:ext cx="95250" cy="95250"/>
-          </a:xfrm>
-          <a:prstGeom xmlns:a="http://schemas.openxmlformats.org/drawingml/2006/main" prst="rect">
-            <a:avLst/>
-          </a:prstGeom>
-          <a:solidFill xmlns:a="http://schemas.openxmlformats.org/drawingml/2006/main">
-            <a:srgbClr val="FF7300"/>
-          </a:solidFill>
-          <a:ln xmlns:a="http://schemas.openxmlformats.org/drawingml/2006/main" w="0">
-            <a:noFill/>
-            <a:prstDash val="solid"/>
-          </a:ln>
-        </p:spPr>
-      </p:sp>
-      <p:sp>
-        <p:nvSpPr>
-          <p:cNvPr id="4" name="slide-title">
-            <a:extLst xmlns:a="http://schemas.openxmlformats.org/drawingml/2006/main">
-              <a:ext uri="{FF2B5EF4-FFF2-40B4-BE49-F238E27FC236}">
-                <a16:creationId xmlns:a16="http://schemas.microsoft.com/office/drawing/2014/main" id="{5F01851D-140F-40F0-AEA4-9EA2304E926D}"/>
+              <a:t>03 / 05</a:t>
+            </a:r>
+          </a:p>
+        </p:txBody>
+      </p:sp>
+      <p:sp>
+        <p:nvSpPr>
+          <p:cNvPr id="2" name="slide-title">
+            <a:extLst xmlns:a="http://schemas.openxmlformats.org/drawingml/2006/main">
+              <a:ext uri="{FF2B5EF4-FFF2-40B4-BE49-F238E27FC236}">
+                <a16:creationId xmlns:a16="http://schemas.microsoft.com/office/drawing/2014/main" id="{DC318346-BEB5-4854-9F83-EF3FB64B3615}"/>
               </a:ext>
             </a:extLst>
           </p:cNvPr>
@@ -3752,17 +3423,17 @@
                 <a:ea typeface="Space Grotesk"/>
                 <a:cs typeface="Space Grotesk"/>
               </a:rPr>
-              <a:t>A review costs 0.25 USDC. The auditor earns 0.20.</a:t>
-            </a:r>
-          </a:p>
-        </p:txBody>
-      </p:sp>
-      <p:sp>
-        <p:nvSpPr>
-          <p:cNvPr id="5" name="">
-            <a:extLst xmlns:a="http://schemas.openxmlformats.org/drawingml/2006/main">
-              <a:ext uri="{FF2B5EF4-FFF2-40B4-BE49-F238E27FC236}">
-                <a16:creationId xmlns:a16="http://schemas.microsoft.com/office/drawing/2014/main" id="{8C634FEC-7D7B-459D-99CD-13A7A8DE2577}"/>
+              <a:t>The agent pays 0.25 USDC. The auditor receives 0.20.</a:t>
+            </a:r>
+          </a:p>
+        </p:txBody>
+      </p:sp>
+      <p:sp>
+        <p:nvSpPr>
+          <p:cNvPr id="3" name="">
+            <a:extLst xmlns:a="http://schemas.openxmlformats.org/drawingml/2006/main">
+              <a:ext uri="{FF2B5EF4-FFF2-40B4-BE49-F238E27FC236}">
+                <a16:creationId xmlns:a16="http://schemas.microsoft.com/office/drawing/2014/main" id="{7F3E92B3-D625-49D3-80B7-FBEA01D4BBD2}"/>
               </a:ext>
             </a:extLst>
           </p:cNvPr>
@@ -3790,10 +3461,10 @@
       </p:sp>
       <p:sp>
         <p:nvSpPr>
-          <p:cNvPr id="6" name="">
-            <a:extLst xmlns:a="http://schemas.openxmlformats.org/drawingml/2006/main">
-              <a:ext uri="{FF2B5EF4-FFF2-40B4-BE49-F238E27FC236}">
-                <a16:creationId xmlns:a16="http://schemas.microsoft.com/office/drawing/2014/main" id="{3677915C-C220-4A6A-95DE-56AB0590AF18}"/>
+          <p:cNvPr id="4" name="">
+            <a:extLst xmlns:a="http://schemas.openxmlformats.org/drawingml/2006/main">
+              <a:ext uri="{FF2B5EF4-FFF2-40B4-BE49-F238E27FC236}">
+                <a16:creationId xmlns:a16="http://schemas.microsoft.com/office/drawing/2014/main" id="{B30AD57B-FD13-4717-AF46-991D535512CC}"/>
               </a:ext>
             </a:extLst>
           </p:cNvPr>
@@ -3821,10 +3492,10 @@
       </p:sp>
       <p:sp>
         <p:nvSpPr>
-          <p:cNvPr id="7" name="review-step-0-label">
-            <a:extLst xmlns:a="http://schemas.openxmlformats.org/drawingml/2006/main">
-              <a:ext uri="{FF2B5EF4-FFF2-40B4-BE49-F238E27FC236}">
-                <a16:creationId xmlns:a16="http://schemas.microsoft.com/office/drawing/2014/main" id="{552D648A-CBD6-4C17-B4BE-FD5853851665}"/>
+          <p:cNvPr id="5" name="review-step-0-label">
+            <a:extLst xmlns:a="http://schemas.openxmlformats.org/drawingml/2006/main">
+              <a:ext uri="{FF2B5EF4-FFF2-40B4-BE49-F238E27FC236}">
+                <a16:creationId xmlns:a16="http://schemas.microsoft.com/office/drawing/2014/main" id="{9067691B-F672-483F-A7AA-917EA3588AC4}"/>
               </a:ext>
             </a:extLst>
           </p:cNvPr>
@@ -3872,17 +3543,17 @@
                 <a:ea typeface="Space Grotesk"/>
                 <a:cs typeface="Space Grotesk"/>
               </a:rPr>
-              <a:t>Circle Gateway accepts the x402 payment</a:t>
-            </a:r>
-          </a:p>
-        </p:txBody>
-      </p:sp>
-      <p:sp>
-        <p:nvSpPr>
-          <p:cNvPr id="8" name="review-step-0-detail">
-            <a:extLst xmlns:a="http://schemas.openxmlformats.org/drawingml/2006/main">
-              <a:ext uri="{FF2B5EF4-FFF2-40B4-BE49-F238E27FC236}">
-                <a16:creationId xmlns:a16="http://schemas.microsoft.com/office/drawing/2014/main" id="{BA836001-164B-488D-9C88-C4C924CAEA4C}"/>
+              <a:t>The agent pays through Circle Gateway</a:t>
+            </a:r>
+          </a:p>
+        </p:txBody>
+      </p:sp>
+      <p:sp>
+        <p:nvSpPr>
+          <p:cNvPr id="6" name="review-step-0-detail">
+            <a:extLst xmlns:a="http://schemas.openxmlformats.org/drawingml/2006/main">
+              <a:ext uri="{FF2B5EF4-FFF2-40B4-BE49-F238E27FC236}">
+                <a16:creationId xmlns:a16="http://schemas.microsoft.com/office/drawing/2014/main" id="{C5272944-EEEE-462E-8263-B66C45DF53F3}"/>
               </a:ext>
             </a:extLst>
           </p:cNvPr>
@@ -3930,17 +3601,17 @@
                 <a:ea typeface="Space Grotesk"/>
                 <a:cs typeface="Space Grotesk"/>
               </a:rPr>
-              <a:t>The review order is stored before dispatch.</a:t>
-            </a:r>
-          </a:p>
-        </p:txBody>
-      </p:sp>
-      <p:sp>
-        <p:nvSpPr>
-          <p:cNvPr id="9" name="">
-            <a:extLst xmlns:a="http://schemas.openxmlformats.org/drawingml/2006/main">
-              <a:ext uri="{FF2B5EF4-FFF2-40B4-BE49-F238E27FC236}">
-                <a16:creationId xmlns:a16="http://schemas.microsoft.com/office/drawing/2014/main" id="{74F90231-FBE6-449A-9C53-10F68E0F3296}"/>
+              <a:t>The service stores the review order.</a:t>
+            </a:r>
+          </a:p>
+        </p:txBody>
+      </p:sp>
+      <p:sp>
+        <p:nvSpPr>
+          <p:cNvPr id="7" name="">
+            <a:extLst xmlns:a="http://schemas.openxmlformats.org/drawingml/2006/main">
+              <a:ext uri="{FF2B5EF4-FFF2-40B4-BE49-F238E27FC236}">
+                <a16:creationId xmlns:a16="http://schemas.microsoft.com/office/drawing/2014/main" id="{27F3022F-40E9-47B7-A66B-4E02B29B0CC2}"/>
               </a:ext>
             </a:extLst>
           </p:cNvPr>
@@ -3968,10 +3639,10 @@
       </p:sp>
       <p:sp>
         <p:nvSpPr>
-          <p:cNvPr id="10" name="review-step-1-label">
-            <a:extLst xmlns:a="http://schemas.openxmlformats.org/drawingml/2006/main">
-              <a:ext uri="{FF2B5EF4-FFF2-40B4-BE49-F238E27FC236}">
-                <a16:creationId xmlns:a16="http://schemas.microsoft.com/office/drawing/2014/main" id="{C8BE5713-D479-4528-BA83-EA7FC3CE2CE7}"/>
+          <p:cNvPr id="8" name="review-step-1-label">
+            <a:extLst xmlns:a="http://schemas.openxmlformats.org/drawingml/2006/main">
+              <a:ext uri="{FF2B5EF4-FFF2-40B4-BE49-F238E27FC236}">
+                <a16:creationId xmlns:a16="http://schemas.microsoft.com/office/drawing/2014/main" id="{710E6A24-0B9F-4C3B-B6E8-BB8494E2AAA0}"/>
               </a:ext>
             </a:extLst>
           </p:cNvPr>
@@ -4019,17 +3690,17 @@
                 <a:ea typeface="Space Grotesk"/>
                 <a:cs typeface="Space Grotesk"/>
               </a:rPr>
-              <a:t>Telegram sends the job to allowlisted auditors</a:t>
-            </a:r>
-          </a:p>
-        </p:txBody>
-      </p:sp>
-      <p:sp>
-        <p:nvSpPr>
-          <p:cNvPr id="11" name="review-step-1-detail">
-            <a:extLst xmlns:a="http://schemas.openxmlformats.org/drawingml/2006/main">
-              <a:ext uri="{FF2B5EF4-FFF2-40B4-BE49-F238E27FC236}">
-                <a16:creationId xmlns:a16="http://schemas.microsoft.com/office/drawing/2014/main" id="{00F5BF43-CB89-4B39-ABDE-095668D54D2A}"/>
+              <a:t>Telegram sends the job to approved auditors</a:t>
+            </a:r>
+          </a:p>
+        </p:txBody>
+      </p:sp>
+      <p:sp>
+        <p:nvSpPr>
+          <p:cNvPr id="9" name="review-step-1-detail">
+            <a:extLst xmlns:a="http://schemas.openxmlformats.org/drawingml/2006/main">
+              <a:ext uri="{FF2B5EF4-FFF2-40B4-BE49-F238E27FC236}">
+                <a16:creationId xmlns:a16="http://schemas.microsoft.com/office/drawing/2014/main" id="{12C37DDA-41D9-4C72-8F86-1DC9114C88CA}"/>
               </a:ext>
             </a:extLst>
           </p:cNvPr>
@@ -4077,17 +3748,17 @@
                 <a:ea typeface="Space Grotesk"/>
                 <a:cs typeface="Space Grotesk"/>
               </a:rPr>
-              <a:t>The first eligible auditor can claim it.</a:t>
-            </a:r>
-          </a:p>
-        </p:txBody>
-      </p:sp>
-      <p:sp>
-        <p:nvSpPr>
-          <p:cNvPr id="12" name="">
-            <a:extLst xmlns:a="http://schemas.openxmlformats.org/drawingml/2006/main">
-              <a:ext uri="{FF2B5EF4-FFF2-40B4-BE49-F238E27FC236}">
-                <a16:creationId xmlns:a16="http://schemas.microsoft.com/office/drawing/2014/main" id="{3C3D7113-AA53-45DB-85CC-31A53975B067}"/>
+              <a:t>The first eligible claim wins.</a:t>
+            </a:r>
+          </a:p>
+        </p:txBody>
+      </p:sp>
+      <p:sp>
+        <p:nvSpPr>
+          <p:cNvPr id="10" name="">
+            <a:extLst xmlns:a="http://schemas.openxmlformats.org/drawingml/2006/main">
+              <a:ext uri="{FF2B5EF4-FFF2-40B4-BE49-F238E27FC236}">
+                <a16:creationId xmlns:a16="http://schemas.microsoft.com/office/drawing/2014/main" id="{505D756E-CAB1-47DF-B07F-FA9AA2B746B1}"/>
               </a:ext>
             </a:extLst>
           </p:cNvPr>
@@ -4115,10 +3786,10 @@
       </p:sp>
       <p:sp>
         <p:nvSpPr>
-          <p:cNvPr id="13" name="review-step-2-label">
-            <a:extLst xmlns:a="http://schemas.openxmlformats.org/drawingml/2006/main">
-              <a:ext uri="{FF2B5EF4-FFF2-40B4-BE49-F238E27FC236}">
-                <a16:creationId xmlns:a16="http://schemas.microsoft.com/office/drawing/2014/main" id="{D8868346-51DF-445A-A3AB-867BE7AE30D0}"/>
+          <p:cNvPr id="11" name="review-step-2-label">
+            <a:extLst xmlns:a="http://schemas.openxmlformats.org/drawingml/2006/main">
+              <a:ext uri="{FF2B5EF4-FFF2-40B4-BE49-F238E27FC236}">
+                <a16:creationId xmlns:a16="http://schemas.microsoft.com/office/drawing/2014/main" id="{6895FB20-7EE7-4D81-8DE1-2E522E986BDE}"/>
               </a:ext>
             </a:extLst>
           </p:cNvPr>
@@ -4166,17 +3837,17 @@
                 <a:ea typeface="Space Grotesk"/>
                 <a:cs typeface="Space Grotesk"/>
               </a:rPr>
-              <a:t>The auditor chooses approve or reject</a:t>
-            </a:r>
-          </a:p>
-        </p:txBody>
-      </p:sp>
-      <p:sp>
-        <p:nvSpPr>
-          <p:cNvPr id="14" name="review-step-2-detail">
-            <a:extLst xmlns:a="http://schemas.openxmlformats.org/drawingml/2006/main">
-              <a:ext uri="{FF2B5EF4-FFF2-40B4-BE49-F238E27FC236}">
-                <a16:creationId xmlns:a16="http://schemas.microsoft.com/office/drawing/2014/main" id="{DE48A94A-7D8D-4D2E-9E71-127B3E70D444}"/>
+              <a:t>The auditor approves or rejects</a:t>
+            </a:r>
+          </a:p>
+        </p:txBody>
+      </p:sp>
+      <p:sp>
+        <p:nvSpPr>
+          <p:cNvPr id="12" name="review-step-2-detail">
+            <a:extLst xmlns:a="http://schemas.openxmlformats.org/drawingml/2006/main">
+              <a:ext uri="{FF2B5EF4-FFF2-40B4-BE49-F238E27FC236}">
+                <a16:creationId xmlns:a16="http://schemas.microsoft.com/office/drawing/2014/main" id="{6FE4AAED-8B5C-4CE2-9E89-E77B24B0C1B6}"/>
               </a:ext>
             </a:extLst>
           </p:cNvPr>
@@ -4224,17 +3895,17 @@
                 <a:ea typeface="Space Grotesk"/>
                 <a:cs typeface="Space Grotesk"/>
               </a:rPr>
-              <a:t>A written reason is required.</a:t>
-            </a:r>
-          </a:p>
-        </p:txBody>
-      </p:sp>
-      <p:sp>
-        <p:nvSpPr>
-          <p:cNvPr id="15" name="">
-            <a:extLst xmlns:a="http://schemas.openxmlformats.org/drawingml/2006/main">
-              <a:ext uri="{FF2B5EF4-FFF2-40B4-BE49-F238E27FC236}">
-                <a16:creationId xmlns:a16="http://schemas.microsoft.com/office/drawing/2014/main" id="{B7E12091-0E31-4215-AA83-C559CC81FF0D}"/>
+              <a:t>They must write a reason.</a:t>
+            </a:r>
+          </a:p>
+        </p:txBody>
+      </p:sp>
+      <p:sp>
+        <p:nvSpPr>
+          <p:cNvPr id="13" name="">
+            <a:extLst xmlns:a="http://schemas.openxmlformats.org/drawingml/2006/main">
+              <a:ext uri="{FF2B5EF4-FFF2-40B4-BE49-F238E27FC236}">
+                <a16:creationId xmlns:a16="http://schemas.microsoft.com/office/drawing/2014/main" id="{6286A041-F8AA-45C1-BA5A-DED99CAFDE07}"/>
               </a:ext>
             </a:extLst>
           </p:cNvPr>
@@ -4262,10 +3933,10 @@
       </p:sp>
       <p:sp>
         <p:nvSpPr>
-          <p:cNvPr id="16" name="review-step-3-label">
-            <a:extLst xmlns:a="http://schemas.openxmlformats.org/drawingml/2006/main">
-              <a:ext uri="{FF2B5EF4-FFF2-40B4-BE49-F238E27FC236}">
-                <a16:creationId xmlns:a16="http://schemas.microsoft.com/office/drawing/2014/main" id="{272D5792-ACD2-4605-B3FB-9FFA70C185A7}"/>
+          <p:cNvPr id="14" name="review-step-3-label">
+            <a:extLst xmlns:a="http://schemas.openxmlformats.org/drawingml/2006/main">
+              <a:ext uri="{FF2B5EF4-FFF2-40B4-BE49-F238E27FC236}">
+                <a16:creationId xmlns:a16="http://schemas.microsoft.com/office/drawing/2014/main" id="{62FF97E7-557D-4287-8DB5-A0449DE60FAC}"/>
               </a:ext>
             </a:extLst>
           </p:cNvPr>
@@ -4313,17 +3984,17 @@
                 <a:ea typeface="Space Grotesk"/>
                 <a:cs typeface="Space Grotesk"/>
               </a:rPr>
-              <a:t>Circle Wallet pays the auditor and calls humanResolve</a:t>
-            </a:r>
-          </a:p>
-        </p:txBody>
-      </p:sp>
-      <p:sp>
-        <p:nvSpPr>
-          <p:cNvPr id="17" name="review-step-3-detail">
-            <a:extLst xmlns:a="http://schemas.openxmlformats.org/drawingml/2006/main">
-              <a:ext uri="{FF2B5EF4-FFF2-40B4-BE49-F238E27FC236}">
-                <a16:creationId xmlns:a16="http://schemas.microsoft.com/office/drawing/2014/main" id="{A5A037A4-07D9-4FA3-BF0D-A0FAC553FC02}"/>
+              <a:t>Circle Wallet pays the auditor</a:t>
+            </a:r>
+          </a:p>
+        </p:txBody>
+      </p:sp>
+      <p:sp>
+        <p:nvSpPr>
+          <p:cNvPr id="15" name="review-step-3-detail">
+            <a:extLst xmlns:a="http://schemas.openxmlformats.org/drawingml/2006/main">
+              <a:ext uri="{FF2B5EF4-FFF2-40B4-BE49-F238E27FC236}">
+                <a16:creationId xmlns:a16="http://schemas.microsoft.com/office/drawing/2014/main" id="{029AA003-A7BF-4F15-B9C8-52208B76C547}"/>
               </a:ext>
             </a:extLst>
           </p:cNvPr>
@@ -4371,17 +4042,17 @@
                 <a:ea typeface="Space Grotesk"/>
                 <a:cs typeface="Space Grotesk"/>
               </a:rPr>
-              <a:t>Arc records the reviewer, reward, evidence hash and payout transaction.</a:t>
-            </a:r>
-          </a:p>
-        </p:txBody>
-      </p:sp>
-      <p:sp>
-        <p:nvSpPr>
-          <p:cNvPr id="18" name="telegram-panel">
-            <a:extLst xmlns:a="http://schemas.openxmlformats.org/drawingml/2006/main">
-              <a:ext uri="{FF2B5EF4-FFF2-40B4-BE49-F238E27FC236}">
-                <a16:creationId xmlns:a16="http://schemas.microsoft.com/office/drawing/2014/main" id="{D346DED7-EB47-4986-9B32-3F01E0A5B04A}"/>
+              <a:t>The service records the verdict and settles the escrow on Arc.</a:t>
+            </a:r>
+          </a:p>
+        </p:txBody>
+      </p:sp>
+      <p:sp>
+        <p:nvSpPr>
+          <p:cNvPr id="16" name="telegram-panel">
+            <a:extLst xmlns:a="http://schemas.openxmlformats.org/drawingml/2006/main">
+              <a:ext uri="{FF2B5EF4-FFF2-40B4-BE49-F238E27FC236}">
+                <a16:creationId xmlns:a16="http://schemas.microsoft.com/office/drawing/2014/main" id="{C73AD171-22BF-4C02-941F-0B520EE15893}"/>
               </a:ext>
             </a:extLst>
           </p:cNvPr>
@@ -4411,10 +4082,10 @@
       </p:sp>
       <p:sp>
         <p:nvSpPr>
-          <p:cNvPr id="19" name="">
-            <a:extLst xmlns:a="http://schemas.openxmlformats.org/drawingml/2006/main">
-              <a:ext uri="{FF2B5EF4-FFF2-40B4-BE49-F238E27FC236}">
-                <a16:creationId xmlns:a16="http://schemas.microsoft.com/office/drawing/2014/main" id="{CBB61277-ACC2-41A6-BE4A-260F855B7B9E}"/>
+          <p:cNvPr id="17" name="">
+            <a:extLst xmlns:a="http://schemas.openxmlformats.org/drawingml/2006/main">
+              <a:ext uri="{FF2B5EF4-FFF2-40B4-BE49-F238E27FC236}">
+                <a16:creationId xmlns:a16="http://schemas.microsoft.com/office/drawing/2014/main" id="{99683F5C-D1B9-4C11-BB5C-653CD75C7F4D}"/>
               </a:ext>
             </a:extLst>
           </p:cNvPr>
@@ -4442,10 +4113,10 @@
       </p:sp>
       <p:sp>
         <p:nvSpPr>
-          <p:cNvPr id="20" name="telegram-title">
-            <a:extLst xmlns:a="http://schemas.openxmlformats.org/drawingml/2006/main">
-              <a:ext uri="{FF2B5EF4-FFF2-40B4-BE49-F238E27FC236}">
-                <a16:creationId xmlns:a16="http://schemas.microsoft.com/office/drawing/2014/main" id="{65D8716E-08A8-4F4E-A95A-B4E32950A1D9}"/>
+          <p:cNvPr id="18" name="telegram-title">
+            <a:extLst xmlns:a="http://schemas.openxmlformats.org/drawingml/2006/main">
+              <a:ext uri="{FF2B5EF4-FFF2-40B4-BE49-F238E27FC236}">
+                <a16:creationId xmlns:a16="http://schemas.microsoft.com/office/drawing/2014/main" id="{9C59F283-2D53-4F48-8F28-04B60E25B2E8}"/>
               </a:ext>
             </a:extLst>
           </p:cNvPr>
@@ -4493,17 +4164,17 @@
                 <a:ea typeface="Space Grotesk"/>
                 <a:cs typeface="Space Grotesk"/>
               </a:rPr>
-              <a:t>Claim in Telegram</a:t>
-            </a:r>
-          </a:p>
-        </p:txBody>
-      </p:sp>
-      <p:sp>
-        <p:nvSpPr>
-          <p:cNvPr id="21" name="telegram-copy">
-            <a:extLst xmlns:a="http://schemas.openxmlformats.org/drawingml/2006/main">
-              <a:ext uri="{FF2B5EF4-FFF2-40B4-BE49-F238E27FC236}">
-                <a16:creationId xmlns:a16="http://schemas.microsoft.com/office/drawing/2014/main" id="{DEEC4B9F-42A0-4535-ADF8-7C3F915B91E4}"/>
+              <a:t>Review in Telegram</a:t>
+            </a:r>
+          </a:p>
+        </p:txBody>
+      </p:sp>
+      <p:sp>
+        <p:nvSpPr>
+          <p:cNvPr id="19" name="telegram-copy">
+            <a:extLst xmlns:a="http://schemas.openxmlformats.org/drawingml/2006/main">
+              <a:ext uri="{FF2B5EF4-FFF2-40B4-BE49-F238E27FC236}">
+                <a16:creationId xmlns:a16="http://schemas.microsoft.com/office/drawing/2014/main" id="{15083C19-4211-4FC9-A2E4-993BE5E86405}"/>
               </a:ext>
             </a:extLst>
           </p:cNvPr>
@@ -4551,21 +4222,21 @@
                 <a:ea typeface="Space Grotesk"/>
                 <a:cs typeface="Space Grotesk"/>
               </a:rPr>
-              <a:t>Claim the review, select a decision, then reply with a reason.</a:t>
+              <a:t>Claim, decide, and reply with a reason.</a:t>
             </a:r>
           </a:p>
         </p:txBody>
       </p:sp>
       <p:pic>
         <p:nvPicPr>
-          <p:cNvPr id="48" name=""/>
+          <p:cNvPr id="41" name=""/>
           <p:cNvPicPr>
             <a:picLocks xmlns:a="http://schemas.openxmlformats.org/drawingml/2006/main" noChangeAspect="1"/>
           </p:cNvPicPr>
           <p:nvPr/>
         </p:nvPicPr>
         <p:blipFill>
-          <a:blip xmlns:r="http://schemas.openxmlformats.org/officeDocument/2006/relationships" xmlns:a="http://schemas.openxmlformats.org/drawingml/2006/main" r:embed="Rca425ae4ded84cca"/>
+          <a:blip xmlns:r="http://schemas.openxmlformats.org/officeDocument/2006/relationships" xmlns:a="http://schemas.openxmlformats.org/drawingml/2006/main" r:embed="Rd8fe800d20364363"/>
           <a:stretch xmlns:a="http://schemas.openxmlformats.org/drawingml/2006/main"/>
         </p:blipFill>
         <p:spPr>
@@ -4580,10 +4251,10 @@
       </p:pic>
       <p:sp>
         <p:nvSpPr>
-          <p:cNvPr id="23" name="reward-note">
-            <a:extLst xmlns:a="http://schemas.openxmlformats.org/drawingml/2006/main">
-              <a:ext uri="{FF2B5EF4-FFF2-40B4-BE49-F238E27FC236}">
-                <a16:creationId xmlns:a16="http://schemas.microsoft.com/office/drawing/2014/main" id="{6245AFB8-0DAC-4A60-916E-A4E4793DD383}"/>
+          <p:cNvPr id="21" name="reward-note">
+            <a:extLst xmlns:a="http://schemas.openxmlformats.org/drawingml/2006/main">
+              <a:ext uri="{FF2B5EF4-FFF2-40B4-BE49-F238E27FC236}">
+                <a16:creationId xmlns:a16="http://schemas.microsoft.com/office/drawing/2014/main" id="{428880A0-7C4C-42E0-88BB-F7DC9254D40C}"/>
               </a:ext>
             </a:extLst>
           </p:cNvPr>
@@ -4631,154 +4302,7 @@
                 <a:ea typeface="Space Grotesk"/>
                 <a:cs typeface="Space Grotesk"/>
               </a:rPr>
-              <a:t>Approve and reject pay the same reviewer reward.</a:t>
-            </a:r>
-          </a:p>
-        </p:txBody>
-      </p:sp>
-      <p:sp>
-        <p:nvSpPr>
-          <p:cNvPr id="24" name="">
-            <a:extLst xmlns:a="http://schemas.openxmlformats.org/drawingml/2006/main">
-              <a:ext uri="{FF2B5EF4-FFF2-40B4-BE49-F238E27FC236}">
-                <a16:creationId xmlns:a16="http://schemas.microsoft.com/office/drawing/2014/main" id="{FFD2B4A9-6C03-450B-9107-66469BE43063}"/>
-              </a:ext>
-            </a:extLst>
-          </p:cNvPr>
-          <p:cNvSpPr>
-            <a:spLocks xmlns:a="http://schemas.openxmlformats.org/drawingml/2006/main" noGrp="1"/>
-          </p:cNvSpPr>
-          <p:nvPr/>
-        </p:nvSpPr>
-        <p:spPr>
-          <a:xfrm xmlns:a="http://schemas.openxmlformats.org/drawingml/2006/main">
-            <a:off x="685800" y="6334125"/>
-            <a:ext cx="10820400" cy="9525"/>
-          </a:xfrm>
-          <a:prstGeom xmlns:a="http://schemas.openxmlformats.org/drawingml/2006/main" prst="rect">
-            <a:avLst/>
-          </a:prstGeom>
-          <a:solidFill xmlns:a="http://schemas.openxmlformats.org/drawingml/2006/main">
-            <a:srgbClr val="2B2B2B"/>
-          </a:solidFill>
-          <a:ln xmlns:a="http://schemas.openxmlformats.org/drawingml/2006/main" w="0">
-            <a:noFill/>
-            <a:prstDash val="solid"/>
-          </a:ln>
-        </p:spPr>
-      </p:sp>
-      <p:sp>
-        <p:nvSpPr>
-          <p:cNvPr id="25" name="footer-left">
-            <a:extLst xmlns:a="http://schemas.openxmlformats.org/drawingml/2006/main">
-              <a:ext uri="{FF2B5EF4-FFF2-40B4-BE49-F238E27FC236}">
-                <a16:creationId xmlns:a16="http://schemas.microsoft.com/office/drawing/2014/main" id="{6D0F242E-2FD9-4B75-9F70-EEB03C1EA167}"/>
-              </a:ext>
-            </a:extLst>
-          </p:cNvPr>
-          <p:cNvSpPr>
-            <a:spLocks xmlns:a="http://schemas.openxmlformats.org/drawingml/2006/main" noGrp="1"/>
-          </p:cNvSpPr>
-          <p:nvPr/>
-        </p:nvSpPr>
-        <p:spPr>
-          <a:xfrm xmlns:a="http://schemas.openxmlformats.org/drawingml/2006/main">
-            <a:off x="685800" y="6467475"/>
-            <a:ext cx="4381500" cy="190500"/>
-          </a:xfrm>
-          <a:prstGeom xmlns:a="http://schemas.openxmlformats.org/drawingml/2006/main" prst="rect">
-            <a:avLst/>
-          </a:prstGeom>
-          <a:noFill xmlns:a="http://schemas.openxmlformats.org/drawingml/2006/main"/>
-          <a:ln xmlns:a="http://schemas.openxmlformats.org/drawingml/2006/main" w="0">
-            <a:noFill/>
-            <a:prstDash val="solid"/>
-          </a:ln>
-        </p:spPr>
-        <p:txBody>
-          <a:bodyPr xmlns:a="http://schemas.openxmlformats.org/drawingml/2006/main" lIns="0" tIns="0" rIns="0" bIns="0" anchor="t">
-            <a:normAutofit fontScale="100000"/>
-          </a:bodyPr>
-          <a:lstStyle xmlns:a="http://schemas.openxmlformats.org/drawingml/2006/main"/>
-          <a:p xmlns:a="http://schemas.openxmlformats.org/drawingml/2006/main">
-            <a:pPr algn="l">
-              <a:defRPr sz="900" b="0">
-                <a:solidFill>
-                  <a:srgbClr val="94948E"/>
-                </a:solidFill>
-                <a:latin typeface="Space Grotesk"/>
-                <a:ea typeface="Space Grotesk"/>
-                <a:cs typeface="Space Grotesk"/>
-              </a:defRPr>
-            </a:pPr>
-            <a:r>
-              <a:rPr sz="900" b="0">
-                <a:solidFill>
-                  <a:srgbClr val="94948E"/>
-                </a:solidFill>
-                <a:latin typeface="Space Grotesk"/>
-                <a:ea typeface="Space Grotesk"/>
-                <a:cs typeface="Space Grotesk"/>
-              </a:rPr>
-              <a:t>Circle Arc Hackathon · Checkpoint 2</a:t>
-            </a:r>
-          </a:p>
-        </p:txBody>
-      </p:sp>
-      <p:sp>
-        <p:nvSpPr>
-          <p:cNvPr id="26" name="footer-right">
-            <a:extLst xmlns:a="http://schemas.openxmlformats.org/drawingml/2006/main">
-              <a:ext uri="{FF2B5EF4-FFF2-40B4-BE49-F238E27FC236}">
-                <a16:creationId xmlns:a16="http://schemas.microsoft.com/office/drawing/2014/main" id="{B293FE59-C08A-4004-893D-E96FD5F76702}"/>
-              </a:ext>
-            </a:extLst>
-          </p:cNvPr>
-          <p:cNvSpPr>
-            <a:spLocks xmlns:a="http://schemas.openxmlformats.org/drawingml/2006/main" noGrp="1"/>
-          </p:cNvSpPr>
-          <p:nvPr/>
-        </p:nvSpPr>
-        <p:spPr>
-          <a:xfrm xmlns:a="http://schemas.openxmlformats.org/drawingml/2006/main">
-            <a:off x="9220200" y="6467475"/>
-            <a:ext cx="2286000" cy="190500"/>
-          </a:xfrm>
-          <a:prstGeom xmlns:a="http://schemas.openxmlformats.org/drawingml/2006/main" prst="rect">
-            <a:avLst/>
-          </a:prstGeom>
-          <a:noFill xmlns:a="http://schemas.openxmlformats.org/drawingml/2006/main"/>
-          <a:ln xmlns:a="http://schemas.openxmlformats.org/drawingml/2006/main" w="0">
-            <a:noFill/>
-            <a:prstDash val="solid"/>
-          </a:ln>
-        </p:spPr>
-        <p:txBody>
-          <a:bodyPr xmlns:a="http://schemas.openxmlformats.org/drawingml/2006/main" lIns="0" tIns="0" rIns="0" bIns="0" anchor="t">
-            <a:normAutofit fontScale="100000"/>
-          </a:bodyPr>
-          <a:lstStyle xmlns:a="http://schemas.openxmlformats.org/drawingml/2006/main"/>
-          <a:p xmlns:a="http://schemas.openxmlformats.org/drawingml/2006/main">
-            <a:pPr algn="r">
-              <a:defRPr sz="900" b="0">
-                <a:solidFill>
-                  <a:srgbClr val="94948E"/>
-                </a:solidFill>
-                <a:latin typeface="Space Grotesk"/>
-                <a:ea typeface="Space Grotesk"/>
-                <a:cs typeface="Space Grotesk"/>
-              </a:defRPr>
-            </a:pPr>
-            <a:r>
-              <a:rPr sz="900" b="0">
-                <a:solidFill>
-                  <a:srgbClr val="94948E"/>
-                </a:solidFill>
-                <a:latin typeface="Space Grotesk"/>
-                <a:ea typeface="Space Grotesk"/>
-                <a:cs typeface="Space Grotesk"/>
-              </a:rPr>
-              <a:t>Agentic Economy</a:t>
+              <a:t>The reward is the same for approve and reject.</a:t>
             </a:r>
           </a:p>
         </p:txBody>
@@ -4786,7 +4310,7 @@
     </p:spTree>
     <p:extLst>
       <p:ext uri="{BB962C8B-B14F-4D97-AF65-F5344CB8AC3E}">
-        <p14:creationId xmlns:p14="http://schemas.microsoft.com/office/powerpoint/2010/main" val="1274702589"/>
+        <p14:creationId xmlns:p14="http://schemas.microsoft.com/office/powerpoint/2010/main" val="1365583552"/>
       </p:ext>
     </p:extLst>
   </p:cSld>
@@ -4814,22 +4338,22 @@
       </p:grpSpPr>
       <p:sp>
         <p:nvSpPr>
-          <p:cNvPr id="30" name="section-4">
-            <a:extLst xmlns:a="http://schemas.openxmlformats.org/drawingml/2006/main">
-              <a:ext uri="{FF2B5EF4-FFF2-40B4-BE49-F238E27FC236}">
-                <a16:creationId xmlns:a16="http://schemas.microsoft.com/office/drawing/2014/main" id="{47262128-2856-4321-93A2-D02FB268C6F9}"/>
-              </a:ext>
-            </a:extLst>
-          </p:cNvPr>
-          <p:cNvSpPr>
-            <a:spLocks xmlns:a="http://schemas.openxmlformats.org/drawingml/2006/main" noGrp="1"/>
-          </p:cNvSpPr>
-          <p:nvPr/>
-        </p:nvSpPr>
-        <p:spPr>
-          <a:xfrm xmlns:a="http://schemas.openxmlformats.org/drawingml/2006/main">
-            <a:off x="685800" y="304800"/>
-            <a:ext cx="3048000" cy="190500"/>
+          <p:cNvPr id="25" name="page-4">
+            <a:extLst xmlns:a="http://schemas.openxmlformats.org/drawingml/2006/main">
+              <a:ext uri="{FF2B5EF4-FFF2-40B4-BE49-F238E27FC236}">
+                <a16:creationId xmlns:a16="http://schemas.microsoft.com/office/drawing/2014/main" id="{602DD566-6703-4E89-8D0E-21DAAE15779B}"/>
+              </a:ext>
+            </a:extLst>
+          </p:cNvPr>
+          <p:cNvSpPr>
+            <a:spLocks xmlns:a="http://schemas.openxmlformats.org/drawingml/2006/main" noGrp="1"/>
+          </p:cNvSpPr>
+          <p:nvPr/>
+        </p:nvSpPr>
+        <p:spPr>
+          <a:xfrm xmlns:a="http://schemas.openxmlformats.org/drawingml/2006/main">
+            <a:off x="10648950" y="304800"/>
+            <a:ext cx="857250" cy="190500"/>
           </a:xfrm>
           <a:prstGeom xmlns:a="http://schemas.openxmlformats.org/drawingml/2006/main" prst="rect">
             <a:avLst/>
@@ -4846,335 +4370,10 @@
           </a:bodyPr>
           <a:lstStyle xmlns:a="http://schemas.openxmlformats.org/drawingml/2006/main"/>
           <a:p xmlns:a="http://schemas.openxmlformats.org/drawingml/2006/main">
-            <a:pPr algn="l">
+            <a:pPr algn="r">
               <a:defRPr sz="975" b="0">
                 <a:solidFill>
                   <a:srgbClr val="94948E"/>
-                </a:solidFill>
-                <a:latin typeface="Space Grotesk"/>
-                <a:ea typeface="Space Grotesk"/>
-                <a:cs typeface="Space Grotesk"/>
-              </a:defRPr>
-            </a:pPr>
-            <a:r>
-              <a:rPr sz="975" b="0">
-                <a:solidFill>
-                  <a:srgbClr val="94948E"/>
-                </a:solidFill>
-                <a:latin typeface="Space Grotesk"/>
-                <a:ea typeface="Space Grotesk"/>
-                <a:cs typeface="Space Grotesk"/>
-              </a:rPr>
-              <a:t>vAPI Trust Network  ·  04</a:t>
-            </a:r>
-          </a:p>
-        </p:txBody>
-      </p:sp>
-      <p:sp>
-        <p:nvSpPr>
-          <p:cNvPr id="2" name="">
-            <a:extLst xmlns:a="http://schemas.openxmlformats.org/drawingml/2006/main">
-              <a:ext uri="{FF2B5EF4-FFF2-40B4-BE49-F238E27FC236}">
-                <a16:creationId xmlns:a16="http://schemas.microsoft.com/office/drawing/2014/main" id="{4F3B45C4-BE9D-48E8-9514-C50FB2CE923F}"/>
-              </a:ext>
-            </a:extLst>
-          </p:cNvPr>
-          <p:cNvSpPr>
-            <a:spLocks xmlns:a="http://schemas.openxmlformats.org/drawingml/2006/main" noGrp="1"/>
-          </p:cNvSpPr>
-          <p:nvPr/>
-        </p:nvSpPr>
-        <p:spPr>
-          <a:xfrm xmlns:a="http://schemas.openxmlformats.org/drawingml/2006/main">
-            <a:off x="685800" y="581025"/>
-            <a:ext cx="10820400" cy="9525"/>
-          </a:xfrm>
-          <a:prstGeom xmlns:a="http://schemas.openxmlformats.org/drawingml/2006/main" prst="rect">
-            <a:avLst/>
-          </a:prstGeom>
-          <a:solidFill xmlns:a="http://schemas.openxmlformats.org/drawingml/2006/main">
-            <a:srgbClr val="2B2B2B"/>
-          </a:solidFill>
-          <a:ln xmlns:a="http://schemas.openxmlformats.org/drawingml/2006/main" w="0">
-            <a:noFill/>
-            <a:prstDash val="solid"/>
-          </a:ln>
-        </p:spPr>
-      </p:sp>
-      <p:sp>
-        <p:nvSpPr>
-          <p:cNvPr id="3" name="">
-            <a:extLst xmlns:a="http://schemas.openxmlformats.org/drawingml/2006/main">
-              <a:ext uri="{FF2B5EF4-FFF2-40B4-BE49-F238E27FC236}">
-                <a16:creationId xmlns:a16="http://schemas.microsoft.com/office/drawing/2014/main" id="{E0F6F482-6C35-4234-8C4B-3D42BE0EA4EF}"/>
-              </a:ext>
-            </a:extLst>
-          </p:cNvPr>
-          <p:cNvSpPr>
-            <a:spLocks xmlns:a="http://schemas.openxmlformats.org/drawingml/2006/main" noGrp="1"/>
-          </p:cNvSpPr>
-          <p:nvPr/>
-        </p:nvSpPr>
-        <p:spPr>
-          <a:xfrm xmlns:a="http://schemas.openxmlformats.org/drawingml/2006/main">
-            <a:off x="11410950" y="304800"/>
-            <a:ext cx="95250" cy="95250"/>
-          </a:xfrm>
-          <a:prstGeom xmlns:a="http://schemas.openxmlformats.org/drawingml/2006/main" prst="rect">
-            <a:avLst/>
-          </a:prstGeom>
-          <a:solidFill xmlns:a="http://schemas.openxmlformats.org/drawingml/2006/main">
-            <a:srgbClr val="FF7300"/>
-          </a:solidFill>
-          <a:ln xmlns:a="http://schemas.openxmlformats.org/drawingml/2006/main" w="0">
-            <a:noFill/>
-            <a:prstDash val="solid"/>
-          </a:ln>
-        </p:spPr>
-      </p:sp>
-      <p:sp>
-        <p:nvSpPr>
-          <p:cNvPr id="4" name="slide-title">
-            <a:extLst xmlns:a="http://schemas.openxmlformats.org/drawingml/2006/main">
-              <a:ext uri="{FF2B5EF4-FFF2-40B4-BE49-F238E27FC236}">
-                <a16:creationId xmlns:a16="http://schemas.microsoft.com/office/drawing/2014/main" id="{67025191-0F18-474D-946E-67E6E63C9FA3}"/>
-              </a:ext>
-            </a:extLst>
-          </p:cNvPr>
-          <p:cNvSpPr>
-            <a:spLocks xmlns:a="http://schemas.openxmlformats.org/drawingml/2006/main" noGrp="1"/>
-          </p:cNvSpPr>
-          <p:nvPr/>
-        </p:nvSpPr>
-        <p:spPr>
-          <a:xfrm xmlns:a="http://schemas.openxmlformats.org/drawingml/2006/main">
-            <a:off x="685800" y="838200"/>
-            <a:ext cx="10001250" cy="971550"/>
-          </a:xfrm>
-          <a:prstGeom xmlns:a="http://schemas.openxmlformats.org/drawingml/2006/main" prst="rect">
-            <a:avLst/>
-          </a:prstGeom>
-          <a:noFill xmlns:a="http://schemas.openxmlformats.org/drawingml/2006/main"/>
-          <a:ln xmlns:a="http://schemas.openxmlformats.org/drawingml/2006/main" w="0">
-            <a:noFill/>
-            <a:prstDash val="solid"/>
-          </a:ln>
-        </p:spPr>
-        <p:txBody>
-          <a:bodyPr xmlns:a="http://schemas.openxmlformats.org/drawingml/2006/main" lIns="0" tIns="0" rIns="0" bIns="0" anchor="t">
-            <a:normAutofit fontScale="100000"/>
-          </a:bodyPr>
-          <a:lstStyle xmlns:a="http://schemas.openxmlformats.org/drawingml/2006/main"/>
-          <a:p xmlns:a="http://schemas.openxmlformats.org/drawingml/2006/main">
-            <a:pPr algn="l">
-              <a:defRPr sz="3150" b="0">
-                <a:solidFill>
-                  <a:srgbClr val="FAFAFA"/>
-                </a:solidFill>
-                <a:latin typeface="Space Grotesk"/>
-                <a:ea typeface="Space Grotesk"/>
-                <a:cs typeface="Space Grotesk"/>
-              </a:defRPr>
-            </a:pPr>
-            <a:r>
-              <a:rPr sz="3150" b="0">
-                <a:solidFill>
-                  <a:srgbClr val="FAFAFA"/>
-                </a:solidFill>
-                <a:latin typeface="Space Grotesk"/>
-                <a:ea typeface="Space Grotesk"/>
-                <a:cs typeface="Space Grotesk"/>
-              </a:rPr>
-              <a:t>EvaluationRouter v3 is deployed on Arc Testnet</a:t>
-            </a:r>
-          </a:p>
-        </p:txBody>
-      </p:sp>
-      <p:sp>
-        <p:nvSpPr>
-          <p:cNvPr id="5" name="router-label">
-            <a:extLst xmlns:a="http://schemas.openxmlformats.org/drawingml/2006/main">
-              <a:ext uri="{FF2B5EF4-FFF2-40B4-BE49-F238E27FC236}">
-                <a16:creationId xmlns:a16="http://schemas.microsoft.com/office/drawing/2014/main" id="{59EAC060-FE5D-42C8-96C0-03E022864D9A}"/>
-              </a:ext>
-            </a:extLst>
-          </p:cNvPr>
-          <p:cNvSpPr>
-            <a:spLocks xmlns:a="http://schemas.openxmlformats.org/drawingml/2006/main" noGrp="1"/>
-          </p:cNvSpPr>
-          <p:nvPr/>
-        </p:nvSpPr>
-        <p:spPr>
-          <a:xfrm xmlns:a="http://schemas.openxmlformats.org/drawingml/2006/main">
-            <a:off x="685800" y="2076450"/>
-            <a:ext cx="4000500" cy="304800"/>
-          </a:xfrm>
-          <a:prstGeom xmlns:a="http://schemas.openxmlformats.org/drawingml/2006/main" prst="rect">
-            <a:avLst/>
-          </a:prstGeom>
-          <a:noFill xmlns:a="http://schemas.openxmlformats.org/drawingml/2006/main"/>
-          <a:ln xmlns:a="http://schemas.openxmlformats.org/drawingml/2006/main" w="0">
-            <a:noFill/>
-            <a:prstDash val="solid"/>
-          </a:ln>
-        </p:spPr>
-        <p:txBody>
-          <a:bodyPr xmlns:a="http://schemas.openxmlformats.org/drawingml/2006/main" lIns="0" tIns="0" rIns="0" bIns="0" anchor="t">
-            <a:normAutofit fontScale="100000"/>
-          </a:bodyPr>
-          <a:lstStyle xmlns:a="http://schemas.openxmlformats.org/drawingml/2006/main"/>
-          <a:p xmlns:a="http://schemas.openxmlformats.org/drawingml/2006/main">
-            <a:pPr algn="l">
-              <a:defRPr sz="1725" b="0">
-                <a:solidFill>
-                  <a:srgbClr val="FAFAFA"/>
-                </a:solidFill>
-                <a:latin typeface="Space Grotesk"/>
-                <a:ea typeface="Space Grotesk"/>
-                <a:cs typeface="Space Grotesk"/>
-              </a:defRPr>
-            </a:pPr>
-            <a:r>
-              <a:rPr sz="1725" b="0">
-                <a:solidFill>
-                  <a:srgbClr val="FAFAFA"/>
-                </a:solidFill>
-                <a:latin typeface="Space Grotesk"/>
-                <a:ea typeface="Space Grotesk"/>
-                <a:cs typeface="Space Grotesk"/>
-              </a:rPr>
-              <a:t>EvaluationRouter v3</a:t>
-            </a:r>
-          </a:p>
-        </p:txBody>
-      </p:sp>
-      <p:sp>
-        <p:nvSpPr>
-          <p:cNvPr id="6" name="">
-            <a:extLst xmlns:a="http://schemas.openxmlformats.org/drawingml/2006/main">
-              <a:ext uri="{FF2B5EF4-FFF2-40B4-BE49-F238E27FC236}">
-                <a16:creationId xmlns:a16="http://schemas.microsoft.com/office/drawing/2014/main" id="{8CDB796F-A32E-4DE0-80BE-91D70AE73BAD}"/>
-              </a:ext>
-            </a:extLst>
-          </p:cNvPr>
-          <p:cNvSpPr>
-            <a:spLocks xmlns:a="http://schemas.openxmlformats.org/drawingml/2006/main" noGrp="1"/>
-          </p:cNvSpPr>
-          <p:nvPr/>
-        </p:nvSpPr>
-        <p:spPr>
-          <a:xfrm xmlns:a="http://schemas.openxmlformats.org/drawingml/2006/main">
-            <a:off x="685800" y="2590800"/>
-            <a:ext cx="114300" cy="114300"/>
-          </a:xfrm>
-          <a:prstGeom xmlns:a="http://schemas.openxmlformats.org/drawingml/2006/main" prst="rect">
-            <a:avLst/>
-          </a:prstGeom>
-          <a:solidFill xmlns:a="http://schemas.openxmlformats.org/drawingml/2006/main">
-            <a:srgbClr val="C3FF3D"/>
-          </a:solidFill>
-          <a:ln xmlns:a="http://schemas.openxmlformats.org/drawingml/2006/main" w="0">
-            <a:noFill/>
-            <a:prstDash val="solid"/>
-          </a:ln>
-        </p:spPr>
-      </p:sp>
-      <p:sp>
-        <p:nvSpPr>
-          <p:cNvPr id="7" name="verified-label">
-            <a:extLst xmlns:a="http://schemas.openxmlformats.org/drawingml/2006/main">
-              <a:ext uri="{FF2B5EF4-FFF2-40B4-BE49-F238E27FC236}">
-                <a16:creationId xmlns:a16="http://schemas.microsoft.com/office/drawing/2014/main" id="{8EFB6F76-C9E9-4B37-993F-FA7B07377D33}"/>
-              </a:ext>
-            </a:extLst>
-          </p:cNvPr>
-          <p:cNvSpPr>
-            <a:spLocks xmlns:a="http://schemas.openxmlformats.org/drawingml/2006/main" noGrp="1"/>
-          </p:cNvSpPr>
-          <p:nvPr/>
-        </p:nvSpPr>
-        <p:spPr>
-          <a:xfrm xmlns:a="http://schemas.openxmlformats.org/drawingml/2006/main">
-            <a:off x="914400" y="2533650"/>
-            <a:ext cx="1714500" cy="247650"/>
-          </a:xfrm>
-          <a:prstGeom xmlns:a="http://schemas.openxmlformats.org/drawingml/2006/main" prst="rect">
-            <a:avLst/>
-          </a:prstGeom>
-          <a:noFill xmlns:a="http://schemas.openxmlformats.org/drawingml/2006/main"/>
-          <a:ln xmlns:a="http://schemas.openxmlformats.org/drawingml/2006/main" w="0">
-            <a:noFill/>
-            <a:prstDash val="solid"/>
-          </a:ln>
-        </p:spPr>
-        <p:txBody>
-          <a:bodyPr xmlns:a="http://schemas.openxmlformats.org/drawingml/2006/main" lIns="0" tIns="0" rIns="0" bIns="0" anchor="t">
-            <a:normAutofit fontScale="100000"/>
-          </a:bodyPr>
-          <a:lstStyle xmlns:a="http://schemas.openxmlformats.org/drawingml/2006/main"/>
-          <a:p xmlns:a="http://schemas.openxmlformats.org/drawingml/2006/main">
-            <a:pPr algn="l">
-              <a:defRPr sz="1200" b="0">
-                <a:solidFill>
-                  <a:srgbClr val="C3FF3D"/>
-                </a:solidFill>
-                <a:latin typeface="Space Grotesk"/>
-                <a:ea typeface="Space Grotesk"/>
-                <a:cs typeface="Space Grotesk"/>
-              </a:defRPr>
-            </a:pPr>
-            <a:r>
-              <a:rPr sz="1200" b="0">
-                <a:solidFill>
-                  <a:srgbClr val="C3FF3D"/>
-                </a:solidFill>
-                <a:latin typeface="Space Grotesk"/>
-                <a:ea typeface="Space Grotesk"/>
-                <a:cs typeface="Space Grotesk"/>
-              </a:rPr>
-              <a:t>Source verified</a:t>
-            </a:r>
-          </a:p>
-        </p:txBody>
-      </p:sp>
-      <p:sp>
-        <p:nvSpPr>
-          <p:cNvPr id="8" name="router-address">
-            <a:extLst xmlns:a="http://schemas.openxmlformats.org/drawingml/2006/main">
-              <a:ext uri="{FF2B5EF4-FFF2-40B4-BE49-F238E27FC236}">
-                <a16:creationId xmlns:a16="http://schemas.microsoft.com/office/drawing/2014/main" id="{179D5F5D-55E4-45B5-851D-81851E3643BF}"/>
-              </a:ext>
-            </a:extLst>
-          </p:cNvPr>
-          <p:cNvSpPr>
-            <a:spLocks xmlns:a="http://schemas.openxmlformats.org/drawingml/2006/main" noGrp="1"/>
-          </p:cNvSpPr>
-          <p:nvPr/>
-        </p:nvSpPr>
-        <p:spPr>
-          <a:xfrm xmlns:a="http://schemas.openxmlformats.org/drawingml/2006/main">
-            <a:off x="685800" y="2952750"/>
-            <a:ext cx="5429250" cy="552450"/>
-          </a:xfrm>
-          <a:prstGeom xmlns:a="http://schemas.openxmlformats.org/drawingml/2006/main" prst="rect">
-            <a:avLst/>
-          </a:prstGeom>
-          <a:noFill xmlns:a="http://schemas.openxmlformats.org/drawingml/2006/main"/>
-          <a:ln xmlns:a="http://schemas.openxmlformats.org/drawingml/2006/main" w="0">
-            <a:noFill/>
-            <a:prstDash val="solid"/>
-          </a:ln>
-        </p:spPr>
-        <p:txBody>
-          <a:bodyPr xmlns:a="http://schemas.openxmlformats.org/drawingml/2006/main" lIns="0" tIns="0" rIns="0" bIns="0" anchor="t">
-            <a:normAutofit fontScale="100000"/>
-          </a:bodyPr>
-          <a:lstStyle xmlns:a="http://schemas.openxmlformats.org/drawingml/2006/main"/>
-          <a:p xmlns:a="http://schemas.openxmlformats.org/drawingml/2006/main">
-            <a:pPr algn="l">
-              <a:defRPr sz="1425" b="0">
-                <a:solidFill>
-                  <a:srgbClr val="B0B0AB"/>
                 </a:solidFill>
                 <a:latin typeface="IBM Plex Mono"/>
                 <a:ea typeface="IBM Plex Mono"/>
@@ -5182,6 +4381,269 @@
               </a:defRPr>
             </a:pPr>
             <a:r>
+              <a:rPr sz="975" b="0">
+                <a:solidFill>
+                  <a:srgbClr val="94948E"/>
+                </a:solidFill>
+                <a:latin typeface="IBM Plex Mono"/>
+                <a:ea typeface="IBM Plex Mono"/>
+                <a:cs typeface="IBM Plex Mono"/>
+              </a:rPr>
+              <a:t>04 / 05</a:t>
+            </a:r>
+          </a:p>
+        </p:txBody>
+      </p:sp>
+      <p:sp>
+        <p:nvSpPr>
+          <p:cNvPr id="2" name="slide-title">
+            <a:extLst xmlns:a="http://schemas.openxmlformats.org/drawingml/2006/main">
+              <a:ext uri="{FF2B5EF4-FFF2-40B4-BE49-F238E27FC236}">
+                <a16:creationId xmlns:a16="http://schemas.microsoft.com/office/drawing/2014/main" id="{0B11475F-54B5-4D96-B1EE-3096A4441E9C}"/>
+              </a:ext>
+            </a:extLst>
+          </p:cNvPr>
+          <p:cNvSpPr>
+            <a:spLocks xmlns:a="http://schemas.openxmlformats.org/drawingml/2006/main" noGrp="1"/>
+          </p:cNvSpPr>
+          <p:nvPr/>
+        </p:nvSpPr>
+        <p:spPr>
+          <a:xfrm xmlns:a="http://schemas.openxmlformats.org/drawingml/2006/main">
+            <a:off x="685800" y="838200"/>
+            <a:ext cx="10001250" cy="971550"/>
+          </a:xfrm>
+          <a:prstGeom xmlns:a="http://schemas.openxmlformats.org/drawingml/2006/main" prst="rect">
+            <a:avLst/>
+          </a:prstGeom>
+          <a:noFill xmlns:a="http://schemas.openxmlformats.org/drawingml/2006/main"/>
+          <a:ln xmlns:a="http://schemas.openxmlformats.org/drawingml/2006/main" w="0">
+            <a:noFill/>
+            <a:prstDash val="solid"/>
+          </a:ln>
+        </p:spPr>
+        <p:txBody>
+          <a:bodyPr xmlns:a="http://schemas.openxmlformats.org/drawingml/2006/main" lIns="0" tIns="0" rIns="0" bIns="0" anchor="t">
+            <a:normAutofit fontScale="100000"/>
+          </a:bodyPr>
+          <a:lstStyle xmlns:a="http://schemas.openxmlformats.org/drawingml/2006/main"/>
+          <a:p xmlns:a="http://schemas.openxmlformats.org/drawingml/2006/main">
+            <a:pPr algn="l">
+              <a:defRPr sz="3150" b="0">
+                <a:solidFill>
+                  <a:srgbClr val="FAFAFA"/>
+                </a:solidFill>
+                <a:latin typeface="Space Grotesk"/>
+                <a:ea typeface="Space Grotesk"/>
+                <a:cs typeface="Space Grotesk"/>
+              </a:defRPr>
+            </a:pPr>
+            <a:r>
+              <a:rPr sz="3150" b="0">
+                <a:solidFill>
+                  <a:srgbClr val="FAFAFA"/>
+                </a:solidFill>
+                <a:latin typeface="Space Grotesk"/>
+                <a:ea typeface="Space Grotesk"/>
+                <a:cs typeface="Space Grotesk"/>
+              </a:rPr>
+              <a:t>The router is live on Arc Testnet.</a:t>
+            </a:r>
+          </a:p>
+        </p:txBody>
+      </p:sp>
+      <p:sp>
+        <p:nvSpPr>
+          <p:cNvPr id="3" name="router-label">
+            <a:extLst xmlns:a="http://schemas.openxmlformats.org/drawingml/2006/main">
+              <a:ext uri="{FF2B5EF4-FFF2-40B4-BE49-F238E27FC236}">
+                <a16:creationId xmlns:a16="http://schemas.microsoft.com/office/drawing/2014/main" id="{BCBE6D21-1F08-46DC-80E7-EA240D915EBC}"/>
+              </a:ext>
+            </a:extLst>
+          </p:cNvPr>
+          <p:cNvSpPr>
+            <a:spLocks xmlns:a="http://schemas.openxmlformats.org/drawingml/2006/main" noGrp="1"/>
+          </p:cNvSpPr>
+          <p:nvPr/>
+        </p:nvSpPr>
+        <p:spPr>
+          <a:xfrm xmlns:a="http://schemas.openxmlformats.org/drawingml/2006/main">
+            <a:off x="685800" y="2076450"/>
+            <a:ext cx="4000500" cy="304800"/>
+          </a:xfrm>
+          <a:prstGeom xmlns:a="http://schemas.openxmlformats.org/drawingml/2006/main" prst="rect">
+            <a:avLst/>
+          </a:prstGeom>
+          <a:noFill xmlns:a="http://schemas.openxmlformats.org/drawingml/2006/main"/>
+          <a:ln xmlns:a="http://schemas.openxmlformats.org/drawingml/2006/main" w="0">
+            <a:noFill/>
+            <a:prstDash val="solid"/>
+          </a:ln>
+        </p:spPr>
+        <p:txBody>
+          <a:bodyPr xmlns:a="http://schemas.openxmlformats.org/drawingml/2006/main" lIns="0" tIns="0" rIns="0" bIns="0" anchor="t">
+            <a:normAutofit fontScale="100000"/>
+          </a:bodyPr>
+          <a:lstStyle xmlns:a="http://schemas.openxmlformats.org/drawingml/2006/main"/>
+          <a:p xmlns:a="http://schemas.openxmlformats.org/drawingml/2006/main">
+            <a:pPr algn="l">
+              <a:defRPr sz="1725" b="0">
+                <a:solidFill>
+                  <a:srgbClr val="FAFAFA"/>
+                </a:solidFill>
+                <a:latin typeface="Space Grotesk"/>
+                <a:ea typeface="Space Grotesk"/>
+                <a:cs typeface="Space Grotesk"/>
+              </a:defRPr>
+            </a:pPr>
+            <a:r>
+              <a:rPr sz="1725" b="0">
+                <a:solidFill>
+                  <a:srgbClr val="FAFAFA"/>
+                </a:solidFill>
+                <a:latin typeface="Space Grotesk"/>
+                <a:ea typeface="Space Grotesk"/>
+                <a:cs typeface="Space Grotesk"/>
+              </a:rPr>
+              <a:t>EvaluationRouter v3</a:t>
+            </a:r>
+          </a:p>
+        </p:txBody>
+      </p:sp>
+      <p:sp>
+        <p:nvSpPr>
+          <p:cNvPr id="4" name="">
+            <a:extLst xmlns:a="http://schemas.openxmlformats.org/drawingml/2006/main">
+              <a:ext uri="{FF2B5EF4-FFF2-40B4-BE49-F238E27FC236}">
+                <a16:creationId xmlns:a16="http://schemas.microsoft.com/office/drawing/2014/main" id="{2E7B6331-BED0-4F1C-9BC5-31583E71B607}"/>
+              </a:ext>
+            </a:extLst>
+          </p:cNvPr>
+          <p:cNvSpPr>
+            <a:spLocks xmlns:a="http://schemas.openxmlformats.org/drawingml/2006/main" noGrp="1"/>
+          </p:cNvSpPr>
+          <p:nvPr/>
+        </p:nvSpPr>
+        <p:spPr>
+          <a:xfrm xmlns:a="http://schemas.openxmlformats.org/drawingml/2006/main">
+            <a:off x="685800" y="2590800"/>
+            <a:ext cx="114300" cy="114300"/>
+          </a:xfrm>
+          <a:prstGeom xmlns:a="http://schemas.openxmlformats.org/drawingml/2006/main" prst="rect">
+            <a:avLst/>
+          </a:prstGeom>
+          <a:solidFill xmlns:a="http://schemas.openxmlformats.org/drawingml/2006/main">
+            <a:srgbClr val="C3FF3D"/>
+          </a:solidFill>
+          <a:ln xmlns:a="http://schemas.openxmlformats.org/drawingml/2006/main" w="0">
+            <a:noFill/>
+            <a:prstDash val="solid"/>
+          </a:ln>
+        </p:spPr>
+      </p:sp>
+      <p:sp>
+        <p:nvSpPr>
+          <p:cNvPr id="5" name="verified-label">
+            <a:extLst xmlns:a="http://schemas.openxmlformats.org/drawingml/2006/main">
+              <a:ext uri="{FF2B5EF4-FFF2-40B4-BE49-F238E27FC236}">
+                <a16:creationId xmlns:a16="http://schemas.microsoft.com/office/drawing/2014/main" id="{EE12E6FF-6F97-47C6-A143-572F130C15E2}"/>
+              </a:ext>
+            </a:extLst>
+          </p:cNvPr>
+          <p:cNvSpPr>
+            <a:spLocks xmlns:a="http://schemas.openxmlformats.org/drawingml/2006/main" noGrp="1"/>
+          </p:cNvSpPr>
+          <p:nvPr/>
+        </p:nvSpPr>
+        <p:spPr>
+          <a:xfrm xmlns:a="http://schemas.openxmlformats.org/drawingml/2006/main">
+            <a:off x="914400" y="2533650"/>
+            <a:ext cx="1714500" cy="247650"/>
+          </a:xfrm>
+          <a:prstGeom xmlns:a="http://schemas.openxmlformats.org/drawingml/2006/main" prst="rect">
+            <a:avLst/>
+          </a:prstGeom>
+          <a:noFill xmlns:a="http://schemas.openxmlformats.org/drawingml/2006/main"/>
+          <a:ln xmlns:a="http://schemas.openxmlformats.org/drawingml/2006/main" w="0">
+            <a:noFill/>
+            <a:prstDash val="solid"/>
+          </a:ln>
+        </p:spPr>
+        <p:txBody>
+          <a:bodyPr xmlns:a="http://schemas.openxmlformats.org/drawingml/2006/main" lIns="0" tIns="0" rIns="0" bIns="0" anchor="t">
+            <a:normAutofit fontScale="100000"/>
+          </a:bodyPr>
+          <a:lstStyle xmlns:a="http://schemas.openxmlformats.org/drawingml/2006/main"/>
+          <a:p xmlns:a="http://schemas.openxmlformats.org/drawingml/2006/main">
+            <a:pPr algn="l">
+              <a:defRPr sz="1200" b="0">
+                <a:solidFill>
+                  <a:srgbClr val="C3FF3D"/>
+                </a:solidFill>
+                <a:latin typeface="Space Grotesk"/>
+                <a:ea typeface="Space Grotesk"/>
+                <a:cs typeface="Space Grotesk"/>
+              </a:defRPr>
+            </a:pPr>
+            <a:r>
+              <a:rPr sz="1200" b="0">
+                <a:solidFill>
+                  <a:srgbClr val="C3FF3D"/>
+                </a:solidFill>
+                <a:latin typeface="Space Grotesk"/>
+                <a:ea typeface="Space Grotesk"/>
+                <a:cs typeface="Space Grotesk"/>
+              </a:rPr>
+              <a:t>Source verified</a:t>
+            </a:r>
+          </a:p>
+        </p:txBody>
+      </p:sp>
+      <p:sp>
+        <p:nvSpPr>
+          <p:cNvPr id="6" name="router-address">
+            <a:extLst xmlns:a="http://schemas.openxmlformats.org/drawingml/2006/main">
+              <a:ext uri="{FF2B5EF4-FFF2-40B4-BE49-F238E27FC236}">
+                <a16:creationId xmlns:a16="http://schemas.microsoft.com/office/drawing/2014/main" id="{79484A3C-3854-43BF-B498-79A99BA6B173}"/>
+              </a:ext>
+            </a:extLst>
+          </p:cNvPr>
+          <p:cNvSpPr>
+            <a:spLocks xmlns:a="http://schemas.openxmlformats.org/drawingml/2006/main" noGrp="1"/>
+          </p:cNvSpPr>
+          <p:nvPr/>
+        </p:nvSpPr>
+        <p:spPr>
+          <a:xfrm xmlns:a="http://schemas.openxmlformats.org/drawingml/2006/main">
+            <a:off x="685800" y="2952750"/>
+            <a:ext cx="5429250" cy="552450"/>
+          </a:xfrm>
+          <a:prstGeom xmlns:a="http://schemas.openxmlformats.org/drawingml/2006/main" prst="rect">
+            <a:avLst/>
+          </a:prstGeom>
+          <a:noFill xmlns:a="http://schemas.openxmlformats.org/drawingml/2006/main"/>
+          <a:ln xmlns:a="http://schemas.openxmlformats.org/drawingml/2006/main" w="0">
+            <a:noFill/>
+            <a:prstDash val="solid"/>
+          </a:ln>
+        </p:spPr>
+        <p:txBody>
+          <a:bodyPr xmlns:a="http://schemas.openxmlformats.org/drawingml/2006/main" lIns="0" tIns="0" rIns="0" bIns="0" anchor="t">
+            <a:normAutofit fontScale="100000"/>
+          </a:bodyPr>
+          <a:lstStyle xmlns:a="http://schemas.openxmlformats.org/drawingml/2006/main"/>
+          <a:p xmlns:a="http://schemas.openxmlformats.org/drawingml/2006/main">
+            <a:pPr algn="l">
+              <a:defRPr sz="1425" b="0">
+                <a:solidFill>
+                  <a:srgbClr val="B0B0AB"/>
+                </a:solidFill>
+                <a:latin typeface="IBM Plex Mono"/>
+                <a:ea typeface="IBM Plex Mono"/>
+                <a:cs typeface="IBM Plex Mono"/>
+              </a:defRPr>
+            </a:pPr>
+            <a:r>
               <a:rPr sz="1425" b="0">
                 <a:solidFill>
                   <a:srgbClr val="B0B0AB"/>
@@ -5197,10 +4659,10 @@
       </p:sp>
       <p:sp>
         <p:nvSpPr>
-          <p:cNvPr id="9" name="commerce-label">
-            <a:extLst xmlns:a="http://schemas.openxmlformats.org/drawingml/2006/main">
-              <a:ext uri="{FF2B5EF4-FFF2-40B4-BE49-F238E27FC236}">
-                <a16:creationId xmlns:a16="http://schemas.microsoft.com/office/drawing/2014/main" id="{AEC11ECA-3E2F-4FF7-8A1D-53CD844BC641}"/>
+          <p:cNvPr id="7" name="commerce-label">
+            <a:extLst xmlns:a="http://schemas.openxmlformats.org/drawingml/2006/main">
+              <a:ext uri="{FF2B5EF4-FFF2-40B4-BE49-F238E27FC236}">
+                <a16:creationId xmlns:a16="http://schemas.microsoft.com/office/drawing/2014/main" id="{6CD546A5-38CD-4662-A799-5540627B9D05}"/>
               </a:ext>
             </a:extLst>
           </p:cNvPr>
@@ -5255,10 +4717,10 @@
       </p:sp>
       <p:sp>
         <p:nvSpPr>
-          <p:cNvPr id="10" name="commerce-address">
-            <a:extLst xmlns:a="http://schemas.openxmlformats.org/drawingml/2006/main">
-              <a:ext uri="{FF2B5EF4-FFF2-40B4-BE49-F238E27FC236}">
-                <a16:creationId xmlns:a16="http://schemas.microsoft.com/office/drawing/2014/main" id="{3D2B7FB5-76D1-4C68-A372-F61BA4795A5D}"/>
+          <p:cNvPr id="8" name="commerce-address">
+            <a:extLst xmlns:a="http://schemas.openxmlformats.org/drawingml/2006/main">
+              <a:ext uri="{FF2B5EF4-FFF2-40B4-BE49-F238E27FC236}">
+                <a16:creationId xmlns:a16="http://schemas.microsoft.com/office/drawing/2014/main" id="{4D6A6849-B77E-4006-A381-A0AC1E7B06C0}"/>
               </a:ext>
             </a:extLst>
           </p:cNvPr>
@@ -5313,10 +4775,10 @@
       </p:sp>
       <p:sp>
         <p:nvSpPr>
-          <p:cNvPr id="11" name="">
-            <a:extLst xmlns:a="http://schemas.openxmlformats.org/drawingml/2006/main">
-              <a:ext uri="{FF2B5EF4-FFF2-40B4-BE49-F238E27FC236}">
-                <a16:creationId xmlns:a16="http://schemas.microsoft.com/office/drawing/2014/main" id="{5A8C9EAD-F4D6-406F-BF0C-07D068FBB3AB}"/>
+          <p:cNvPr id="9" name="">
+            <a:extLst xmlns:a="http://schemas.openxmlformats.org/drawingml/2006/main">
+              <a:ext uri="{FF2B5EF4-FFF2-40B4-BE49-F238E27FC236}">
+                <a16:creationId xmlns:a16="http://schemas.microsoft.com/office/drawing/2014/main" id="{3DD7A77B-3FC0-4C29-83DA-5EB1EAE75DF1}"/>
               </a:ext>
             </a:extLst>
           </p:cNvPr>
@@ -5344,10 +4806,10 @@
       </p:sp>
       <p:sp>
         <p:nvSpPr>
-          <p:cNvPr id="12" name="jobs-label">
-            <a:extLst xmlns:a="http://schemas.openxmlformats.org/drawingml/2006/main">
-              <a:ext uri="{FF2B5EF4-FFF2-40B4-BE49-F238E27FC236}">
-                <a16:creationId xmlns:a16="http://schemas.microsoft.com/office/drawing/2014/main" id="{D6D389D6-1188-4877-914B-CFFB51CCC979}"/>
+          <p:cNvPr id="10" name="jobs-label">
+            <a:extLst xmlns:a="http://schemas.openxmlformats.org/drawingml/2006/main">
+              <a:ext uri="{FF2B5EF4-FFF2-40B4-BE49-F238E27FC236}">
+                <a16:creationId xmlns:a16="http://schemas.microsoft.com/office/drawing/2014/main" id="{D410CF31-BF3C-418F-BE1A-874946CBB9EE}"/>
               </a:ext>
             </a:extLst>
           </p:cNvPr>
@@ -5395,17 +4857,17 @@
                 <a:ea typeface="Space Grotesk"/>
                 <a:cs typeface="Space Grotesk"/>
               </a:rPr>
-              <a:t>Deployed job paths</a:t>
-            </a:r>
-          </a:p>
-        </p:txBody>
-      </p:sp>
-      <p:sp>
-        <p:nvSpPr>
-          <p:cNvPr id="13" name="">
-            <a:extLst xmlns:a="http://schemas.openxmlformats.org/drawingml/2006/main">
-              <a:ext uri="{FF2B5EF4-FFF2-40B4-BE49-F238E27FC236}">
-                <a16:creationId xmlns:a16="http://schemas.microsoft.com/office/drawing/2014/main" id="{8CE65549-51C1-4F70-864E-0CA65E359CA1}"/>
+              <a:t>Test jobs on Arc</a:t>
+            </a:r>
+          </a:p>
+        </p:txBody>
+      </p:sp>
+      <p:sp>
+        <p:nvSpPr>
+          <p:cNvPr id="11" name="">
+            <a:extLst xmlns:a="http://schemas.openxmlformats.org/drawingml/2006/main">
+              <a:ext uri="{FF2B5EF4-FFF2-40B4-BE49-F238E27FC236}">
+                <a16:creationId xmlns:a16="http://schemas.microsoft.com/office/drawing/2014/main" id="{3667105D-9481-44A6-A0F8-4273A3F261A4}"/>
               </a:ext>
             </a:extLst>
           </p:cNvPr>
@@ -5433,10 +4895,10 @@
       </p:sp>
       <p:sp>
         <p:nvSpPr>
-          <p:cNvPr id="14" name="job-0">
-            <a:extLst xmlns:a="http://schemas.openxmlformats.org/drawingml/2006/main">
-              <a:ext uri="{FF2B5EF4-FFF2-40B4-BE49-F238E27FC236}">
-                <a16:creationId xmlns:a16="http://schemas.microsoft.com/office/drawing/2014/main" id="{B69FF0E6-D8CF-41F3-A9D9-A8B1816FE515}"/>
+          <p:cNvPr id="12" name="job-0">
+            <a:extLst xmlns:a="http://schemas.openxmlformats.org/drawingml/2006/main">
+              <a:ext uri="{FF2B5EF4-FFF2-40B4-BE49-F238E27FC236}">
+                <a16:creationId xmlns:a16="http://schemas.microsoft.com/office/drawing/2014/main" id="{B73CFA7F-112D-40B8-A5D3-4C63C6914D5D}"/>
               </a:ext>
             </a:extLst>
           </p:cNvPr>
@@ -5491,10 +4953,10 @@
       </p:sp>
       <p:sp>
         <p:nvSpPr>
-          <p:cNvPr id="15" name="job-0-result">
-            <a:extLst xmlns:a="http://schemas.openxmlformats.org/drawingml/2006/main">
-              <a:ext uri="{FF2B5EF4-FFF2-40B4-BE49-F238E27FC236}">
-                <a16:creationId xmlns:a16="http://schemas.microsoft.com/office/drawing/2014/main" id="{1C68678B-A1A4-4689-8DB4-D33B5FBC8D63}"/>
+          <p:cNvPr id="13" name="job-0-result">
+            <a:extLst xmlns:a="http://schemas.openxmlformats.org/drawingml/2006/main">
+              <a:ext uri="{FF2B5EF4-FFF2-40B4-BE49-F238E27FC236}">
+                <a16:creationId xmlns:a16="http://schemas.microsoft.com/office/drawing/2014/main" id="{994C4EB9-DC75-4495-A4E3-A6F701116058}"/>
               </a:ext>
             </a:extLst>
           </p:cNvPr>
@@ -5549,10 +5011,10 @@
       </p:sp>
       <p:sp>
         <p:nvSpPr>
-          <p:cNvPr id="16" name="">
-            <a:extLst xmlns:a="http://schemas.openxmlformats.org/drawingml/2006/main">
-              <a:ext uri="{FF2B5EF4-FFF2-40B4-BE49-F238E27FC236}">
-                <a16:creationId xmlns:a16="http://schemas.microsoft.com/office/drawing/2014/main" id="{52ECD535-B31D-4C21-BEA9-F1990BDE8D57}"/>
+          <p:cNvPr id="14" name="">
+            <a:extLst xmlns:a="http://schemas.openxmlformats.org/drawingml/2006/main">
+              <a:ext uri="{FF2B5EF4-FFF2-40B4-BE49-F238E27FC236}">
+                <a16:creationId xmlns:a16="http://schemas.microsoft.com/office/drawing/2014/main" id="{B1B3BDBB-80F6-4398-B594-D5F9D8171B4A}"/>
               </a:ext>
             </a:extLst>
           </p:cNvPr>
@@ -5580,10 +5042,10 @@
       </p:sp>
       <p:sp>
         <p:nvSpPr>
-          <p:cNvPr id="17" name="">
-            <a:extLst xmlns:a="http://schemas.openxmlformats.org/drawingml/2006/main">
-              <a:ext uri="{FF2B5EF4-FFF2-40B4-BE49-F238E27FC236}">
-                <a16:creationId xmlns:a16="http://schemas.microsoft.com/office/drawing/2014/main" id="{287C82AD-24B2-490D-BBF6-6C45D1A2A47E}"/>
+          <p:cNvPr id="15" name="">
+            <a:extLst xmlns:a="http://schemas.openxmlformats.org/drawingml/2006/main">
+              <a:ext uri="{FF2B5EF4-FFF2-40B4-BE49-F238E27FC236}">
+                <a16:creationId xmlns:a16="http://schemas.microsoft.com/office/drawing/2014/main" id="{86E5112C-BA5A-4507-9F44-4B6DD61FD80E}"/>
               </a:ext>
             </a:extLst>
           </p:cNvPr>
@@ -5611,10 +5073,10 @@
       </p:sp>
       <p:sp>
         <p:nvSpPr>
-          <p:cNvPr id="18" name="job-1">
-            <a:extLst xmlns:a="http://schemas.openxmlformats.org/drawingml/2006/main">
-              <a:ext uri="{FF2B5EF4-FFF2-40B4-BE49-F238E27FC236}">
-                <a16:creationId xmlns:a16="http://schemas.microsoft.com/office/drawing/2014/main" id="{3E4EBC3F-2D5B-4E82-B085-A8E4E8D1BD64}"/>
+          <p:cNvPr id="16" name="job-1">
+            <a:extLst xmlns:a="http://schemas.openxmlformats.org/drawingml/2006/main">
+              <a:ext uri="{FF2B5EF4-FFF2-40B4-BE49-F238E27FC236}">
+                <a16:creationId xmlns:a16="http://schemas.microsoft.com/office/drawing/2014/main" id="{2508C37B-E2A0-4E64-9E7F-34AA403FC26D}"/>
               </a:ext>
             </a:extLst>
           </p:cNvPr>
@@ -5669,10 +5131,10 @@
       </p:sp>
       <p:sp>
         <p:nvSpPr>
-          <p:cNvPr id="19" name="job-1-result">
-            <a:extLst xmlns:a="http://schemas.openxmlformats.org/drawingml/2006/main">
-              <a:ext uri="{FF2B5EF4-FFF2-40B4-BE49-F238E27FC236}">
-                <a16:creationId xmlns:a16="http://schemas.microsoft.com/office/drawing/2014/main" id="{4AEACC5B-B84F-45ED-B8D3-B12E06FC9445}"/>
+          <p:cNvPr id="17" name="job-1-result">
+            <a:extLst xmlns:a="http://schemas.openxmlformats.org/drawingml/2006/main">
+              <a:ext uri="{FF2B5EF4-FFF2-40B4-BE49-F238E27FC236}">
+                <a16:creationId xmlns:a16="http://schemas.microsoft.com/office/drawing/2014/main" id="{8FC0C10D-0476-4C3E-B009-F1AC9943925F}"/>
               </a:ext>
             </a:extLst>
           </p:cNvPr>
@@ -5727,10 +5189,10 @@
       </p:sp>
       <p:sp>
         <p:nvSpPr>
-          <p:cNvPr id="20" name="">
-            <a:extLst xmlns:a="http://schemas.openxmlformats.org/drawingml/2006/main">
-              <a:ext uri="{FF2B5EF4-FFF2-40B4-BE49-F238E27FC236}">
-                <a16:creationId xmlns:a16="http://schemas.microsoft.com/office/drawing/2014/main" id="{8617A886-17F6-4C2B-ADCC-ADDF967B6FF2}"/>
+          <p:cNvPr id="18" name="">
+            <a:extLst xmlns:a="http://schemas.openxmlformats.org/drawingml/2006/main">
+              <a:ext uri="{FF2B5EF4-FFF2-40B4-BE49-F238E27FC236}">
+                <a16:creationId xmlns:a16="http://schemas.microsoft.com/office/drawing/2014/main" id="{437B2A9A-5A17-4E03-BEAB-BE859EB6BD12}"/>
               </a:ext>
             </a:extLst>
           </p:cNvPr>
@@ -5758,10 +5220,10 @@
       </p:sp>
       <p:sp>
         <p:nvSpPr>
-          <p:cNvPr id="21" name="">
-            <a:extLst xmlns:a="http://schemas.openxmlformats.org/drawingml/2006/main">
-              <a:ext uri="{FF2B5EF4-FFF2-40B4-BE49-F238E27FC236}">
-                <a16:creationId xmlns:a16="http://schemas.microsoft.com/office/drawing/2014/main" id="{35FB3EAC-FACF-4773-8B6A-FC4854154F87}"/>
+          <p:cNvPr id="19" name="">
+            <a:extLst xmlns:a="http://schemas.openxmlformats.org/drawingml/2006/main">
+              <a:ext uri="{FF2B5EF4-FFF2-40B4-BE49-F238E27FC236}">
+                <a16:creationId xmlns:a16="http://schemas.microsoft.com/office/drawing/2014/main" id="{2CFB6C7B-4B39-484A-B5CA-0082B76778C5}"/>
               </a:ext>
             </a:extLst>
           </p:cNvPr>
@@ -5789,10 +5251,10 @@
       </p:sp>
       <p:sp>
         <p:nvSpPr>
-          <p:cNvPr id="22" name="job-2">
-            <a:extLst xmlns:a="http://schemas.openxmlformats.org/drawingml/2006/main">
-              <a:ext uri="{FF2B5EF4-FFF2-40B4-BE49-F238E27FC236}">
-                <a16:creationId xmlns:a16="http://schemas.microsoft.com/office/drawing/2014/main" id="{3C8F0442-F27D-4889-802D-BCFBF90C91B7}"/>
+          <p:cNvPr id="20" name="job-2">
+            <a:extLst xmlns:a="http://schemas.openxmlformats.org/drawingml/2006/main">
+              <a:ext uri="{FF2B5EF4-FFF2-40B4-BE49-F238E27FC236}">
+                <a16:creationId xmlns:a16="http://schemas.microsoft.com/office/drawing/2014/main" id="{1BEE5CC5-85D5-4E70-A501-512EF3AA41EE}"/>
               </a:ext>
             </a:extLst>
           </p:cNvPr>
@@ -5847,10 +5309,10 @@
       </p:sp>
       <p:sp>
         <p:nvSpPr>
-          <p:cNvPr id="23" name="job-2-result">
-            <a:extLst xmlns:a="http://schemas.openxmlformats.org/drawingml/2006/main">
-              <a:ext uri="{FF2B5EF4-FFF2-40B4-BE49-F238E27FC236}">
-                <a16:creationId xmlns:a16="http://schemas.microsoft.com/office/drawing/2014/main" id="{604BEF5D-4A1D-4CED-8CA4-AB858C028F3F}"/>
+          <p:cNvPr id="21" name="job-2-result">
+            <a:extLst xmlns:a="http://schemas.openxmlformats.org/drawingml/2006/main">
+              <a:ext uri="{FF2B5EF4-FFF2-40B4-BE49-F238E27FC236}">
+                <a16:creationId xmlns:a16="http://schemas.microsoft.com/office/drawing/2014/main" id="{411D8F28-81E3-4483-A1AA-2884FB5A96C8}"/>
               </a:ext>
             </a:extLst>
           </p:cNvPr>
@@ -5905,10 +5367,10 @@
       </p:sp>
       <p:sp>
         <p:nvSpPr>
-          <p:cNvPr id="24" name="">
-            <a:extLst xmlns:a="http://schemas.openxmlformats.org/drawingml/2006/main">
-              <a:ext uri="{FF2B5EF4-FFF2-40B4-BE49-F238E27FC236}">
-                <a16:creationId xmlns:a16="http://schemas.microsoft.com/office/drawing/2014/main" id="{FB523C2C-08C3-4BC9-A623-8B4EE0B8734C}"/>
+          <p:cNvPr id="22" name="">
+            <a:extLst xmlns:a="http://schemas.openxmlformats.org/drawingml/2006/main">
+              <a:ext uri="{FF2B5EF4-FFF2-40B4-BE49-F238E27FC236}">
+                <a16:creationId xmlns:a16="http://schemas.microsoft.com/office/drawing/2014/main" id="{457ED6F7-1A5F-4EC0-B40F-AF0DDD06FF93}"/>
               </a:ext>
             </a:extLst>
           </p:cNvPr>
@@ -5936,10 +5398,10 @@
       </p:sp>
       <p:sp>
         <p:nvSpPr>
-          <p:cNvPr id="25" name="test-strip">
-            <a:extLst xmlns:a="http://schemas.openxmlformats.org/drawingml/2006/main">
-              <a:ext uri="{FF2B5EF4-FFF2-40B4-BE49-F238E27FC236}">
-                <a16:creationId xmlns:a16="http://schemas.microsoft.com/office/drawing/2014/main" id="{FBB4BCEC-EDE5-43B4-82BD-1F008CA0EF85}"/>
+          <p:cNvPr id="23" name="test-strip">
+            <a:extLst xmlns:a="http://schemas.openxmlformats.org/drawingml/2006/main">
+              <a:ext uri="{FF2B5EF4-FFF2-40B4-BE49-F238E27FC236}">
+                <a16:creationId xmlns:a16="http://schemas.microsoft.com/office/drawing/2014/main" id="{8BBD28C0-720A-42EF-BD0B-239F5226625C}"/>
               </a:ext>
             </a:extLst>
           </p:cNvPr>
@@ -5969,10 +5431,10 @@
       </p:sp>
       <p:sp>
         <p:nvSpPr>
-          <p:cNvPr id="26" name="test-strip-copy">
-            <a:extLst xmlns:a="http://schemas.openxmlformats.org/drawingml/2006/main">
-              <a:ext uri="{FF2B5EF4-FFF2-40B4-BE49-F238E27FC236}">
-                <a16:creationId xmlns:a16="http://schemas.microsoft.com/office/drawing/2014/main" id="{DB66BAD7-CDC8-4FFC-8057-45312C9048BC}"/>
+          <p:cNvPr id="24" name="test-strip-copy">
+            <a:extLst xmlns:a="http://schemas.openxmlformats.org/drawingml/2006/main">
+              <a:ext uri="{FF2B5EF4-FFF2-40B4-BE49-F238E27FC236}">
+                <a16:creationId xmlns:a16="http://schemas.microsoft.com/office/drawing/2014/main" id="{499BE5F5-DA18-4D62-A552-A072F988E412}"/>
               </a:ext>
             </a:extLst>
           </p:cNvPr>
@@ -6020,154 +5482,7 @@
                 <a:ea typeface="Space Grotesk"/>
                 <a:cs typeface="Space Grotesk"/>
               </a:rPr>
-              <a:t>37 Foundry tests   ·   108 core tests   ·   14 desktop and mobile browser runs</a:t>
-            </a:r>
-          </a:p>
-        </p:txBody>
-      </p:sp>
-      <p:sp>
-        <p:nvSpPr>
-          <p:cNvPr id="27" name="">
-            <a:extLst xmlns:a="http://schemas.openxmlformats.org/drawingml/2006/main">
-              <a:ext uri="{FF2B5EF4-FFF2-40B4-BE49-F238E27FC236}">
-                <a16:creationId xmlns:a16="http://schemas.microsoft.com/office/drawing/2014/main" id="{0CAF2C16-E8F1-49AF-B766-6B5F72E505A0}"/>
-              </a:ext>
-            </a:extLst>
-          </p:cNvPr>
-          <p:cNvSpPr>
-            <a:spLocks xmlns:a="http://schemas.openxmlformats.org/drawingml/2006/main" noGrp="1"/>
-          </p:cNvSpPr>
-          <p:nvPr/>
-        </p:nvSpPr>
-        <p:spPr>
-          <a:xfrm xmlns:a="http://schemas.openxmlformats.org/drawingml/2006/main">
-            <a:off x="685800" y="6334125"/>
-            <a:ext cx="10820400" cy="9525"/>
-          </a:xfrm>
-          <a:prstGeom xmlns:a="http://schemas.openxmlformats.org/drawingml/2006/main" prst="rect">
-            <a:avLst/>
-          </a:prstGeom>
-          <a:solidFill xmlns:a="http://schemas.openxmlformats.org/drawingml/2006/main">
-            <a:srgbClr val="2B2B2B"/>
-          </a:solidFill>
-          <a:ln xmlns:a="http://schemas.openxmlformats.org/drawingml/2006/main" w="0">
-            <a:noFill/>
-            <a:prstDash val="solid"/>
-          </a:ln>
-        </p:spPr>
-      </p:sp>
-      <p:sp>
-        <p:nvSpPr>
-          <p:cNvPr id="28" name="footer-left">
-            <a:extLst xmlns:a="http://schemas.openxmlformats.org/drawingml/2006/main">
-              <a:ext uri="{FF2B5EF4-FFF2-40B4-BE49-F238E27FC236}">
-                <a16:creationId xmlns:a16="http://schemas.microsoft.com/office/drawing/2014/main" id="{DF2F1E6A-21F7-4023-9416-21C9C303CA46}"/>
-              </a:ext>
-            </a:extLst>
-          </p:cNvPr>
-          <p:cNvSpPr>
-            <a:spLocks xmlns:a="http://schemas.openxmlformats.org/drawingml/2006/main" noGrp="1"/>
-          </p:cNvSpPr>
-          <p:nvPr/>
-        </p:nvSpPr>
-        <p:spPr>
-          <a:xfrm xmlns:a="http://schemas.openxmlformats.org/drawingml/2006/main">
-            <a:off x="685800" y="6467475"/>
-            <a:ext cx="4381500" cy="190500"/>
-          </a:xfrm>
-          <a:prstGeom xmlns:a="http://schemas.openxmlformats.org/drawingml/2006/main" prst="rect">
-            <a:avLst/>
-          </a:prstGeom>
-          <a:noFill xmlns:a="http://schemas.openxmlformats.org/drawingml/2006/main"/>
-          <a:ln xmlns:a="http://schemas.openxmlformats.org/drawingml/2006/main" w="0">
-            <a:noFill/>
-            <a:prstDash val="solid"/>
-          </a:ln>
-        </p:spPr>
-        <p:txBody>
-          <a:bodyPr xmlns:a="http://schemas.openxmlformats.org/drawingml/2006/main" lIns="0" tIns="0" rIns="0" bIns="0" anchor="t">
-            <a:normAutofit fontScale="100000"/>
-          </a:bodyPr>
-          <a:lstStyle xmlns:a="http://schemas.openxmlformats.org/drawingml/2006/main"/>
-          <a:p xmlns:a="http://schemas.openxmlformats.org/drawingml/2006/main">
-            <a:pPr algn="l">
-              <a:defRPr sz="900" b="0">
-                <a:solidFill>
-                  <a:srgbClr val="94948E"/>
-                </a:solidFill>
-                <a:latin typeface="Space Grotesk"/>
-                <a:ea typeface="Space Grotesk"/>
-                <a:cs typeface="Space Grotesk"/>
-              </a:defRPr>
-            </a:pPr>
-            <a:r>
-              <a:rPr sz="900" b="0">
-                <a:solidFill>
-                  <a:srgbClr val="94948E"/>
-                </a:solidFill>
-                <a:latin typeface="Space Grotesk"/>
-                <a:ea typeface="Space Grotesk"/>
-                <a:cs typeface="Space Grotesk"/>
-              </a:rPr>
-              <a:t>Arc Testnet · chain ID 5042002</a:t>
-            </a:r>
-          </a:p>
-        </p:txBody>
-      </p:sp>
-      <p:sp>
-        <p:nvSpPr>
-          <p:cNvPr id="29" name="footer-right">
-            <a:extLst xmlns:a="http://schemas.openxmlformats.org/drawingml/2006/main">
-              <a:ext uri="{FF2B5EF4-FFF2-40B4-BE49-F238E27FC236}">
-                <a16:creationId xmlns:a16="http://schemas.microsoft.com/office/drawing/2014/main" id="{40209A71-F66B-44D9-972F-F88F2B17757D}"/>
-              </a:ext>
-            </a:extLst>
-          </p:cNvPr>
-          <p:cNvSpPr>
-            <a:spLocks xmlns:a="http://schemas.openxmlformats.org/drawingml/2006/main" noGrp="1"/>
-          </p:cNvSpPr>
-          <p:nvPr/>
-        </p:nvSpPr>
-        <p:spPr>
-          <a:xfrm xmlns:a="http://schemas.openxmlformats.org/drawingml/2006/main">
-            <a:off x="9220200" y="6467475"/>
-            <a:ext cx="2286000" cy="190500"/>
-          </a:xfrm>
-          <a:prstGeom xmlns:a="http://schemas.openxmlformats.org/drawingml/2006/main" prst="rect">
-            <a:avLst/>
-          </a:prstGeom>
-          <a:noFill xmlns:a="http://schemas.openxmlformats.org/drawingml/2006/main"/>
-          <a:ln xmlns:a="http://schemas.openxmlformats.org/drawingml/2006/main" w="0">
-            <a:noFill/>
-            <a:prstDash val="solid"/>
-          </a:ln>
-        </p:spPr>
-        <p:txBody>
-          <a:bodyPr xmlns:a="http://schemas.openxmlformats.org/drawingml/2006/main" lIns="0" tIns="0" rIns="0" bIns="0" anchor="t">
-            <a:normAutofit fontScale="100000"/>
-          </a:bodyPr>
-          <a:lstStyle xmlns:a="http://schemas.openxmlformats.org/drawingml/2006/main"/>
-          <a:p xmlns:a="http://schemas.openxmlformats.org/drawingml/2006/main">
-            <a:pPr algn="r">
-              <a:defRPr sz="900" b="0">
-                <a:solidFill>
-                  <a:srgbClr val="94948E"/>
-                </a:solidFill>
-                <a:latin typeface="Space Grotesk"/>
-                <a:ea typeface="Space Grotesk"/>
-                <a:cs typeface="Space Grotesk"/>
-              </a:defRPr>
-            </a:pPr>
-            <a:r>
-              <a:rPr sz="900" b="0">
-                <a:solidFill>
-                  <a:srgbClr val="94948E"/>
-                </a:solidFill>
-                <a:latin typeface="Space Grotesk"/>
-                <a:ea typeface="Space Grotesk"/>
-                <a:cs typeface="Space Grotesk"/>
-              </a:rPr>
-              <a:t>Agentic Economy</a:t>
+              <a:t>37 contract tests   ·   108 service tests   ·   14 browser tests</a:t>
             </a:r>
           </a:p>
         </p:txBody>
@@ -6175,7 +5490,7 @@
     </p:spTree>
     <p:extLst>
       <p:ext uri="{BB962C8B-B14F-4D97-AF65-F5344CB8AC3E}">
-        <p14:creationId xmlns:p14="http://schemas.microsoft.com/office/powerpoint/2010/main" val="1853615920"/>
+        <p14:creationId xmlns:p14="http://schemas.microsoft.com/office/powerpoint/2010/main" val="196577728"/>
       </p:ext>
     </p:extLst>
   </p:cSld>
@@ -6203,22 +5518,22 @@
       </p:grpSpPr>
       <p:sp>
         <p:nvSpPr>
-          <p:cNvPr id="32" name="section-5">
-            <a:extLst xmlns:a="http://schemas.openxmlformats.org/drawingml/2006/main">
-              <a:ext uri="{FF2B5EF4-FFF2-40B4-BE49-F238E27FC236}">
-                <a16:creationId xmlns:a16="http://schemas.microsoft.com/office/drawing/2014/main" id="{FED0F017-DDB0-41C0-A8C3-B44B255E396F}"/>
-              </a:ext>
-            </a:extLst>
-          </p:cNvPr>
-          <p:cNvSpPr>
-            <a:spLocks xmlns:a="http://schemas.openxmlformats.org/drawingml/2006/main" noGrp="1"/>
-          </p:cNvSpPr>
-          <p:nvPr/>
-        </p:nvSpPr>
-        <p:spPr>
-          <a:xfrm xmlns:a="http://schemas.openxmlformats.org/drawingml/2006/main">
-            <a:off x="685800" y="304800"/>
-            <a:ext cx="3048000" cy="190500"/>
+          <p:cNvPr id="27" name="page-5">
+            <a:extLst xmlns:a="http://schemas.openxmlformats.org/drawingml/2006/main">
+              <a:ext uri="{FF2B5EF4-FFF2-40B4-BE49-F238E27FC236}">
+                <a16:creationId xmlns:a16="http://schemas.microsoft.com/office/drawing/2014/main" id="{338276DC-25C3-443B-AAB2-4732436AC8D1}"/>
+              </a:ext>
+            </a:extLst>
+          </p:cNvPr>
+          <p:cNvSpPr>
+            <a:spLocks xmlns:a="http://schemas.openxmlformats.org/drawingml/2006/main" noGrp="1"/>
+          </p:cNvSpPr>
+          <p:nvPr/>
+        </p:nvSpPr>
+        <p:spPr>
+          <a:xfrm xmlns:a="http://schemas.openxmlformats.org/drawingml/2006/main">
+            <a:off x="10648950" y="304800"/>
+            <a:ext cx="857250" cy="190500"/>
           </a:xfrm>
           <a:prstGeom xmlns:a="http://schemas.openxmlformats.org/drawingml/2006/main" prst="rect">
             <a:avLst/>
@@ -6235,633 +5550,10 @@
           </a:bodyPr>
           <a:lstStyle xmlns:a="http://schemas.openxmlformats.org/drawingml/2006/main"/>
           <a:p xmlns:a="http://schemas.openxmlformats.org/drawingml/2006/main">
-            <a:pPr algn="l">
+            <a:pPr algn="r">
               <a:defRPr sz="975" b="0">
                 <a:solidFill>
                   <a:srgbClr val="94948E"/>
-                </a:solidFill>
-                <a:latin typeface="Space Grotesk"/>
-                <a:ea typeface="Space Grotesk"/>
-                <a:cs typeface="Space Grotesk"/>
-              </a:defRPr>
-            </a:pPr>
-            <a:r>
-              <a:rPr sz="975" b="0">
-                <a:solidFill>
-                  <a:srgbClr val="94948E"/>
-                </a:solidFill>
-                <a:latin typeface="Space Grotesk"/>
-                <a:ea typeface="Space Grotesk"/>
-                <a:cs typeface="Space Grotesk"/>
-              </a:rPr>
-              <a:t>vAPI Trust Network  ·  05</a:t>
-            </a:r>
-          </a:p>
-        </p:txBody>
-      </p:sp>
-      <p:sp>
-        <p:nvSpPr>
-          <p:cNvPr id="2" name="">
-            <a:extLst xmlns:a="http://schemas.openxmlformats.org/drawingml/2006/main">
-              <a:ext uri="{FF2B5EF4-FFF2-40B4-BE49-F238E27FC236}">
-                <a16:creationId xmlns:a16="http://schemas.microsoft.com/office/drawing/2014/main" id="{0EFE4EBA-46E2-45F8-A3E4-63738B359863}"/>
-              </a:ext>
-            </a:extLst>
-          </p:cNvPr>
-          <p:cNvSpPr>
-            <a:spLocks xmlns:a="http://schemas.openxmlformats.org/drawingml/2006/main" noGrp="1"/>
-          </p:cNvSpPr>
-          <p:nvPr/>
-        </p:nvSpPr>
-        <p:spPr>
-          <a:xfrm xmlns:a="http://schemas.openxmlformats.org/drawingml/2006/main">
-            <a:off x="685800" y="581025"/>
-            <a:ext cx="10820400" cy="9525"/>
-          </a:xfrm>
-          <a:prstGeom xmlns:a="http://schemas.openxmlformats.org/drawingml/2006/main" prst="rect">
-            <a:avLst/>
-          </a:prstGeom>
-          <a:solidFill xmlns:a="http://schemas.openxmlformats.org/drawingml/2006/main">
-            <a:srgbClr val="2B2B2B"/>
-          </a:solidFill>
-          <a:ln xmlns:a="http://schemas.openxmlformats.org/drawingml/2006/main" w="0">
-            <a:noFill/>
-            <a:prstDash val="solid"/>
-          </a:ln>
-        </p:spPr>
-      </p:sp>
-      <p:sp>
-        <p:nvSpPr>
-          <p:cNvPr id="3" name="">
-            <a:extLst xmlns:a="http://schemas.openxmlformats.org/drawingml/2006/main">
-              <a:ext uri="{FF2B5EF4-FFF2-40B4-BE49-F238E27FC236}">
-                <a16:creationId xmlns:a16="http://schemas.microsoft.com/office/drawing/2014/main" id="{990ACCD2-26D5-49D1-8008-6E38D294427B}"/>
-              </a:ext>
-            </a:extLst>
-          </p:cNvPr>
-          <p:cNvSpPr>
-            <a:spLocks xmlns:a="http://schemas.openxmlformats.org/drawingml/2006/main" noGrp="1"/>
-          </p:cNvSpPr>
-          <p:nvPr/>
-        </p:nvSpPr>
-        <p:spPr>
-          <a:xfrm xmlns:a="http://schemas.openxmlformats.org/drawingml/2006/main">
-            <a:off x="11410950" y="304800"/>
-            <a:ext cx="95250" cy="95250"/>
-          </a:xfrm>
-          <a:prstGeom xmlns:a="http://schemas.openxmlformats.org/drawingml/2006/main" prst="rect">
-            <a:avLst/>
-          </a:prstGeom>
-          <a:solidFill xmlns:a="http://schemas.openxmlformats.org/drawingml/2006/main">
-            <a:srgbClr val="FF7300"/>
-          </a:solidFill>
-          <a:ln xmlns:a="http://schemas.openxmlformats.org/drawingml/2006/main" w="0">
-            <a:noFill/>
-            <a:prstDash val="solid"/>
-          </a:ln>
-        </p:spPr>
-      </p:sp>
-      <p:sp>
-        <p:nvSpPr>
-          <p:cNvPr id="4" name="slide-title">
-            <a:extLst xmlns:a="http://schemas.openxmlformats.org/drawingml/2006/main">
-              <a:ext uri="{FF2B5EF4-FFF2-40B4-BE49-F238E27FC236}">
-                <a16:creationId xmlns:a16="http://schemas.microsoft.com/office/drawing/2014/main" id="{FED46B1A-539D-432C-8DF3-D4EE5401D333}"/>
-              </a:ext>
-            </a:extLst>
-          </p:cNvPr>
-          <p:cNvSpPr>
-            <a:spLocks xmlns:a="http://schemas.openxmlformats.org/drawingml/2006/main" noGrp="1"/>
-          </p:cNvSpPr>
-          <p:nvPr/>
-        </p:nvSpPr>
-        <p:spPr>
-          <a:xfrm xmlns:a="http://schemas.openxmlformats.org/drawingml/2006/main">
-            <a:off x="685800" y="838200"/>
-            <a:ext cx="10001250" cy="971550"/>
-          </a:xfrm>
-          <a:prstGeom xmlns:a="http://schemas.openxmlformats.org/drawingml/2006/main" prst="rect">
-            <a:avLst/>
-          </a:prstGeom>
-          <a:noFill xmlns:a="http://schemas.openxmlformats.org/drawingml/2006/main"/>
-          <a:ln xmlns:a="http://schemas.openxmlformats.org/drawingml/2006/main" w="0">
-            <a:noFill/>
-            <a:prstDash val="solid"/>
-          </a:ln>
-        </p:spPr>
-        <p:txBody>
-          <a:bodyPr xmlns:a="http://schemas.openxmlformats.org/drawingml/2006/main" lIns="0" tIns="0" rIns="0" bIns="0" anchor="t">
-            <a:normAutofit fontScale="100000"/>
-          </a:bodyPr>
-          <a:lstStyle xmlns:a="http://schemas.openxmlformats.org/drawingml/2006/main"/>
-          <a:p xmlns:a="http://schemas.openxmlformats.org/drawingml/2006/main">
-            <a:pPr algn="l">
-              <a:defRPr sz="3150" b="0">
-                <a:solidFill>
-                  <a:srgbClr val="FAFAFA"/>
-                </a:solidFill>
-                <a:latin typeface="Space Grotesk"/>
-                <a:ea typeface="Space Grotesk"/>
-                <a:cs typeface="Space Grotesk"/>
-              </a:defRPr>
-            </a:pPr>
-            <a:r>
-              <a:rPr sz="3150" b="0">
-                <a:solidFill>
-                  <a:srgbClr val="FAFAFA"/>
-                </a:solidFill>
-                <a:latin typeface="Space Grotesk"/>
-                <a:ea typeface="Space Grotesk"/>
-                <a:cs typeface="Space Grotesk"/>
-              </a:rPr>
-              <a:t>The next rehearsal must reach payout and settlement</a:t>
-            </a:r>
-          </a:p>
-        </p:txBody>
-      </p:sp>
-      <p:sp>
-        <p:nvSpPr>
-          <p:cNvPr id="5" name="last-run-title">
-            <a:extLst xmlns:a="http://schemas.openxmlformats.org/drawingml/2006/main">
-              <a:ext uri="{FF2B5EF4-FFF2-40B4-BE49-F238E27FC236}">
-                <a16:creationId xmlns:a16="http://schemas.microsoft.com/office/drawing/2014/main" id="{C59102E3-A652-4244-AEB6-C1A564D17D92}"/>
-              </a:ext>
-            </a:extLst>
-          </p:cNvPr>
-          <p:cNvSpPr>
-            <a:spLocks xmlns:a="http://schemas.openxmlformats.org/drawingml/2006/main" noGrp="1"/>
-          </p:cNvSpPr>
-          <p:nvPr/>
-        </p:nvSpPr>
-        <p:spPr>
-          <a:xfrm xmlns:a="http://schemas.openxmlformats.org/drawingml/2006/main">
-            <a:off x="685800" y="2114550"/>
-            <a:ext cx="4476750" cy="323850"/>
-          </a:xfrm>
-          <a:prstGeom xmlns:a="http://schemas.openxmlformats.org/drawingml/2006/main" prst="rect">
-            <a:avLst/>
-          </a:prstGeom>
-          <a:noFill xmlns:a="http://schemas.openxmlformats.org/drawingml/2006/main"/>
-          <a:ln xmlns:a="http://schemas.openxmlformats.org/drawingml/2006/main" w="0">
-            <a:noFill/>
-            <a:prstDash val="solid"/>
-          </a:ln>
-        </p:spPr>
-        <p:txBody>
-          <a:bodyPr xmlns:a="http://schemas.openxmlformats.org/drawingml/2006/main" lIns="0" tIns="0" rIns="0" bIns="0" anchor="t">
-            <a:normAutofit fontScale="100000"/>
-          </a:bodyPr>
-          <a:lstStyle xmlns:a="http://schemas.openxmlformats.org/drawingml/2006/main"/>
-          <a:p xmlns:a="http://schemas.openxmlformats.org/drawingml/2006/main">
-            <a:pPr algn="l">
-              <a:defRPr sz="1725" b="0">
-                <a:solidFill>
-                  <a:srgbClr val="FAFAFA"/>
-                </a:solidFill>
-                <a:latin typeface="Space Grotesk"/>
-                <a:ea typeface="Space Grotesk"/>
-                <a:cs typeface="Space Grotesk"/>
-              </a:defRPr>
-            </a:pPr>
-            <a:r>
-              <a:rPr sz="1725" b="0">
-                <a:solidFill>
-                  <a:srgbClr val="FAFAFA"/>
-                </a:solidFill>
-                <a:latin typeface="Space Grotesk"/>
-                <a:ea typeface="Space Grotesk"/>
-                <a:cs typeface="Space Grotesk"/>
-              </a:rPr>
-              <a:t>Last rehearsal · job 159917</a:t>
-            </a:r>
-          </a:p>
-        </p:txBody>
-      </p:sp>
-      <p:sp>
-        <p:nvSpPr>
-          <p:cNvPr id="6" name="">
-            <a:extLst xmlns:a="http://schemas.openxmlformats.org/drawingml/2006/main">
-              <a:ext uri="{FF2B5EF4-FFF2-40B4-BE49-F238E27FC236}">
-                <a16:creationId xmlns:a16="http://schemas.microsoft.com/office/drawing/2014/main" id="{F1B8A583-43D1-4088-8A7B-108363A6039F}"/>
-              </a:ext>
-            </a:extLst>
-          </p:cNvPr>
-          <p:cNvSpPr>
-            <a:spLocks xmlns:a="http://schemas.openxmlformats.org/drawingml/2006/main" noGrp="1"/>
-          </p:cNvSpPr>
-          <p:nvPr/>
-        </p:nvSpPr>
-        <p:spPr>
-          <a:xfrm xmlns:a="http://schemas.openxmlformats.org/drawingml/2006/main">
-            <a:off x="857250" y="2809875"/>
-            <a:ext cx="28575" cy="1714500"/>
-          </a:xfrm>
-          <a:prstGeom xmlns:a="http://schemas.openxmlformats.org/drawingml/2006/main" prst="rect">
-            <a:avLst/>
-          </a:prstGeom>
-          <a:solidFill xmlns:a="http://schemas.openxmlformats.org/drawingml/2006/main">
-            <a:srgbClr val="3B3B3B"/>
-          </a:solidFill>
-          <a:ln xmlns:a="http://schemas.openxmlformats.org/drawingml/2006/main" w="0">
-            <a:noFill/>
-            <a:prstDash val="solid"/>
-          </a:ln>
-        </p:spPr>
-      </p:sp>
-      <p:sp>
-        <p:nvSpPr>
-          <p:cNvPr id="7" name="">
-            <a:extLst xmlns:a="http://schemas.openxmlformats.org/drawingml/2006/main">
-              <a:ext uri="{FF2B5EF4-FFF2-40B4-BE49-F238E27FC236}">
-                <a16:creationId xmlns:a16="http://schemas.microsoft.com/office/drawing/2014/main" id="{BB472210-7615-4E35-9F15-85F3E9EFE98C}"/>
-              </a:ext>
-            </a:extLst>
-          </p:cNvPr>
-          <p:cNvSpPr>
-            <a:spLocks xmlns:a="http://schemas.openxmlformats.org/drawingml/2006/main" noGrp="1"/>
-          </p:cNvSpPr>
-          <p:nvPr/>
-        </p:nvSpPr>
-        <p:spPr>
-          <a:xfrm xmlns:a="http://schemas.openxmlformats.org/drawingml/2006/main">
-            <a:off x="781050" y="2724150"/>
-            <a:ext cx="180975" cy="180975"/>
-          </a:xfrm>
-          <a:prstGeom xmlns:a="http://schemas.openxmlformats.org/drawingml/2006/main" prst="rect">
-            <a:avLst/>
-          </a:prstGeom>
-          <a:solidFill xmlns:a="http://schemas.openxmlformats.org/drawingml/2006/main">
-            <a:srgbClr val="C3FF3D"/>
-          </a:solidFill>
-          <a:ln xmlns:a="http://schemas.openxmlformats.org/drawingml/2006/main" w="0">
-            <a:noFill/>
-            <a:prstDash val="solid"/>
-          </a:ln>
-        </p:spPr>
-      </p:sp>
-      <p:sp>
-        <p:nvSpPr>
-          <p:cNvPr id="8" name="last-run-0">
-            <a:extLst xmlns:a="http://schemas.openxmlformats.org/drawingml/2006/main">
-              <a:ext uri="{FF2B5EF4-FFF2-40B4-BE49-F238E27FC236}">
-                <a16:creationId xmlns:a16="http://schemas.microsoft.com/office/drawing/2014/main" id="{31E7FCEB-65A4-4B3B-ADAB-07366F081789}"/>
-              </a:ext>
-            </a:extLst>
-          </p:cNvPr>
-          <p:cNvSpPr>
-            <a:spLocks xmlns:a="http://schemas.openxmlformats.org/drawingml/2006/main" noGrp="1"/>
-          </p:cNvSpPr>
-          <p:nvPr/>
-        </p:nvSpPr>
-        <p:spPr>
-          <a:xfrm xmlns:a="http://schemas.openxmlformats.org/drawingml/2006/main">
-            <a:off x="1181100" y="2686050"/>
-            <a:ext cx="4667250" cy="342900"/>
-          </a:xfrm>
-          <a:prstGeom xmlns:a="http://schemas.openxmlformats.org/drawingml/2006/main" prst="rect">
-            <a:avLst/>
-          </a:prstGeom>
-          <a:noFill xmlns:a="http://schemas.openxmlformats.org/drawingml/2006/main"/>
-          <a:ln xmlns:a="http://schemas.openxmlformats.org/drawingml/2006/main" w="0">
-            <a:noFill/>
-            <a:prstDash val="solid"/>
-          </a:ln>
-        </p:spPr>
-        <p:txBody>
-          <a:bodyPr xmlns:a="http://schemas.openxmlformats.org/drawingml/2006/main" lIns="0" tIns="0" rIns="0" bIns="0" anchor="t">
-            <a:normAutofit fontScale="100000"/>
-          </a:bodyPr>
-          <a:lstStyle xmlns:a="http://schemas.openxmlformats.org/drawingml/2006/main"/>
-          <a:p xmlns:a="http://schemas.openxmlformats.org/drawingml/2006/main">
-            <a:pPr algn="l">
-              <a:defRPr sz="1425" b="0">
-                <a:solidFill>
-                  <a:srgbClr val="FAFAFA"/>
-                </a:solidFill>
-                <a:latin typeface="Space Grotesk"/>
-                <a:ea typeface="Space Grotesk"/>
-                <a:cs typeface="Space Grotesk"/>
-              </a:defRPr>
-            </a:pPr>
-            <a:r>
-              <a:rPr sz="1425" b="0">
-                <a:solidFill>
-                  <a:srgbClr val="FAFAFA"/>
-                </a:solidFill>
-                <a:latin typeface="Space Grotesk"/>
-                <a:ea typeface="Space Grotesk"/>
-                <a:cs typeface="Space Grotesk"/>
-              </a:rPr>
-              <a:t>Escrow created and funded</a:t>
-            </a:r>
-          </a:p>
-        </p:txBody>
-      </p:sp>
-      <p:sp>
-        <p:nvSpPr>
-          <p:cNvPr id="9" name="">
-            <a:extLst xmlns:a="http://schemas.openxmlformats.org/drawingml/2006/main">
-              <a:ext uri="{FF2B5EF4-FFF2-40B4-BE49-F238E27FC236}">
-                <a16:creationId xmlns:a16="http://schemas.microsoft.com/office/drawing/2014/main" id="{0B4E6801-76A7-45B2-8B08-0A7FFBEFEB31}"/>
-              </a:ext>
-            </a:extLst>
-          </p:cNvPr>
-          <p:cNvSpPr>
-            <a:spLocks xmlns:a="http://schemas.openxmlformats.org/drawingml/2006/main" noGrp="1"/>
-          </p:cNvSpPr>
-          <p:nvPr/>
-        </p:nvSpPr>
-        <p:spPr>
-          <a:xfrm xmlns:a="http://schemas.openxmlformats.org/drawingml/2006/main">
-            <a:off x="781050" y="3409950"/>
-            <a:ext cx="180975" cy="180975"/>
-          </a:xfrm>
-          <a:prstGeom xmlns:a="http://schemas.openxmlformats.org/drawingml/2006/main" prst="rect">
-            <a:avLst/>
-          </a:prstGeom>
-          <a:solidFill xmlns:a="http://schemas.openxmlformats.org/drawingml/2006/main">
-            <a:srgbClr val="8A37FB"/>
-          </a:solidFill>
-          <a:ln xmlns:a="http://schemas.openxmlformats.org/drawingml/2006/main" w="0">
-            <a:noFill/>
-            <a:prstDash val="solid"/>
-          </a:ln>
-        </p:spPr>
-      </p:sp>
-      <p:sp>
-        <p:nvSpPr>
-          <p:cNvPr id="10" name="last-run-1">
-            <a:extLst xmlns:a="http://schemas.openxmlformats.org/drawingml/2006/main">
-              <a:ext uri="{FF2B5EF4-FFF2-40B4-BE49-F238E27FC236}">
-                <a16:creationId xmlns:a16="http://schemas.microsoft.com/office/drawing/2014/main" id="{B7840F34-54E9-43D7-BAED-8E007991AACD}"/>
-              </a:ext>
-            </a:extLst>
-          </p:cNvPr>
-          <p:cNvSpPr>
-            <a:spLocks xmlns:a="http://schemas.openxmlformats.org/drawingml/2006/main" noGrp="1"/>
-          </p:cNvSpPr>
-          <p:nvPr/>
-        </p:nvSpPr>
-        <p:spPr>
-          <a:xfrm xmlns:a="http://schemas.openxmlformats.org/drawingml/2006/main">
-            <a:off x="1181100" y="3371850"/>
-            <a:ext cx="4667250" cy="342900"/>
-          </a:xfrm>
-          <a:prstGeom xmlns:a="http://schemas.openxmlformats.org/drawingml/2006/main" prst="rect">
-            <a:avLst/>
-          </a:prstGeom>
-          <a:noFill xmlns:a="http://schemas.openxmlformats.org/drawingml/2006/main"/>
-          <a:ln xmlns:a="http://schemas.openxmlformats.org/drawingml/2006/main" w="0">
-            <a:noFill/>
-            <a:prstDash val="solid"/>
-          </a:ln>
-        </p:spPr>
-        <p:txBody>
-          <a:bodyPr xmlns:a="http://schemas.openxmlformats.org/drawingml/2006/main" lIns="0" tIns="0" rIns="0" bIns="0" anchor="t">
-            <a:normAutofit fontScale="100000"/>
-          </a:bodyPr>
-          <a:lstStyle xmlns:a="http://schemas.openxmlformats.org/drawingml/2006/main"/>
-          <a:p xmlns:a="http://schemas.openxmlformats.org/drawingml/2006/main">
-            <a:pPr algn="l">
-              <a:defRPr sz="1425" b="0">
-                <a:solidFill>
-                  <a:srgbClr val="FAFAFA"/>
-                </a:solidFill>
-                <a:latin typeface="Space Grotesk"/>
-                <a:ea typeface="Space Grotesk"/>
-                <a:cs typeface="Space Grotesk"/>
-              </a:defRPr>
-            </a:pPr>
-            <a:r>
-              <a:rPr sz="1425" b="0">
-                <a:solidFill>
-                  <a:srgbClr val="FAFAFA"/>
-                </a:solidFill>
-                <a:latin typeface="Space Grotesk"/>
-                <a:ea typeface="Space Grotesk"/>
-                <a:cs typeface="Space Grotesk"/>
-              </a:rPr>
-              <a:t>0.25 USDC x402 payment accepted</a:t>
-            </a:r>
-          </a:p>
-        </p:txBody>
-      </p:sp>
-      <p:sp>
-        <p:nvSpPr>
-          <p:cNvPr id="11" name="">
-            <a:extLst xmlns:a="http://schemas.openxmlformats.org/drawingml/2006/main">
-              <a:ext uri="{FF2B5EF4-FFF2-40B4-BE49-F238E27FC236}">
-                <a16:creationId xmlns:a16="http://schemas.microsoft.com/office/drawing/2014/main" id="{3BCBD7FB-4132-49A1-AC79-7A3713022FD4}"/>
-              </a:ext>
-            </a:extLst>
-          </p:cNvPr>
-          <p:cNvSpPr>
-            <a:spLocks xmlns:a="http://schemas.openxmlformats.org/drawingml/2006/main" noGrp="1"/>
-          </p:cNvSpPr>
-          <p:nvPr/>
-        </p:nvSpPr>
-        <p:spPr>
-          <a:xfrm xmlns:a="http://schemas.openxmlformats.org/drawingml/2006/main">
-            <a:off x="781050" y="4095750"/>
-            <a:ext cx="180975" cy="180975"/>
-          </a:xfrm>
-          <a:prstGeom xmlns:a="http://schemas.openxmlformats.org/drawingml/2006/main" prst="rect">
-            <a:avLst/>
-          </a:prstGeom>
-          <a:solidFill xmlns:a="http://schemas.openxmlformats.org/drawingml/2006/main">
-            <a:srgbClr val="FF337C"/>
-          </a:solidFill>
-          <a:ln xmlns:a="http://schemas.openxmlformats.org/drawingml/2006/main" w="0">
-            <a:noFill/>
-            <a:prstDash val="solid"/>
-          </a:ln>
-        </p:spPr>
-      </p:sp>
-      <p:sp>
-        <p:nvSpPr>
-          <p:cNvPr id="12" name="last-run-2">
-            <a:extLst xmlns:a="http://schemas.openxmlformats.org/drawingml/2006/main">
-              <a:ext uri="{FF2B5EF4-FFF2-40B4-BE49-F238E27FC236}">
-                <a16:creationId xmlns:a16="http://schemas.microsoft.com/office/drawing/2014/main" id="{9DCD6A87-2E43-4F6F-973D-36BF2B1924E1}"/>
-              </a:ext>
-            </a:extLst>
-          </p:cNvPr>
-          <p:cNvSpPr>
-            <a:spLocks xmlns:a="http://schemas.openxmlformats.org/drawingml/2006/main" noGrp="1"/>
-          </p:cNvSpPr>
-          <p:nvPr/>
-        </p:nvSpPr>
-        <p:spPr>
-          <a:xfrm xmlns:a="http://schemas.openxmlformats.org/drawingml/2006/main">
-            <a:off x="1181100" y="4057650"/>
-            <a:ext cx="4667250" cy="342900"/>
-          </a:xfrm>
-          <a:prstGeom xmlns:a="http://schemas.openxmlformats.org/drawingml/2006/main" prst="rect">
-            <a:avLst/>
-          </a:prstGeom>
-          <a:noFill xmlns:a="http://schemas.openxmlformats.org/drawingml/2006/main"/>
-          <a:ln xmlns:a="http://schemas.openxmlformats.org/drawingml/2006/main" w="0">
-            <a:noFill/>
-            <a:prstDash val="solid"/>
-          </a:ln>
-        </p:spPr>
-        <p:txBody>
-          <a:bodyPr xmlns:a="http://schemas.openxmlformats.org/drawingml/2006/main" lIns="0" tIns="0" rIns="0" bIns="0" anchor="t">
-            <a:normAutofit fontScale="100000"/>
-          </a:bodyPr>
-          <a:lstStyle xmlns:a="http://schemas.openxmlformats.org/drawingml/2006/main"/>
-          <a:p xmlns:a="http://schemas.openxmlformats.org/drawingml/2006/main">
-            <a:pPr algn="l">
-              <a:defRPr sz="1425" b="0">
-                <a:solidFill>
-                  <a:srgbClr val="B0B0AB"/>
-                </a:solidFill>
-                <a:latin typeface="Space Grotesk"/>
-                <a:ea typeface="Space Grotesk"/>
-                <a:cs typeface="Space Grotesk"/>
-              </a:defRPr>
-            </a:pPr>
-            <a:r>
-              <a:rPr sz="1425" b="0">
-                <a:solidFill>
-                  <a:srgbClr val="B0B0AB"/>
-                </a:solidFill>
-                <a:latin typeface="Space Grotesk"/>
-                <a:ea typeface="Space Grotesk"/>
-                <a:cs typeface="Space Grotesk"/>
-              </a:rPr>
-              <a:t>Telegram review expired before a verdict</a:t>
-            </a:r>
-          </a:p>
-        </p:txBody>
-      </p:sp>
-      <p:sp>
-        <p:nvSpPr>
-          <p:cNvPr id="13" name="">
-            <a:extLst xmlns:a="http://schemas.openxmlformats.org/drawingml/2006/main">
-              <a:ext uri="{FF2B5EF4-FFF2-40B4-BE49-F238E27FC236}">
-                <a16:creationId xmlns:a16="http://schemas.microsoft.com/office/drawing/2014/main" id="{F526B21D-598C-415A-B89C-81319288A1F6}"/>
-              </a:ext>
-            </a:extLst>
-          </p:cNvPr>
-          <p:cNvSpPr>
-            <a:spLocks xmlns:a="http://schemas.openxmlformats.org/drawingml/2006/main" noGrp="1"/>
-          </p:cNvSpPr>
-          <p:nvPr/>
-        </p:nvSpPr>
-        <p:spPr>
-          <a:xfrm xmlns:a="http://schemas.openxmlformats.org/drawingml/2006/main">
-            <a:off x="6286500" y="2019300"/>
-            <a:ext cx="9525" cy="3238500"/>
-          </a:xfrm>
-          <a:prstGeom xmlns:a="http://schemas.openxmlformats.org/drawingml/2006/main" prst="rect">
-            <a:avLst/>
-          </a:prstGeom>
-          <a:solidFill xmlns:a="http://schemas.openxmlformats.org/drawingml/2006/main">
-            <a:srgbClr val="2B2B2B"/>
-          </a:solidFill>
-          <a:ln xmlns:a="http://schemas.openxmlformats.org/drawingml/2006/main" w="0">
-            <a:noFill/>
-            <a:prstDash val="solid"/>
-          </a:ln>
-        </p:spPr>
-      </p:sp>
-      <p:sp>
-        <p:nvSpPr>
-          <p:cNvPr id="14" name="next-run-title">
-            <a:extLst xmlns:a="http://schemas.openxmlformats.org/drawingml/2006/main">
-              <a:ext uri="{FF2B5EF4-FFF2-40B4-BE49-F238E27FC236}">
-                <a16:creationId xmlns:a16="http://schemas.microsoft.com/office/drawing/2014/main" id="{B756B283-8223-4649-8C7F-14D9544809DB}"/>
-              </a:ext>
-            </a:extLst>
-          </p:cNvPr>
-          <p:cNvSpPr>
-            <a:spLocks xmlns:a="http://schemas.openxmlformats.org/drawingml/2006/main" noGrp="1"/>
-          </p:cNvSpPr>
-          <p:nvPr/>
-        </p:nvSpPr>
-        <p:spPr>
-          <a:xfrm xmlns:a="http://schemas.openxmlformats.org/drawingml/2006/main">
-            <a:off x="6762750" y="2114550"/>
-            <a:ext cx="2857500" cy="323850"/>
-          </a:xfrm>
-          <a:prstGeom xmlns:a="http://schemas.openxmlformats.org/drawingml/2006/main" prst="rect">
-            <a:avLst/>
-          </a:prstGeom>
-          <a:noFill xmlns:a="http://schemas.openxmlformats.org/drawingml/2006/main"/>
-          <a:ln xmlns:a="http://schemas.openxmlformats.org/drawingml/2006/main" w="0">
-            <a:noFill/>
-            <a:prstDash val="solid"/>
-          </a:ln>
-        </p:spPr>
-        <p:txBody>
-          <a:bodyPr xmlns:a="http://schemas.openxmlformats.org/drawingml/2006/main" lIns="0" tIns="0" rIns="0" bIns="0" anchor="t">
-            <a:normAutofit fontScale="100000"/>
-          </a:bodyPr>
-          <a:lstStyle xmlns:a="http://schemas.openxmlformats.org/drawingml/2006/main"/>
-          <a:p xmlns:a="http://schemas.openxmlformats.org/drawingml/2006/main">
-            <a:pPr algn="l">
-              <a:defRPr sz="1725" b="0">
-                <a:solidFill>
-                  <a:srgbClr val="FAFAFA"/>
-                </a:solidFill>
-                <a:latin typeface="Space Grotesk"/>
-                <a:ea typeface="Space Grotesk"/>
-                <a:cs typeface="Space Grotesk"/>
-              </a:defRPr>
-            </a:pPr>
-            <a:r>
-              <a:rPr sz="1725" b="0">
-                <a:solidFill>
-                  <a:srgbClr val="FAFAFA"/>
-                </a:solidFill>
-                <a:latin typeface="Space Grotesk"/>
-                <a:ea typeface="Space Grotesk"/>
-                <a:cs typeface="Space Grotesk"/>
-              </a:rPr>
-              <a:t>Next run</a:t>
-            </a:r>
-          </a:p>
-        </p:txBody>
-      </p:sp>
-      <p:sp>
-        <p:nvSpPr>
-          <p:cNvPr id="15" name="next-run-number-0">
-            <a:extLst xmlns:a="http://schemas.openxmlformats.org/drawingml/2006/main">
-              <a:ext uri="{FF2B5EF4-FFF2-40B4-BE49-F238E27FC236}">
-                <a16:creationId xmlns:a16="http://schemas.microsoft.com/office/drawing/2014/main" id="{8178736D-4A94-4E73-A654-2594125E024D}"/>
-              </a:ext>
-            </a:extLst>
-          </p:cNvPr>
-          <p:cNvSpPr>
-            <a:spLocks xmlns:a="http://schemas.openxmlformats.org/drawingml/2006/main" noGrp="1"/>
-          </p:cNvSpPr>
-          <p:nvPr/>
-        </p:nvSpPr>
-        <p:spPr>
-          <a:xfrm xmlns:a="http://schemas.openxmlformats.org/drawingml/2006/main">
-            <a:off x="6762750" y="2762250"/>
-            <a:ext cx="323850" cy="247650"/>
-          </a:xfrm>
-          <a:prstGeom xmlns:a="http://schemas.openxmlformats.org/drawingml/2006/main" prst="rect">
-            <a:avLst/>
-          </a:prstGeom>
-          <a:noFill xmlns:a="http://schemas.openxmlformats.org/drawingml/2006/main"/>
-          <a:ln xmlns:a="http://schemas.openxmlformats.org/drawingml/2006/main" w="0">
-            <a:noFill/>
-            <a:prstDash val="solid"/>
-          </a:ln>
-        </p:spPr>
-        <p:txBody>
-          <a:bodyPr xmlns:a="http://schemas.openxmlformats.org/drawingml/2006/main" lIns="0" tIns="0" rIns="0" bIns="0" anchor="t">
-            <a:normAutofit fontScale="100000"/>
-          </a:bodyPr>
-          <a:lstStyle xmlns:a="http://schemas.openxmlformats.org/drawingml/2006/main"/>
-          <a:p xmlns:a="http://schemas.openxmlformats.org/drawingml/2006/main">
-            <a:pPr algn="l">
-              <a:defRPr sz="1125" b="0">
-                <a:solidFill>
-                  <a:srgbClr val="FF7300"/>
                 </a:solidFill>
                 <a:latin typeface="IBM Plex Mono"/>
                 <a:ea typeface="IBM Plex Mono"/>
@@ -6869,6 +5561,567 @@
               </a:defRPr>
             </a:pPr>
             <a:r>
+              <a:rPr sz="975" b="0">
+                <a:solidFill>
+                  <a:srgbClr val="94948E"/>
+                </a:solidFill>
+                <a:latin typeface="IBM Plex Mono"/>
+                <a:ea typeface="IBM Plex Mono"/>
+                <a:cs typeface="IBM Plex Mono"/>
+              </a:rPr>
+              <a:t>05 / 05</a:t>
+            </a:r>
+          </a:p>
+        </p:txBody>
+      </p:sp>
+      <p:sp>
+        <p:nvSpPr>
+          <p:cNvPr id="2" name="slide-title">
+            <a:extLst xmlns:a="http://schemas.openxmlformats.org/drawingml/2006/main">
+              <a:ext uri="{FF2B5EF4-FFF2-40B4-BE49-F238E27FC236}">
+                <a16:creationId xmlns:a16="http://schemas.microsoft.com/office/drawing/2014/main" id="{942FDA42-4698-4C0D-BED3-DD22CDFD7EF0}"/>
+              </a:ext>
+            </a:extLst>
+          </p:cNvPr>
+          <p:cNvSpPr>
+            <a:spLocks xmlns:a="http://schemas.openxmlformats.org/drawingml/2006/main" noGrp="1"/>
+          </p:cNvSpPr>
+          <p:nvPr/>
+        </p:nvSpPr>
+        <p:spPr>
+          <a:xfrm xmlns:a="http://schemas.openxmlformats.org/drawingml/2006/main">
+            <a:off x="685800" y="838200"/>
+            <a:ext cx="10001250" cy="971550"/>
+          </a:xfrm>
+          <a:prstGeom xmlns:a="http://schemas.openxmlformats.org/drawingml/2006/main" prst="rect">
+            <a:avLst/>
+          </a:prstGeom>
+          <a:noFill xmlns:a="http://schemas.openxmlformats.org/drawingml/2006/main"/>
+          <a:ln xmlns:a="http://schemas.openxmlformats.org/drawingml/2006/main" w="0">
+            <a:noFill/>
+            <a:prstDash val="solid"/>
+          </a:ln>
+        </p:spPr>
+        <p:txBody>
+          <a:bodyPr xmlns:a="http://schemas.openxmlformats.org/drawingml/2006/main" lIns="0" tIns="0" rIns="0" bIns="0" anchor="t">
+            <a:normAutofit fontScale="100000"/>
+          </a:bodyPr>
+          <a:lstStyle xmlns:a="http://schemas.openxmlformats.org/drawingml/2006/main"/>
+          <a:p xmlns:a="http://schemas.openxmlformats.org/drawingml/2006/main">
+            <a:pPr algn="l">
+              <a:defRPr sz="3150" b="0">
+                <a:solidFill>
+                  <a:srgbClr val="FAFAFA"/>
+                </a:solidFill>
+                <a:latin typeface="Space Grotesk"/>
+                <a:ea typeface="Space Grotesk"/>
+                <a:cs typeface="Space Grotesk"/>
+              </a:defRPr>
+            </a:pPr>
+            <a:r>
+              <a:rPr sz="3150" b="0">
+                <a:solidFill>
+                  <a:srgbClr val="FAFAFA"/>
+                </a:solidFill>
+                <a:latin typeface="Space Grotesk"/>
+                <a:ea typeface="Space Grotesk"/>
+                <a:cs typeface="Space Grotesk"/>
+              </a:rPr>
+              <a:t>The next live run must reach payout and settlement.</a:t>
+            </a:r>
+          </a:p>
+        </p:txBody>
+      </p:sp>
+      <p:sp>
+        <p:nvSpPr>
+          <p:cNvPr id="3" name="last-run-title">
+            <a:extLst xmlns:a="http://schemas.openxmlformats.org/drawingml/2006/main">
+              <a:ext uri="{FF2B5EF4-FFF2-40B4-BE49-F238E27FC236}">
+                <a16:creationId xmlns:a16="http://schemas.microsoft.com/office/drawing/2014/main" id="{8D7C9013-04C4-494F-881F-AD3A7FE7C059}"/>
+              </a:ext>
+            </a:extLst>
+          </p:cNvPr>
+          <p:cNvSpPr>
+            <a:spLocks xmlns:a="http://schemas.openxmlformats.org/drawingml/2006/main" noGrp="1"/>
+          </p:cNvSpPr>
+          <p:nvPr/>
+        </p:nvSpPr>
+        <p:spPr>
+          <a:xfrm xmlns:a="http://schemas.openxmlformats.org/drawingml/2006/main">
+            <a:off x="685800" y="2114550"/>
+            <a:ext cx="4476750" cy="323850"/>
+          </a:xfrm>
+          <a:prstGeom xmlns:a="http://schemas.openxmlformats.org/drawingml/2006/main" prst="rect">
+            <a:avLst/>
+          </a:prstGeom>
+          <a:noFill xmlns:a="http://schemas.openxmlformats.org/drawingml/2006/main"/>
+          <a:ln xmlns:a="http://schemas.openxmlformats.org/drawingml/2006/main" w="0">
+            <a:noFill/>
+            <a:prstDash val="solid"/>
+          </a:ln>
+        </p:spPr>
+        <p:txBody>
+          <a:bodyPr xmlns:a="http://schemas.openxmlformats.org/drawingml/2006/main" lIns="0" tIns="0" rIns="0" bIns="0" anchor="t">
+            <a:normAutofit fontScale="100000"/>
+          </a:bodyPr>
+          <a:lstStyle xmlns:a="http://schemas.openxmlformats.org/drawingml/2006/main"/>
+          <a:p xmlns:a="http://schemas.openxmlformats.org/drawingml/2006/main">
+            <a:pPr algn="l">
+              <a:defRPr sz="1725" b="0">
+                <a:solidFill>
+                  <a:srgbClr val="FAFAFA"/>
+                </a:solidFill>
+                <a:latin typeface="Space Grotesk"/>
+                <a:ea typeface="Space Grotesk"/>
+                <a:cs typeface="Space Grotesk"/>
+              </a:defRPr>
+            </a:pPr>
+            <a:r>
+              <a:rPr sz="1725" b="0">
+                <a:solidFill>
+                  <a:srgbClr val="FAFAFA"/>
+                </a:solidFill>
+                <a:latin typeface="Space Grotesk"/>
+                <a:ea typeface="Space Grotesk"/>
+                <a:cs typeface="Space Grotesk"/>
+              </a:rPr>
+              <a:t>Job 159917</a:t>
+            </a:r>
+          </a:p>
+        </p:txBody>
+      </p:sp>
+      <p:sp>
+        <p:nvSpPr>
+          <p:cNvPr id="4" name="">
+            <a:extLst xmlns:a="http://schemas.openxmlformats.org/drawingml/2006/main">
+              <a:ext uri="{FF2B5EF4-FFF2-40B4-BE49-F238E27FC236}">
+                <a16:creationId xmlns:a16="http://schemas.microsoft.com/office/drawing/2014/main" id="{1BE73B10-6F8F-4935-B96C-DB08B8CA557E}"/>
+              </a:ext>
+            </a:extLst>
+          </p:cNvPr>
+          <p:cNvSpPr>
+            <a:spLocks xmlns:a="http://schemas.openxmlformats.org/drawingml/2006/main" noGrp="1"/>
+          </p:cNvSpPr>
+          <p:nvPr/>
+        </p:nvSpPr>
+        <p:spPr>
+          <a:xfrm xmlns:a="http://schemas.openxmlformats.org/drawingml/2006/main">
+            <a:off x="857250" y="2809875"/>
+            <a:ext cx="28575" cy="1714500"/>
+          </a:xfrm>
+          <a:prstGeom xmlns:a="http://schemas.openxmlformats.org/drawingml/2006/main" prst="rect">
+            <a:avLst/>
+          </a:prstGeom>
+          <a:solidFill xmlns:a="http://schemas.openxmlformats.org/drawingml/2006/main">
+            <a:srgbClr val="3B3B3B"/>
+          </a:solidFill>
+          <a:ln xmlns:a="http://schemas.openxmlformats.org/drawingml/2006/main" w="0">
+            <a:noFill/>
+            <a:prstDash val="solid"/>
+          </a:ln>
+        </p:spPr>
+      </p:sp>
+      <p:sp>
+        <p:nvSpPr>
+          <p:cNvPr id="5" name="">
+            <a:extLst xmlns:a="http://schemas.openxmlformats.org/drawingml/2006/main">
+              <a:ext uri="{FF2B5EF4-FFF2-40B4-BE49-F238E27FC236}">
+                <a16:creationId xmlns:a16="http://schemas.microsoft.com/office/drawing/2014/main" id="{6978EB3B-2CA3-4E1C-8F5E-1C23D4CF4880}"/>
+              </a:ext>
+            </a:extLst>
+          </p:cNvPr>
+          <p:cNvSpPr>
+            <a:spLocks xmlns:a="http://schemas.openxmlformats.org/drawingml/2006/main" noGrp="1"/>
+          </p:cNvSpPr>
+          <p:nvPr/>
+        </p:nvSpPr>
+        <p:spPr>
+          <a:xfrm xmlns:a="http://schemas.openxmlformats.org/drawingml/2006/main">
+            <a:off x="781050" y="2724150"/>
+            <a:ext cx="180975" cy="180975"/>
+          </a:xfrm>
+          <a:prstGeom xmlns:a="http://schemas.openxmlformats.org/drawingml/2006/main" prst="rect">
+            <a:avLst/>
+          </a:prstGeom>
+          <a:solidFill xmlns:a="http://schemas.openxmlformats.org/drawingml/2006/main">
+            <a:srgbClr val="C3FF3D"/>
+          </a:solidFill>
+          <a:ln xmlns:a="http://schemas.openxmlformats.org/drawingml/2006/main" w="0">
+            <a:noFill/>
+            <a:prstDash val="solid"/>
+          </a:ln>
+        </p:spPr>
+      </p:sp>
+      <p:sp>
+        <p:nvSpPr>
+          <p:cNvPr id="6" name="last-run-0">
+            <a:extLst xmlns:a="http://schemas.openxmlformats.org/drawingml/2006/main">
+              <a:ext uri="{FF2B5EF4-FFF2-40B4-BE49-F238E27FC236}">
+                <a16:creationId xmlns:a16="http://schemas.microsoft.com/office/drawing/2014/main" id="{9F99BB48-3701-4073-8460-128DE1ED89DF}"/>
+              </a:ext>
+            </a:extLst>
+          </p:cNvPr>
+          <p:cNvSpPr>
+            <a:spLocks xmlns:a="http://schemas.openxmlformats.org/drawingml/2006/main" noGrp="1"/>
+          </p:cNvSpPr>
+          <p:nvPr/>
+        </p:nvSpPr>
+        <p:spPr>
+          <a:xfrm xmlns:a="http://schemas.openxmlformats.org/drawingml/2006/main">
+            <a:off x="1181100" y="2686050"/>
+            <a:ext cx="4667250" cy="342900"/>
+          </a:xfrm>
+          <a:prstGeom xmlns:a="http://schemas.openxmlformats.org/drawingml/2006/main" prst="rect">
+            <a:avLst/>
+          </a:prstGeom>
+          <a:noFill xmlns:a="http://schemas.openxmlformats.org/drawingml/2006/main"/>
+          <a:ln xmlns:a="http://schemas.openxmlformats.org/drawingml/2006/main" w="0">
+            <a:noFill/>
+            <a:prstDash val="solid"/>
+          </a:ln>
+        </p:spPr>
+        <p:txBody>
+          <a:bodyPr xmlns:a="http://schemas.openxmlformats.org/drawingml/2006/main" lIns="0" tIns="0" rIns="0" bIns="0" anchor="t">
+            <a:normAutofit fontScale="100000"/>
+          </a:bodyPr>
+          <a:lstStyle xmlns:a="http://schemas.openxmlformats.org/drawingml/2006/main"/>
+          <a:p xmlns:a="http://schemas.openxmlformats.org/drawingml/2006/main">
+            <a:pPr algn="l">
+              <a:defRPr sz="1425" b="0">
+                <a:solidFill>
+                  <a:srgbClr val="FAFAFA"/>
+                </a:solidFill>
+                <a:latin typeface="Space Grotesk"/>
+                <a:ea typeface="Space Grotesk"/>
+                <a:cs typeface="Space Grotesk"/>
+              </a:defRPr>
+            </a:pPr>
+            <a:r>
+              <a:rPr sz="1425" b="0">
+                <a:solidFill>
+                  <a:srgbClr val="FAFAFA"/>
+                </a:solidFill>
+                <a:latin typeface="Space Grotesk"/>
+                <a:ea typeface="Space Grotesk"/>
+                <a:cs typeface="Space Grotesk"/>
+              </a:rPr>
+              <a:t>Escrow created and funded</a:t>
+            </a:r>
+          </a:p>
+        </p:txBody>
+      </p:sp>
+      <p:sp>
+        <p:nvSpPr>
+          <p:cNvPr id="7" name="">
+            <a:extLst xmlns:a="http://schemas.openxmlformats.org/drawingml/2006/main">
+              <a:ext uri="{FF2B5EF4-FFF2-40B4-BE49-F238E27FC236}">
+                <a16:creationId xmlns:a16="http://schemas.microsoft.com/office/drawing/2014/main" id="{E875F93E-7B59-4B32-86A9-542EEB0365AA}"/>
+              </a:ext>
+            </a:extLst>
+          </p:cNvPr>
+          <p:cNvSpPr>
+            <a:spLocks xmlns:a="http://schemas.openxmlformats.org/drawingml/2006/main" noGrp="1"/>
+          </p:cNvSpPr>
+          <p:nvPr/>
+        </p:nvSpPr>
+        <p:spPr>
+          <a:xfrm xmlns:a="http://schemas.openxmlformats.org/drawingml/2006/main">
+            <a:off x="781050" y="3409950"/>
+            <a:ext cx="180975" cy="180975"/>
+          </a:xfrm>
+          <a:prstGeom xmlns:a="http://schemas.openxmlformats.org/drawingml/2006/main" prst="rect">
+            <a:avLst/>
+          </a:prstGeom>
+          <a:solidFill xmlns:a="http://schemas.openxmlformats.org/drawingml/2006/main">
+            <a:srgbClr val="8A37FB"/>
+          </a:solidFill>
+          <a:ln xmlns:a="http://schemas.openxmlformats.org/drawingml/2006/main" w="0">
+            <a:noFill/>
+            <a:prstDash val="solid"/>
+          </a:ln>
+        </p:spPr>
+      </p:sp>
+      <p:sp>
+        <p:nvSpPr>
+          <p:cNvPr id="8" name="last-run-1">
+            <a:extLst xmlns:a="http://schemas.openxmlformats.org/drawingml/2006/main">
+              <a:ext uri="{FF2B5EF4-FFF2-40B4-BE49-F238E27FC236}">
+                <a16:creationId xmlns:a16="http://schemas.microsoft.com/office/drawing/2014/main" id="{60751870-F511-45A7-9B22-C51EE94A4291}"/>
+              </a:ext>
+            </a:extLst>
+          </p:cNvPr>
+          <p:cNvSpPr>
+            <a:spLocks xmlns:a="http://schemas.openxmlformats.org/drawingml/2006/main" noGrp="1"/>
+          </p:cNvSpPr>
+          <p:nvPr/>
+        </p:nvSpPr>
+        <p:spPr>
+          <a:xfrm xmlns:a="http://schemas.openxmlformats.org/drawingml/2006/main">
+            <a:off x="1181100" y="3371850"/>
+            <a:ext cx="4667250" cy="342900"/>
+          </a:xfrm>
+          <a:prstGeom xmlns:a="http://schemas.openxmlformats.org/drawingml/2006/main" prst="rect">
+            <a:avLst/>
+          </a:prstGeom>
+          <a:noFill xmlns:a="http://schemas.openxmlformats.org/drawingml/2006/main"/>
+          <a:ln xmlns:a="http://schemas.openxmlformats.org/drawingml/2006/main" w="0">
+            <a:noFill/>
+            <a:prstDash val="solid"/>
+          </a:ln>
+        </p:spPr>
+        <p:txBody>
+          <a:bodyPr xmlns:a="http://schemas.openxmlformats.org/drawingml/2006/main" lIns="0" tIns="0" rIns="0" bIns="0" anchor="t">
+            <a:normAutofit fontScale="100000"/>
+          </a:bodyPr>
+          <a:lstStyle xmlns:a="http://schemas.openxmlformats.org/drawingml/2006/main"/>
+          <a:p xmlns:a="http://schemas.openxmlformats.org/drawingml/2006/main">
+            <a:pPr algn="l">
+              <a:defRPr sz="1425" b="0">
+                <a:solidFill>
+                  <a:srgbClr val="FAFAFA"/>
+                </a:solidFill>
+                <a:latin typeface="Space Grotesk"/>
+                <a:ea typeface="Space Grotesk"/>
+                <a:cs typeface="Space Grotesk"/>
+              </a:defRPr>
+            </a:pPr>
+            <a:r>
+              <a:rPr sz="1425" b="0">
+                <a:solidFill>
+                  <a:srgbClr val="FAFAFA"/>
+                </a:solidFill>
+                <a:latin typeface="Space Grotesk"/>
+                <a:ea typeface="Space Grotesk"/>
+                <a:cs typeface="Space Grotesk"/>
+              </a:rPr>
+              <a:t>0.25 USDC x402 payment accepted</a:t>
+            </a:r>
+          </a:p>
+        </p:txBody>
+      </p:sp>
+      <p:sp>
+        <p:nvSpPr>
+          <p:cNvPr id="9" name="">
+            <a:extLst xmlns:a="http://schemas.openxmlformats.org/drawingml/2006/main">
+              <a:ext uri="{FF2B5EF4-FFF2-40B4-BE49-F238E27FC236}">
+                <a16:creationId xmlns:a16="http://schemas.microsoft.com/office/drawing/2014/main" id="{92C67E52-6078-4E29-ABFA-8E8FFE813CA9}"/>
+              </a:ext>
+            </a:extLst>
+          </p:cNvPr>
+          <p:cNvSpPr>
+            <a:spLocks xmlns:a="http://schemas.openxmlformats.org/drawingml/2006/main" noGrp="1"/>
+          </p:cNvSpPr>
+          <p:nvPr/>
+        </p:nvSpPr>
+        <p:spPr>
+          <a:xfrm xmlns:a="http://schemas.openxmlformats.org/drawingml/2006/main">
+            <a:off x="781050" y="4095750"/>
+            <a:ext cx="180975" cy="180975"/>
+          </a:xfrm>
+          <a:prstGeom xmlns:a="http://schemas.openxmlformats.org/drawingml/2006/main" prst="rect">
+            <a:avLst/>
+          </a:prstGeom>
+          <a:solidFill xmlns:a="http://schemas.openxmlformats.org/drawingml/2006/main">
+            <a:srgbClr val="FF337C"/>
+          </a:solidFill>
+          <a:ln xmlns:a="http://schemas.openxmlformats.org/drawingml/2006/main" w="0">
+            <a:noFill/>
+            <a:prstDash val="solid"/>
+          </a:ln>
+        </p:spPr>
+      </p:sp>
+      <p:sp>
+        <p:nvSpPr>
+          <p:cNvPr id="10" name="last-run-2">
+            <a:extLst xmlns:a="http://schemas.openxmlformats.org/drawingml/2006/main">
+              <a:ext uri="{FF2B5EF4-FFF2-40B4-BE49-F238E27FC236}">
+                <a16:creationId xmlns:a16="http://schemas.microsoft.com/office/drawing/2014/main" id="{A889D0A5-35D1-43F6-B5DC-3DA90DB08DBC}"/>
+              </a:ext>
+            </a:extLst>
+          </p:cNvPr>
+          <p:cNvSpPr>
+            <a:spLocks xmlns:a="http://schemas.openxmlformats.org/drawingml/2006/main" noGrp="1"/>
+          </p:cNvSpPr>
+          <p:nvPr/>
+        </p:nvSpPr>
+        <p:spPr>
+          <a:xfrm xmlns:a="http://schemas.openxmlformats.org/drawingml/2006/main">
+            <a:off x="1181100" y="4057650"/>
+            <a:ext cx="4667250" cy="342900"/>
+          </a:xfrm>
+          <a:prstGeom xmlns:a="http://schemas.openxmlformats.org/drawingml/2006/main" prst="rect">
+            <a:avLst/>
+          </a:prstGeom>
+          <a:noFill xmlns:a="http://schemas.openxmlformats.org/drawingml/2006/main"/>
+          <a:ln xmlns:a="http://schemas.openxmlformats.org/drawingml/2006/main" w="0">
+            <a:noFill/>
+            <a:prstDash val="solid"/>
+          </a:ln>
+        </p:spPr>
+        <p:txBody>
+          <a:bodyPr xmlns:a="http://schemas.openxmlformats.org/drawingml/2006/main" lIns="0" tIns="0" rIns="0" bIns="0" anchor="t">
+            <a:normAutofit fontScale="100000"/>
+          </a:bodyPr>
+          <a:lstStyle xmlns:a="http://schemas.openxmlformats.org/drawingml/2006/main"/>
+          <a:p xmlns:a="http://schemas.openxmlformats.org/drawingml/2006/main">
+            <a:pPr algn="l">
+              <a:defRPr sz="1425" b="0">
+                <a:solidFill>
+                  <a:srgbClr val="B0B0AB"/>
+                </a:solidFill>
+                <a:latin typeface="Space Grotesk"/>
+                <a:ea typeface="Space Grotesk"/>
+                <a:cs typeface="Space Grotesk"/>
+              </a:defRPr>
+            </a:pPr>
+            <a:r>
+              <a:rPr sz="1425" b="0">
+                <a:solidFill>
+                  <a:srgbClr val="B0B0AB"/>
+                </a:solidFill>
+                <a:latin typeface="Space Grotesk"/>
+                <a:ea typeface="Space Grotesk"/>
+                <a:cs typeface="Space Grotesk"/>
+              </a:rPr>
+              <a:t>Telegram review expired before a verdict</a:t>
+            </a:r>
+          </a:p>
+        </p:txBody>
+      </p:sp>
+      <p:sp>
+        <p:nvSpPr>
+          <p:cNvPr id="11" name="">
+            <a:extLst xmlns:a="http://schemas.openxmlformats.org/drawingml/2006/main">
+              <a:ext uri="{FF2B5EF4-FFF2-40B4-BE49-F238E27FC236}">
+                <a16:creationId xmlns:a16="http://schemas.microsoft.com/office/drawing/2014/main" id="{13EF57ED-78BF-410F-91A8-66EC808C19A3}"/>
+              </a:ext>
+            </a:extLst>
+          </p:cNvPr>
+          <p:cNvSpPr>
+            <a:spLocks xmlns:a="http://schemas.openxmlformats.org/drawingml/2006/main" noGrp="1"/>
+          </p:cNvSpPr>
+          <p:nvPr/>
+        </p:nvSpPr>
+        <p:spPr>
+          <a:xfrm xmlns:a="http://schemas.openxmlformats.org/drawingml/2006/main">
+            <a:off x="6286500" y="2019300"/>
+            <a:ext cx="9525" cy="3238500"/>
+          </a:xfrm>
+          <a:prstGeom xmlns:a="http://schemas.openxmlformats.org/drawingml/2006/main" prst="rect">
+            <a:avLst/>
+          </a:prstGeom>
+          <a:solidFill xmlns:a="http://schemas.openxmlformats.org/drawingml/2006/main">
+            <a:srgbClr val="2B2B2B"/>
+          </a:solidFill>
+          <a:ln xmlns:a="http://schemas.openxmlformats.org/drawingml/2006/main" w="0">
+            <a:noFill/>
+            <a:prstDash val="solid"/>
+          </a:ln>
+        </p:spPr>
+      </p:sp>
+      <p:sp>
+        <p:nvSpPr>
+          <p:cNvPr id="12" name="next-run-title">
+            <a:extLst xmlns:a="http://schemas.openxmlformats.org/drawingml/2006/main">
+              <a:ext uri="{FF2B5EF4-FFF2-40B4-BE49-F238E27FC236}">
+                <a16:creationId xmlns:a16="http://schemas.microsoft.com/office/drawing/2014/main" id="{EA75CA4D-BE2F-4C3A-9EB2-8D99EE395C7C}"/>
+              </a:ext>
+            </a:extLst>
+          </p:cNvPr>
+          <p:cNvSpPr>
+            <a:spLocks xmlns:a="http://schemas.openxmlformats.org/drawingml/2006/main" noGrp="1"/>
+          </p:cNvSpPr>
+          <p:nvPr/>
+        </p:nvSpPr>
+        <p:spPr>
+          <a:xfrm xmlns:a="http://schemas.openxmlformats.org/drawingml/2006/main">
+            <a:off x="6762750" y="2114550"/>
+            <a:ext cx="2857500" cy="323850"/>
+          </a:xfrm>
+          <a:prstGeom xmlns:a="http://schemas.openxmlformats.org/drawingml/2006/main" prst="rect">
+            <a:avLst/>
+          </a:prstGeom>
+          <a:noFill xmlns:a="http://schemas.openxmlformats.org/drawingml/2006/main"/>
+          <a:ln xmlns:a="http://schemas.openxmlformats.org/drawingml/2006/main" w="0">
+            <a:noFill/>
+            <a:prstDash val="solid"/>
+          </a:ln>
+        </p:spPr>
+        <p:txBody>
+          <a:bodyPr xmlns:a="http://schemas.openxmlformats.org/drawingml/2006/main" lIns="0" tIns="0" rIns="0" bIns="0" anchor="t">
+            <a:normAutofit fontScale="100000"/>
+          </a:bodyPr>
+          <a:lstStyle xmlns:a="http://schemas.openxmlformats.org/drawingml/2006/main"/>
+          <a:p xmlns:a="http://schemas.openxmlformats.org/drawingml/2006/main">
+            <a:pPr algn="l">
+              <a:defRPr sz="1725" b="0">
+                <a:solidFill>
+                  <a:srgbClr val="FAFAFA"/>
+                </a:solidFill>
+                <a:latin typeface="Space Grotesk"/>
+                <a:ea typeface="Space Grotesk"/>
+                <a:cs typeface="Space Grotesk"/>
+              </a:defRPr>
+            </a:pPr>
+            <a:r>
+              <a:rPr sz="1725" b="0">
+                <a:solidFill>
+                  <a:srgbClr val="FAFAFA"/>
+                </a:solidFill>
+                <a:latin typeface="Space Grotesk"/>
+                <a:ea typeface="Space Grotesk"/>
+                <a:cs typeface="Space Grotesk"/>
+              </a:rPr>
+              <a:t>Next run</a:t>
+            </a:r>
+          </a:p>
+        </p:txBody>
+      </p:sp>
+      <p:sp>
+        <p:nvSpPr>
+          <p:cNvPr id="13" name="next-run-number-0">
+            <a:extLst xmlns:a="http://schemas.openxmlformats.org/drawingml/2006/main">
+              <a:ext uri="{FF2B5EF4-FFF2-40B4-BE49-F238E27FC236}">
+                <a16:creationId xmlns:a16="http://schemas.microsoft.com/office/drawing/2014/main" id="{847CD9EF-80EC-4031-9E2E-AB3C541126FB}"/>
+              </a:ext>
+            </a:extLst>
+          </p:cNvPr>
+          <p:cNvSpPr>
+            <a:spLocks xmlns:a="http://schemas.openxmlformats.org/drawingml/2006/main" noGrp="1"/>
+          </p:cNvSpPr>
+          <p:nvPr/>
+        </p:nvSpPr>
+        <p:spPr>
+          <a:xfrm xmlns:a="http://schemas.openxmlformats.org/drawingml/2006/main">
+            <a:off x="6762750" y="2762250"/>
+            <a:ext cx="323850" cy="247650"/>
+          </a:xfrm>
+          <a:prstGeom xmlns:a="http://schemas.openxmlformats.org/drawingml/2006/main" prst="rect">
+            <a:avLst/>
+          </a:prstGeom>
+          <a:noFill xmlns:a="http://schemas.openxmlformats.org/drawingml/2006/main"/>
+          <a:ln xmlns:a="http://schemas.openxmlformats.org/drawingml/2006/main" w="0">
+            <a:noFill/>
+            <a:prstDash val="solid"/>
+          </a:ln>
+        </p:spPr>
+        <p:txBody>
+          <a:bodyPr xmlns:a="http://schemas.openxmlformats.org/drawingml/2006/main" lIns="0" tIns="0" rIns="0" bIns="0" anchor="t">
+            <a:normAutofit fontScale="100000"/>
+          </a:bodyPr>
+          <a:lstStyle xmlns:a="http://schemas.openxmlformats.org/drawingml/2006/main"/>
+          <a:p xmlns:a="http://schemas.openxmlformats.org/drawingml/2006/main">
+            <a:pPr algn="l">
+              <a:defRPr sz="1125" b="0">
+                <a:solidFill>
+                  <a:srgbClr val="FF7300"/>
+                </a:solidFill>
+                <a:latin typeface="IBM Plex Mono"/>
+                <a:ea typeface="IBM Plex Mono"/>
+                <a:cs typeface="IBM Plex Mono"/>
+              </a:defRPr>
+            </a:pPr>
+            <a:r>
               <a:rPr sz="1125" b="0">
                 <a:solidFill>
                   <a:srgbClr val="FF7300"/>
@@ -6884,10 +6137,10 @@
       </p:sp>
       <p:sp>
         <p:nvSpPr>
-          <p:cNvPr id="16" name="next-run-0">
-            <a:extLst xmlns:a="http://schemas.openxmlformats.org/drawingml/2006/main">
-              <a:ext uri="{FF2B5EF4-FFF2-40B4-BE49-F238E27FC236}">
-                <a16:creationId xmlns:a16="http://schemas.microsoft.com/office/drawing/2014/main" id="{A4300987-0E16-4ADF-842F-D7F1529E4F31}"/>
+          <p:cNvPr id="14" name="next-run-0">
+            <a:extLst xmlns:a="http://schemas.openxmlformats.org/drawingml/2006/main">
+              <a:ext uri="{FF2B5EF4-FFF2-40B4-BE49-F238E27FC236}">
+                <a16:creationId xmlns:a16="http://schemas.microsoft.com/office/drawing/2014/main" id="{C614D4A3-23A2-4A41-85C3-BADEDD11D17A}"/>
               </a:ext>
             </a:extLst>
           </p:cNvPr>
@@ -6935,17 +6188,17 @@
                 <a:ea typeface="Space Grotesk"/>
                 <a:cs typeface="Space Grotesk"/>
               </a:rPr>
-              <a:t>Submit a reasoned verdict in Telegram</a:t>
-            </a:r>
-          </a:p>
-        </p:txBody>
-      </p:sp>
-      <p:sp>
-        <p:nvSpPr>
-          <p:cNvPr id="17" name="">
-            <a:extLst xmlns:a="http://schemas.openxmlformats.org/drawingml/2006/main">
-              <a:ext uri="{FF2B5EF4-FFF2-40B4-BE49-F238E27FC236}">
-                <a16:creationId xmlns:a16="http://schemas.microsoft.com/office/drawing/2014/main" id="{9A8DA3CA-1F39-4E91-A629-B52BE4D0F569}"/>
+              <a:t>Reply with a reason in Telegram</a:t>
+            </a:r>
+          </a:p>
+        </p:txBody>
+      </p:sp>
+      <p:sp>
+        <p:nvSpPr>
+          <p:cNvPr id="15" name="">
+            <a:extLst xmlns:a="http://schemas.openxmlformats.org/drawingml/2006/main">
+              <a:ext uri="{FF2B5EF4-FFF2-40B4-BE49-F238E27FC236}">
+                <a16:creationId xmlns:a16="http://schemas.microsoft.com/office/drawing/2014/main" id="{C0124895-B9C7-4DE0-9A6D-A5D207FF7B28}"/>
               </a:ext>
             </a:extLst>
           </p:cNvPr>
@@ -6973,10 +6226,10 @@
       </p:sp>
       <p:sp>
         <p:nvSpPr>
-          <p:cNvPr id="18" name="next-run-number-1">
-            <a:extLst xmlns:a="http://schemas.openxmlformats.org/drawingml/2006/main">
-              <a:ext uri="{FF2B5EF4-FFF2-40B4-BE49-F238E27FC236}">
-                <a16:creationId xmlns:a16="http://schemas.microsoft.com/office/drawing/2014/main" id="{0E3A169E-8106-475E-A3BC-40EEF136B578}"/>
+          <p:cNvPr id="16" name="next-run-number-1">
+            <a:extLst xmlns:a="http://schemas.openxmlformats.org/drawingml/2006/main">
+              <a:ext uri="{FF2B5EF4-FFF2-40B4-BE49-F238E27FC236}">
+                <a16:creationId xmlns:a16="http://schemas.microsoft.com/office/drawing/2014/main" id="{D60A7B3C-9117-4CD4-B006-C09423397856}"/>
               </a:ext>
             </a:extLst>
           </p:cNvPr>
@@ -7031,10 +6284,10 @@
       </p:sp>
       <p:sp>
         <p:nvSpPr>
-          <p:cNvPr id="19" name="next-run-1">
-            <a:extLst xmlns:a="http://schemas.openxmlformats.org/drawingml/2006/main">
-              <a:ext uri="{FF2B5EF4-FFF2-40B4-BE49-F238E27FC236}">
-                <a16:creationId xmlns:a16="http://schemas.microsoft.com/office/drawing/2014/main" id="{D3410E96-E0CD-4725-AAE5-443279D38F3B}"/>
+          <p:cNvPr id="17" name="next-run-1">
+            <a:extLst xmlns:a="http://schemas.openxmlformats.org/drawingml/2006/main">
+              <a:ext uri="{FF2B5EF4-FFF2-40B4-BE49-F238E27FC236}">
+                <a16:creationId xmlns:a16="http://schemas.microsoft.com/office/drawing/2014/main" id="{B32D45EE-DD3D-4574-9E8D-914FB3F75FD6}"/>
               </a:ext>
             </a:extLst>
           </p:cNvPr>
@@ -7082,17 +6335,17 @@
                 <a:ea typeface="Space Grotesk"/>
                 <a:cs typeface="Space Grotesk"/>
               </a:rPr>
-              <a:t>Confirm the 0.20 USDC auditor payout</a:t>
-            </a:r>
-          </a:p>
-        </p:txBody>
-      </p:sp>
-      <p:sp>
-        <p:nvSpPr>
-          <p:cNvPr id="20" name="">
-            <a:extLst xmlns:a="http://schemas.openxmlformats.org/drawingml/2006/main">
-              <a:ext uri="{FF2B5EF4-FFF2-40B4-BE49-F238E27FC236}">
-                <a16:creationId xmlns:a16="http://schemas.microsoft.com/office/drawing/2014/main" id="{BC745942-C9C3-4066-A327-E245742E070B}"/>
+              <a:t>Confirm the 0.20 USDC payout</a:t>
+            </a:r>
+          </a:p>
+        </p:txBody>
+      </p:sp>
+      <p:sp>
+        <p:nvSpPr>
+          <p:cNvPr id="18" name="">
+            <a:extLst xmlns:a="http://schemas.openxmlformats.org/drawingml/2006/main">
+              <a:ext uri="{FF2B5EF4-FFF2-40B4-BE49-F238E27FC236}">
+                <a16:creationId xmlns:a16="http://schemas.microsoft.com/office/drawing/2014/main" id="{5E8493B8-CE8F-4DB6-A042-BD30AC151AAC}"/>
               </a:ext>
             </a:extLst>
           </p:cNvPr>
@@ -7120,10 +6373,10 @@
       </p:sp>
       <p:sp>
         <p:nvSpPr>
-          <p:cNvPr id="21" name="next-run-number-2">
-            <a:extLst xmlns:a="http://schemas.openxmlformats.org/drawingml/2006/main">
-              <a:ext uri="{FF2B5EF4-FFF2-40B4-BE49-F238E27FC236}">
-                <a16:creationId xmlns:a16="http://schemas.microsoft.com/office/drawing/2014/main" id="{E0F1B33A-A110-4FDF-A00C-051A09571A35}"/>
+          <p:cNvPr id="19" name="next-run-number-2">
+            <a:extLst xmlns:a="http://schemas.openxmlformats.org/drawingml/2006/main">
+              <a:ext uri="{FF2B5EF4-FFF2-40B4-BE49-F238E27FC236}">
+                <a16:creationId xmlns:a16="http://schemas.microsoft.com/office/drawing/2014/main" id="{56D3A5CE-565E-4E4C-B743-D6E717E6F427}"/>
               </a:ext>
             </a:extLst>
           </p:cNvPr>
@@ -7178,10 +6431,10 @@
       </p:sp>
       <p:sp>
         <p:nvSpPr>
-          <p:cNvPr id="22" name="next-run-2">
-            <a:extLst xmlns:a="http://schemas.openxmlformats.org/drawingml/2006/main">
-              <a:ext uri="{FF2B5EF4-FFF2-40B4-BE49-F238E27FC236}">
-                <a16:creationId xmlns:a16="http://schemas.microsoft.com/office/drawing/2014/main" id="{64BCAB63-8F0F-47D1-886B-8DF57F6F42EE}"/>
+          <p:cNvPr id="20" name="next-run-2">
+            <a:extLst xmlns:a="http://schemas.openxmlformats.org/drawingml/2006/main">
+              <a:ext uri="{FF2B5EF4-FFF2-40B4-BE49-F238E27FC236}">
+                <a16:creationId xmlns:a16="http://schemas.microsoft.com/office/drawing/2014/main" id="{C641E83F-1256-4A89-A310-FA8E4B7FF58E}"/>
               </a:ext>
             </a:extLst>
           </p:cNvPr>
@@ -7229,17 +6482,17 @@
                 <a:ea typeface="Space Grotesk"/>
                 <a:cs typeface="Space Grotesk"/>
               </a:rPr>
-              <a:t>Confirm humanResolve and the escrow result</a:t>
-            </a:r>
-          </a:p>
-        </p:txBody>
-      </p:sp>
-      <p:sp>
-        <p:nvSpPr>
-          <p:cNvPr id="23" name="">
-            <a:extLst xmlns:a="http://schemas.openxmlformats.org/drawingml/2006/main">
-              <a:ext uri="{FF2B5EF4-FFF2-40B4-BE49-F238E27FC236}">
-                <a16:creationId xmlns:a16="http://schemas.microsoft.com/office/drawing/2014/main" id="{6B2E260B-6C6E-4F0C-8AA0-20DE57E26CEA}"/>
+              <a:t>Confirm the escrow result on Arc</a:t>
+            </a:r>
+          </a:p>
+        </p:txBody>
+      </p:sp>
+      <p:sp>
+        <p:nvSpPr>
+          <p:cNvPr id="21" name="">
+            <a:extLst xmlns:a="http://schemas.openxmlformats.org/drawingml/2006/main">
+              <a:ext uri="{FF2B5EF4-FFF2-40B4-BE49-F238E27FC236}">
+                <a16:creationId xmlns:a16="http://schemas.microsoft.com/office/drawing/2014/main" id="{ABBE1EA2-0E1D-4BFA-BCDD-FE22C7573AC6}"/>
               </a:ext>
             </a:extLst>
           </p:cNvPr>
@@ -7267,10 +6520,10 @@
       </p:sp>
       <p:sp>
         <p:nvSpPr>
-          <p:cNvPr id="24" name="next-run-number-3">
-            <a:extLst xmlns:a="http://schemas.openxmlformats.org/drawingml/2006/main">
-              <a:ext uri="{FF2B5EF4-FFF2-40B4-BE49-F238E27FC236}">
-                <a16:creationId xmlns:a16="http://schemas.microsoft.com/office/drawing/2014/main" id="{B8116F0A-6CF6-41F2-A36F-517A218DCFD3}"/>
+          <p:cNvPr id="22" name="next-run-number-3">
+            <a:extLst xmlns:a="http://schemas.openxmlformats.org/drawingml/2006/main">
+              <a:ext uri="{FF2B5EF4-FFF2-40B4-BE49-F238E27FC236}">
+                <a16:creationId xmlns:a16="http://schemas.microsoft.com/office/drawing/2014/main" id="{03848EC7-149C-41CE-8A3A-8BECCB60C2F6}"/>
               </a:ext>
             </a:extLst>
           </p:cNvPr>
@@ -7325,10 +6578,10 @@
       </p:sp>
       <p:sp>
         <p:nvSpPr>
-          <p:cNvPr id="25" name="next-run-3">
-            <a:extLst xmlns:a="http://schemas.openxmlformats.org/drawingml/2006/main">
-              <a:ext uri="{FF2B5EF4-FFF2-40B4-BE49-F238E27FC236}">
-                <a16:creationId xmlns:a16="http://schemas.microsoft.com/office/drawing/2014/main" id="{F109A05C-3A07-4B87-8FFE-84696AC6AEC5}"/>
+          <p:cNvPr id="23" name="next-run-3">
+            <a:extLst xmlns:a="http://schemas.openxmlformats.org/drawingml/2006/main">
+              <a:ext uri="{FF2B5EF4-FFF2-40B4-BE49-F238E27FC236}">
+                <a16:creationId xmlns:a16="http://schemas.microsoft.com/office/drawing/2014/main" id="{77677249-1DB9-4343-813F-B24C2648C9BF}"/>
               </a:ext>
             </a:extLst>
           </p:cNvPr>
@@ -7376,17 +6629,17 @@
                 <a:ea typeface="Space Grotesk"/>
                 <a:cs typeface="Space Grotesk"/>
               </a:rPr>
-              <a:t>Publish the read-only run record</a:t>
-            </a:r>
-          </a:p>
-        </p:txBody>
-      </p:sp>
-      <p:sp>
-        <p:nvSpPr>
-          <p:cNvPr id="26" name="">
-            <a:extLst xmlns:a="http://schemas.openxmlformats.org/drawingml/2006/main">
-              <a:ext uri="{FF2B5EF4-FFF2-40B4-BE49-F238E27FC236}">
-                <a16:creationId xmlns:a16="http://schemas.microsoft.com/office/drawing/2014/main" id="{6800A3C2-5B3D-407A-8A14-BCAFB06EB8F5}"/>
+              <a:t>Open the public run record</a:t>
+            </a:r>
+          </a:p>
+        </p:txBody>
+      </p:sp>
+      <p:sp>
+        <p:nvSpPr>
+          <p:cNvPr id="24" name="">
+            <a:extLst xmlns:a="http://schemas.openxmlformats.org/drawingml/2006/main">
+              <a:ext uri="{FF2B5EF4-FFF2-40B4-BE49-F238E27FC236}">
+                <a16:creationId xmlns:a16="http://schemas.microsoft.com/office/drawing/2014/main" id="{048D4AEF-0471-4EA9-8D4A-B71CC7483599}"/>
               </a:ext>
             </a:extLst>
           </p:cNvPr>
@@ -7414,10 +6667,10 @@
       </p:sp>
       <p:sp>
         <p:nvSpPr>
-          <p:cNvPr id="27" name="repo-url">
-            <a:extLst xmlns:a="http://schemas.openxmlformats.org/drawingml/2006/main">
-              <a:ext uri="{FF2B5EF4-FFF2-40B4-BE49-F238E27FC236}">
-                <a16:creationId xmlns:a16="http://schemas.microsoft.com/office/drawing/2014/main" id="{C0B70303-91C1-4793-8863-EB9A0FD4219A}"/>
+          <p:cNvPr id="25" name="repo-url">
+            <a:extLst xmlns:a="http://schemas.openxmlformats.org/drawingml/2006/main">
+              <a:ext uri="{FF2B5EF4-FFF2-40B4-BE49-F238E27FC236}">
+                <a16:creationId xmlns:a16="http://schemas.microsoft.com/office/drawing/2014/main" id="{55CA6655-C031-4BEB-B773-A3943C29FBD6}"/>
               </a:ext>
             </a:extLst>
           </p:cNvPr>
@@ -7472,10 +6725,10 @@
       </p:sp>
       <p:sp>
         <p:nvSpPr>
-          <p:cNvPr id="28" name="app-url">
-            <a:extLst xmlns:a="http://schemas.openxmlformats.org/drawingml/2006/main">
-              <a:ext uri="{FF2B5EF4-FFF2-40B4-BE49-F238E27FC236}">
-                <a16:creationId xmlns:a16="http://schemas.microsoft.com/office/drawing/2014/main" id="{031ECF96-A9F8-40E4-8D46-86E89B0F3CED}"/>
+          <p:cNvPr id="26" name="app-url">
+            <a:extLst xmlns:a="http://schemas.openxmlformats.org/drawingml/2006/main">
+              <a:ext uri="{FF2B5EF4-FFF2-40B4-BE49-F238E27FC236}">
+                <a16:creationId xmlns:a16="http://schemas.microsoft.com/office/drawing/2014/main" id="{7309031C-2071-467D-90A0-36AC28D615A0}"/>
               </a:ext>
             </a:extLst>
           </p:cNvPr>
@@ -7528,157 +6781,10 @@
           </a:p>
         </p:txBody>
       </p:sp>
-      <p:sp>
-        <p:nvSpPr>
-          <p:cNvPr id="29" name="">
-            <a:extLst xmlns:a="http://schemas.openxmlformats.org/drawingml/2006/main">
-              <a:ext uri="{FF2B5EF4-FFF2-40B4-BE49-F238E27FC236}">
-                <a16:creationId xmlns:a16="http://schemas.microsoft.com/office/drawing/2014/main" id="{D03013C0-EC1C-44DB-943C-048E9BD54C41}"/>
-              </a:ext>
-            </a:extLst>
-          </p:cNvPr>
-          <p:cNvSpPr>
-            <a:spLocks xmlns:a="http://schemas.openxmlformats.org/drawingml/2006/main" noGrp="1"/>
-          </p:cNvSpPr>
-          <p:nvPr/>
-        </p:nvSpPr>
-        <p:spPr>
-          <a:xfrm xmlns:a="http://schemas.openxmlformats.org/drawingml/2006/main">
-            <a:off x="685800" y="6334125"/>
-            <a:ext cx="10820400" cy="9525"/>
-          </a:xfrm>
-          <a:prstGeom xmlns:a="http://schemas.openxmlformats.org/drawingml/2006/main" prst="rect">
-            <a:avLst/>
-          </a:prstGeom>
-          <a:solidFill xmlns:a="http://schemas.openxmlformats.org/drawingml/2006/main">
-            <a:srgbClr val="2B2B2B"/>
-          </a:solidFill>
-          <a:ln xmlns:a="http://schemas.openxmlformats.org/drawingml/2006/main" w="0">
-            <a:noFill/>
-            <a:prstDash val="solid"/>
-          </a:ln>
-        </p:spPr>
-      </p:sp>
-      <p:sp>
-        <p:nvSpPr>
-          <p:cNvPr id="30" name="footer-left">
-            <a:extLst xmlns:a="http://schemas.openxmlformats.org/drawingml/2006/main">
-              <a:ext uri="{FF2B5EF4-FFF2-40B4-BE49-F238E27FC236}">
-                <a16:creationId xmlns:a16="http://schemas.microsoft.com/office/drawing/2014/main" id="{8F8DB10F-6A0C-4840-9CE9-3709E8C16104}"/>
-              </a:ext>
-            </a:extLst>
-          </p:cNvPr>
-          <p:cNvSpPr>
-            <a:spLocks xmlns:a="http://schemas.openxmlformats.org/drawingml/2006/main" noGrp="1"/>
-          </p:cNvSpPr>
-          <p:nvPr/>
-        </p:nvSpPr>
-        <p:spPr>
-          <a:xfrm xmlns:a="http://schemas.openxmlformats.org/drawingml/2006/main">
-            <a:off x="685800" y="6467475"/>
-            <a:ext cx="4381500" cy="190500"/>
-          </a:xfrm>
-          <a:prstGeom xmlns:a="http://schemas.openxmlformats.org/drawingml/2006/main" prst="rect">
-            <a:avLst/>
-          </a:prstGeom>
-          <a:noFill xmlns:a="http://schemas.openxmlformats.org/drawingml/2006/main"/>
-          <a:ln xmlns:a="http://schemas.openxmlformats.org/drawingml/2006/main" w="0">
-            <a:noFill/>
-            <a:prstDash val="solid"/>
-          </a:ln>
-        </p:spPr>
-        <p:txBody>
-          <a:bodyPr xmlns:a="http://schemas.openxmlformats.org/drawingml/2006/main" lIns="0" tIns="0" rIns="0" bIns="0" anchor="t">
-            <a:normAutofit fontScale="100000"/>
-          </a:bodyPr>
-          <a:lstStyle xmlns:a="http://schemas.openxmlformats.org/drawingml/2006/main"/>
-          <a:p xmlns:a="http://schemas.openxmlformats.org/drawingml/2006/main">
-            <a:pPr algn="l">
-              <a:defRPr sz="900" b="0">
-                <a:solidFill>
-                  <a:srgbClr val="94948E"/>
-                </a:solidFill>
-                <a:latin typeface="Space Grotesk"/>
-                <a:ea typeface="Space Grotesk"/>
-                <a:cs typeface="Space Grotesk"/>
-              </a:defRPr>
-            </a:pPr>
-            <a:r>
-              <a:rPr sz="900" b="0">
-                <a:solidFill>
-                  <a:srgbClr val="94948E"/>
-                </a:solidFill>
-                <a:latin typeface="Space Grotesk"/>
-                <a:ea typeface="Space Grotesk"/>
-                <a:cs typeface="Space Grotesk"/>
-              </a:rPr>
-              <a:t>Checkpoint status · 2 Aug 2026</a:t>
-            </a:r>
-          </a:p>
-        </p:txBody>
-      </p:sp>
-      <p:sp>
-        <p:nvSpPr>
-          <p:cNvPr id="31" name="footer-right">
-            <a:extLst xmlns:a="http://schemas.openxmlformats.org/drawingml/2006/main">
-              <a:ext uri="{FF2B5EF4-FFF2-40B4-BE49-F238E27FC236}">
-                <a16:creationId xmlns:a16="http://schemas.microsoft.com/office/drawing/2014/main" id="{277DF451-70BF-4954-BA0E-471D115C2E52}"/>
-              </a:ext>
-            </a:extLst>
-          </p:cNvPr>
-          <p:cNvSpPr>
-            <a:spLocks xmlns:a="http://schemas.openxmlformats.org/drawingml/2006/main" noGrp="1"/>
-          </p:cNvSpPr>
-          <p:nvPr/>
-        </p:nvSpPr>
-        <p:spPr>
-          <a:xfrm xmlns:a="http://schemas.openxmlformats.org/drawingml/2006/main">
-            <a:off x="9220200" y="6467475"/>
-            <a:ext cx="2286000" cy="190500"/>
-          </a:xfrm>
-          <a:prstGeom xmlns:a="http://schemas.openxmlformats.org/drawingml/2006/main" prst="rect">
-            <a:avLst/>
-          </a:prstGeom>
-          <a:noFill xmlns:a="http://schemas.openxmlformats.org/drawingml/2006/main"/>
-          <a:ln xmlns:a="http://schemas.openxmlformats.org/drawingml/2006/main" w="0">
-            <a:noFill/>
-            <a:prstDash val="solid"/>
-          </a:ln>
-        </p:spPr>
-        <p:txBody>
-          <a:bodyPr xmlns:a="http://schemas.openxmlformats.org/drawingml/2006/main" lIns="0" tIns="0" rIns="0" bIns="0" anchor="t">
-            <a:normAutofit fontScale="100000"/>
-          </a:bodyPr>
-          <a:lstStyle xmlns:a="http://schemas.openxmlformats.org/drawingml/2006/main"/>
-          <a:p xmlns:a="http://schemas.openxmlformats.org/drawingml/2006/main">
-            <a:pPr algn="r">
-              <a:defRPr sz="900" b="0">
-                <a:solidFill>
-                  <a:srgbClr val="94948E"/>
-                </a:solidFill>
-                <a:latin typeface="Space Grotesk"/>
-                <a:ea typeface="Space Grotesk"/>
-                <a:cs typeface="Space Grotesk"/>
-              </a:defRPr>
-            </a:pPr>
-            <a:r>
-              <a:rPr sz="900" b="0">
-                <a:solidFill>
-                  <a:srgbClr val="94948E"/>
-                </a:solidFill>
-                <a:latin typeface="Space Grotesk"/>
-                <a:ea typeface="Space Grotesk"/>
-                <a:cs typeface="Space Grotesk"/>
-              </a:rPr>
-              <a:t>Agentic Economy</a:t>
-            </a:r>
-          </a:p>
-        </p:txBody>
-      </p:sp>
     </p:spTree>
     <p:extLst>
       <p:ext uri="{BB962C8B-B14F-4D97-AF65-F5344CB8AC3E}">
-        <p14:creationId xmlns:p14="http://schemas.microsoft.com/office/powerpoint/2010/main" val="1354111209"/>
+        <p14:creationId xmlns:p14="http://schemas.microsoft.com/office/powerpoint/2010/main" val="582555888"/>
       </p:ext>
     </p:extLst>
   </p:cSld>

</xml_diff>